<commit_message>
Turn guidance into a customer demo journey
</commit_message>
<xml_diff>
--- a/presentation/eventhouse-schema-drift-reference.pptx
+++ b/presentation/eventhouse-schema-drift-reference.pptx
@@ -3181,7 +3181,7 @@
               </a:defRPr>
             </a:pPr>
             <a:r>
-              <a:t>Schema drift without bulk export</a:t>
+              <a:t>Move schema drift from Spark to Eventhouse</a:t>
             </a:r>
           </a:p>
         </p:txBody>
@@ -3217,11 +3217,11 @@
               </a:defRPr>
             </a:pPr>
             <a:r>
-              <a:t>A reusable Microsoft Fabric Eventhouse reference</a:t>
+              <a:t>A step-by-step customer demo</a:t>
             </a:r>
             <a:br/>
             <a:r>
-              <a:t>Stable typed tables, residual JSON, and reviewed promotion</a:t>
+              <a:t>Prove stable schemas, preserved drift, and governed promotion</a:t>
             </a:r>
           </a:p>
         </p:txBody>
@@ -3319,7 +3319,7 @@
               </a:defRPr>
             </a:pPr>
             <a:r>
-              <a:t>OneLake role</a:t>
+              <a:t>Live proof: what the customer should see</a:t>
             </a:r>
           </a:p>
         </p:txBody>
@@ -3412,7 +3412,7 @@
         <p:spPr>
           <a:xfrm>
             <a:off x="868680" y="1417320"/>
-            <a:ext cx="6537960" cy="4526280"/>
+            <a:ext cx="6400800" cy="4526280"/>
           </a:xfrm>
           <a:prstGeom prst="rect">
             <a:avLst/>
@@ -3437,7 +3437,7 @@
               </a:defRPr>
             </a:pPr>
             <a:r>
-              <a:t>•  Mirror ordinary Eventhouse tables for other Fabric engines</a:t>
+              <a:t>•  Six raw messages route to three typed tables</a:t>
             </a:r>
           </a:p>
           <a:p>
@@ -3453,7 +3453,7 @@
               </a:defRPr>
             </a:pPr>
             <a:r>
-              <a:t>•  Use mirrored Delta as a transitional Spark quick win</a:t>
+              <a:t>•  A new controller field remains in residual JSON</a:t>
             </a:r>
           </a:p>
           <a:p>
@@ -3469,7 +3469,7 @@
               </a:defRPr>
             </a:pPr>
             <a:r>
-              <a:t>•  Validate adaptive batching latency</a:t>
+              <a:t>•  Drift review identifies new paths and observed types</a:t>
             </a:r>
           </a:p>
           <a:p>
@@ -3485,7 +3485,23 @@
               </a:defRPr>
             </a:pPr>
             <a:r>
-              <a:t>•  Adding columns is supported; renaming and type alteration are constrained</a:t>
+              <a:t>•  Two zones create two child rows; an empty array creates none</a:t>
+            </a:r>
+          </a:p>
+          <a:p>
+            <a:pPr>
+              <a:spcAft>
+                <a:spcPts val="1800"/>
+              </a:spcAft>
+              <a:defRPr sz="2200">
+                <a:solidFill>
+                  <a:srgbClr val="182530"/>
+                </a:solidFill>
+                <a:latin typeface="Aptos"/>
+              </a:defRPr>
+            </a:pPr>
+            <a:r>
+              <a:t>•  An incompatible value is still recoverable from RawRecord</a:t>
             </a:r>
           </a:p>
         </p:txBody>
@@ -3550,7 +3566,7 @@
             <a:avLst/>
           </a:prstGeom>
           <a:solidFill>
-            <a:srgbClr val="C42B1C"/>
+            <a:srgbClr val="008577"/>
           </a:solidFill>
           <a:ln>
             <a:noFill/>
@@ -3583,7 +3599,7 @@
               </a:defRPr>
             </a:pPr>
             <a:r>
-              <a:t>TEST</a:t>
+              <a:t>DRIFT SURVIVES</a:t>
             </a:r>
           </a:p>
         </p:txBody>
@@ -3645,7 +3661,7 @@
               </a:defRPr>
             </a:pPr>
             <a:r>
-              <a:t>Production gates</a:t>
+              <a:t>Governed promotion stays simple</a:t>
             </a:r>
           </a:p>
         </p:txBody>
@@ -3738,7 +3754,7 @@
         <p:spPr>
           <a:xfrm>
             <a:off x="868680" y="1417320"/>
-            <a:ext cx="6537960" cy="4526280"/>
+            <a:ext cx="6400800" cy="4526280"/>
           </a:xfrm>
           <a:prstGeom prst="rect">
             <a:avLst/>
@@ -3763,7 +3779,7 @@
               </a:defRPr>
             </a:pPr>
             <a:r>
-              <a:t>•  Peak-load CPU and ingestion latency</a:t>
+              <a:t>•  Add the approved column</a:t>
             </a:r>
           </a:p>
           <a:p>
@@ -3779,7 +3795,7 @@
               </a:defRPr>
             </a:pPr>
             <a:r>
-              <a:t>•  Target completeness and replay</a:t>
+              <a:t>•  Revise the stored function and residual key list</a:t>
             </a:r>
           </a:p>
           <a:p>
@@ -3795,7 +3811,7 @@
               </a:defRPr>
             </a:pPr>
             <a:r>
-              <a:t>•  Malformed and type-conflicted values</a:t>
+              <a:t>•  Compare function schema with the table</a:t>
             </a:r>
           </a:p>
           <a:p>
@@ -3811,7 +3827,7 @@
               </a:defRPr>
             </a:pPr>
             <a:r>
-              <a:t>•  Array amplification</a:t>
+              <a:t>•  Replay only the approved raw interval</a:t>
             </a:r>
           </a:p>
           <a:p>
@@ -3827,7 +3843,7 @@
               </a:defRPr>
             </a:pPr>
             <a:r>
-              <a:t>•  Duplicate arrival window and materialized-view lookback</a:t>
+              <a:t>•  Handle appended versions explicitly</a:t>
             </a:r>
           </a:p>
         </p:txBody>
@@ -3840,18 +3856,18 @@
         </p:nvSpPr>
         <p:spPr>
           <a:xfrm>
-            <a:off x="7818120" y="1371600"/>
-            <a:ext cx="3749039" cy="4526280"/>
+            <a:off x="7543800" y="1417320"/>
+            <a:ext cx="4069080" cy="4389120"/>
           </a:xfrm>
           <a:prstGeom prst="rect">
             <a:avLst/>
           </a:prstGeom>
           <a:solidFill>
-            <a:srgbClr val="EFF5F7"/>
+            <a:srgbClr val="182530"/>
           </a:solidFill>
           <a:ln>
             <a:solidFill>
-              <a:srgbClr val="D3E0E4"/>
+              <a:srgbClr val="384852"/>
             </a:solidFill>
           </a:ln>
         </p:spPr>
@@ -3870,62 +3886,33 @@
           </a:fontRef>
         </p:style>
         <p:txBody>
-          <a:bodyPr rtlCol="0" anchor="ctr"/>
-          <a:lstStyle/>
-          <a:p>
-            <a:pPr algn="ctr"/>
-          </a:p>
-        </p:txBody>
-      </p:sp>
-      <p:sp>
-        <p:nvSpPr>
-          <p:cNvPr id="7" name="Rounded Rectangle 6"/>
-          <p:cNvSpPr/>
-          <p:nvPr/>
-        </p:nvSpPr>
-        <p:spPr>
-          <a:xfrm>
-            <a:off x="8366760" y="2834640"/>
-            <a:ext cx="2651760" cy="1051560"/>
-          </a:xfrm>
-          <a:prstGeom prst="roundRect">
-            <a:avLst/>
-          </a:prstGeom>
-          <a:solidFill>
-            <a:srgbClr val="0078D4"/>
-          </a:solidFill>
-          <a:ln>
-            <a:noFill/>
-          </a:ln>
-        </p:spPr>
-        <p:style>
-          <a:lnRef idx="1">
-            <a:schemeClr val="accent1"/>
-          </a:lnRef>
-          <a:fillRef idx="3">
-            <a:schemeClr val="accent1"/>
-          </a:fillRef>
-          <a:effectRef idx="2">
-            <a:schemeClr val="accent1"/>
-          </a:effectRef>
-          <a:fontRef idx="minor">
-            <a:schemeClr val="lt1"/>
-          </a:fontRef>
-        </p:style>
-        <p:txBody>
-          <a:bodyPr rtlCol="0" anchor="ctr"/>
+          <a:bodyPr rtlCol="0" anchor="ctr" lIns="228600" rIns="182880" tIns="228600"/>
           <a:lstStyle/>
           <a:p>
             <a:pPr algn="ctr">
-              <a:defRPr sz="2000" b="1">
-                <a:solidFill>
-                  <a:srgbClr val="FFFFFF"/>
-                </a:solidFill>
-                <a:latin typeface="Aptos Display"/>
-              </a:defRPr>
-            </a:pPr>
-            <a:r>
-              <a:t>ADOPT</a:t>
+              <a:defRPr sz="1400">
+                <a:solidFill>
+                  <a:srgbClr val="DCEEF1"/>
+                </a:solidFill>
+                <a:latin typeface="Cascadia Mono"/>
+              </a:defRPr>
+            </a:pPr>
+            <a:r>
+              <a:t>.alter-merge table ControllerTelemetry</a:t>
+            </a:r>
+            <a:br/>
+            <a:r>
+              <a:t>  (ServiceCountdownHours:real)</a:t>
+            </a:r>
+            <a:br/>
+            <a:br/>
+            <a:r>
+              <a:t>TransformControllerTelemetry | getschema</a:t>
+            </a:r>
+            <a:br/>
+            <a:br/>
+            <a:r>
+              <a:t>.set-or-append ControllerTelemetry &lt;| ...</a:t>
             </a:r>
           </a:p>
         </p:txBody>
@@ -3987,7 +3974,7 @@
               </a:defRPr>
             </a:pPr>
             <a:r>
-              <a:t>Recommended next steps</a:t>
+              <a:t>Adopt with evidence, not promises</a:t>
             </a:r>
           </a:p>
         </p:txBody>
@@ -4080,7 +4067,7 @@
         <p:spPr>
           <a:xfrm>
             <a:off x="868680" y="1417320"/>
-            <a:ext cx="6537960" cy="4526280"/>
+            <a:ext cx="6400800" cy="4526280"/>
           </a:xfrm>
           <a:prstGeom prst="rect">
             <a:avLst/>
@@ -4105,7 +4092,7 @@
               </a:defRPr>
             </a:pPr>
             <a:r>
-              <a:t>•  Deploy the demo in a disposable KQL database</a:t>
+              <a:t>•  Shadow one source type first</a:t>
             </a:r>
           </a:p>
           <a:p>
@@ -4121,7 +4108,7 @@
               </a:defRPr>
             </a:pPr>
             <a:r>
-              <a:t>•  Replace demo contracts with production metadata</a:t>
+              <a:t>•  Benchmark policy CPU, ingestion latency, and array amplification</a:t>
             </a:r>
           </a:p>
           <a:p>
@@ -4137,7 +4124,7 @@
               </a:defRPr>
             </a:pPr>
             <a:r>
-              <a:t>•  Shadow one source type</a:t>
+              <a:t>•  Validate failure monitoring and bounded replay</a:t>
             </a:r>
           </a:p>
           <a:p>
@@ -4153,7 +4140,7 @@
               </a:defRPr>
             </a:pPr>
             <a:r>
-              <a:t>•  Benchmark at peak concurrency</a:t>
+              <a:t>•  Measure duplicate arrivals before choosing a lookback</a:t>
             </a:r>
           </a:p>
           <a:p>
@@ -4169,7 +4156,7 @@
               </a:defRPr>
             </a:pPr>
             <a:r>
-              <a:t>•  Cut over incrementally and retain raw replay coverage</a:t>
+              <a:t>•  Retire Spark bulk reads only after completeness gates pass</a:t>
             </a:r>
           </a:p>
         </p:txBody>
@@ -4267,7 +4254,7 @@
               </a:defRPr>
             </a:pPr>
             <a:r>
-              <a:t>EVENTHOUSE</a:t>
+              <a:t>SHADOW → BENCHMARK</a:t>
             </a:r>
           </a:p>
         </p:txBody>
@@ -4329,7 +4316,7 @@
               </a:defRPr>
             </a:pPr>
             <a:r>
-              <a:t>The customer problem</a:t>
+              <a:t>Start with today's Spark journey</a:t>
             </a:r>
           </a:p>
         </p:txBody>
@@ -4422,7 +4409,7 @@
         <p:spPr>
           <a:xfrm>
             <a:off x="868680" y="1417320"/>
-            <a:ext cx="6537960" cy="4526280"/>
+            <a:ext cx="6400800" cy="4526280"/>
           </a:xfrm>
           <a:prstGeom prst="rect">
             <a:avLst/>
@@ -4447,7 +4434,7 @@
               </a:defRPr>
             </a:pPr>
             <a:r>
-              <a:t>•  IoT payloads evolve independently of analytics schemas</a:t>
+              <a:t>•  Telemetry lands in Eventhouse</a:t>
             </a:r>
           </a:p>
           <a:p>
@@ -4463,7 +4450,7 @@
               </a:defRPr>
             </a:pPr>
             <a:r>
-              <a:t>•  Spark schema inference requires bulk reads from Eventhouse</a:t>
+              <a:t>•  A notebook exports the batch through the Kusto connector</a:t>
             </a:r>
           </a:p>
           <a:p>
@@ -4479,7 +4466,7 @@
               </a:defRPr>
             </a:pPr>
             <a:r>
-              <a:t>•  Concurrent connector reads can consume export capacity</a:t>
+              <a:t>•  Spark infers JSON, flattens, compares schemas, and manages buffers</a:t>
             </a:r>
           </a:p>
           <a:p>
@@ -4495,7 +4482,7 @@
               </a:defRPr>
             </a:pPr>
             <a:r>
-              <a:t>•  Drift approval pauses batches and creates operational buffers</a:t>
+              <a:t>•  Delta writes require watermarks and merge orchestration</a:t>
             </a:r>
           </a:p>
         </p:txBody>
@@ -4593,7 +4580,7 @@
               </a:defRPr>
             </a:pPr>
             <a:r>
-              <a:t>EXPORT</a:t>
+              <a:t>EXPORT → SPARK</a:t>
             </a:r>
           </a:p>
         </p:txBody>
@@ -4655,7 +4642,7 @@
               </a:defRPr>
             </a:pPr>
             <a:r>
-              <a:t>Current data path</a:t>
+              <a:t>Why the current loop is less efficient</a:t>
             </a:r>
           </a:p>
         </p:txBody>
@@ -4748,7 +4735,7 @@
         <p:spPr>
           <a:xfrm>
             <a:off x="868680" y="1417320"/>
-            <a:ext cx="6537960" cy="4526280"/>
+            <a:ext cx="6400800" cy="4526280"/>
           </a:xfrm>
           <a:prstGeom prst="rect">
             <a:avLst/>
@@ -4773,7 +4760,7 @@
               </a:defRPr>
             </a:pPr>
             <a:r>
-              <a:t>•  Event Hub to Eventhouse landing table</a:t>
+              <a:t>•  Routine processing moves data out of its serving engine</a:t>
             </a:r>
           </a:p>
           <a:p>
@@ -4789,7 +4776,7 @@
               </a:defRPr>
             </a:pPr>
             <a:r>
-              <a:t>•  Kusto Spark connector invokes the export path</a:t>
+              <a:t>•  Every run pays Spark startup and JSON inference cost</a:t>
             </a:r>
           </a:p>
           <a:p>
@@ -4805,7 +4792,7 @@
               </a:defRPr>
             </a:pPr>
             <a:r>
-              <a:t>•  Spark infers, flattens, compares, and buffers</a:t>
+              <a:t>•  Parallel bulk reads compete for export capacity</a:t>
             </a:r>
           </a:p>
           <a:p>
@@ -4821,7 +4808,7 @@
               </a:defRPr>
             </a:pPr>
             <a:r>
-              <a:t>•  Delta targets depend on watermarks and replay orchestration</a:t>
+              <a:t>•  Buffers, watermarks, and merge jobs increase operational state</a:t>
             </a:r>
           </a:p>
         </p:txBody>
@@ -4886,7 +4873,7 @@
             <a:avLst/>
           </a:prstGeom>
           <a:solidFill>
-            <a:srgbClr val="0078D4"/>
+            <a:srgbClr val="E67E22"/>
           </a:solidFill>
           <a:ln>
             <a:noFill/>
@@ -4919,7 +4906,7 @@
               </a:defRPr>
             </a:pPr>
             <a:r>
-              <a:t>FIXED</a:t>
+              <a:t>MOVE + INFER + MERGE</a:t>
             </a:r>
           </a:p>
         </p:txBody>
@@ -4981,7 +4968,7 @@
               </a:defRPr>
             </a:pPr>
             <a:r>
-              <a:t>Stable-schema principle</a:t>
+              <a:t>What the demo builds instead</a:t>
             </a:r>
           </a:p>
         </p:txBody>
@@ -5074,7 +5061,7 @@
         <p:spPr>
           <a:xfrm>
             <a:off x="868680" y="1417320"/>
-            <a:ext cx="6537960" cy="4526280"/>
+            <a:ext cx="6400800" cy="4526280"/>
           </a:xfrm>
           <a:prstGeom prst="rect">
             <a:avLst/>
@@ -5099,7 +5086,7 @@
               </a:defRPr>
             </a:pPr>
             <a:r>
-              <a:t>•  Project known fields explicitly</a:t>
+              <a:t>•  Raw ingestion remains the replay point</a:t>
             </a:r>
           </a:p>
           <a:p>
@@ -5115,7 +5102,7 @@
               </a:defRPr>
             </a:pPr>
             <a:r>
-              <a:t>•  Remove known keys from the telemetry bag</a:t>
+              <a:t>•  Update policies create stable typed tables</a:t>
             </a:r>
           </a:p>
           <a:p>
@@ -5131,7 +5118,7 @@
               </a:defRPr>
             </a:pPr>
             <a:r>
-              <a:t>•  Store the remainder as ResidualTelemetry</a:t>
+              <a:t>•  Unknown values remain in residual JSON</a:t>
             </a:r>
           </a:p>
           <a:p>
@@ -5147,105 +5134,83 @@
               </a:defRPr>
             </a:pPr>
             <a:r>
-              <a:t>•  A new key changes data, not the policy output schema</a:t>
-            </a:r>
-          </a:p>
-        </p:txBody>
-      </p:sp>
-      <p:sp>
-        <p:nvSpPr>
-          <p:cNvPr id="6" name="Rectangle 5"/>
-          <p:cNvSpPr/>
+              <a:t>•  A drift policy creates review evidence</a:t>
+            </a:r>
+          </a:p>
+          <a:p>
+            <a:pPr>
+              <a:spcAft>
+                <a:spcPts val="1800"/>
+              </a:spcAft>
+              <a:defRPr sz="2200">
+                <a:solidFill>
+                  <a:srgbClr val="182530"/>
+                </a:solidFill>
+                <a:latin typeface="Aptos"/>
+              </a:defRPr>
+            </a:pPr>
+            <a:r>
+              <a:t>•  Arrays become child rows</a:t>
+            </a:r>
+          </a:p>
+        </p:txBody>
+      </p:sp>
+      <p:pic>
+        <p:nvPicPr>
+          <p:cNvPr id="6" name="Picture 5" descr="target-architecture.png"/>
+          <p:cNvPicPr>
+            <a:picLocks noChangeAspect="1"/>
+          </p:cNvPicPr>
           <p:nvPr/>
-        </p:nvSpPr>
-        <p:spPr>
-          <a:xfrm>
-            <a:off x="7818120" y="1371600"/>
-            <a:ext cx="3749039" cy="4526280"/>
+        </p:nvPicPr>
+        <p:blipFill>
+          <a:blip r:embed="rId2"/>
+          <a:stretch>
+            <a:fillRect/>
+          </a:stretch>
+        </p:blipFill>
+        <p:spPr>
+          <a:xfrm>
+            <a:off x="7452360" y="1325880"/>
+            <a:ext cx="4251960" cy="3611880"/>
           </a:xfrm>
           <a:prstGeom prst="rect">
             <a:avLst/>
           </a:prstGeom>
-          <a:solidFill>
-            <a:srgbClr val="EFF5F7"/>
-          </a:solidFill>
-          <a:ln>
-            <a:solidFill>
-              <a:srgbClr val="D3E0E4"/>
-            </a:solidFill>
-          </a:ln>
-        </p:spPr>
-        <p:style>
-          <a:lnRef idx="1">
-            <a:schemeClr val="accent1"/>
-          </a:lnRef>
-          <a:fillRef idx="3">
-            <a:schemeClr val="accent1"/>
-          </a:fillRef>
-          <a:effectRef idx="2">
-            <a:schemeClr val="accent1"/>
-          </a:effectRef>
-          <a:fontRef idx="minor">
-            <a:schemeClr val="lt1"/>
-          </a:fontRef>
-        </p:style>
-        <p:txBody>
-          <a:bodyPr rtlCol="0" anchor="ctr"/>
-          <a:lstStyle/>
-          <a:p>
-            <a:pPr algn="ctr"/>
-          </a:p>
-        </p:txBody>
-      </p:sp>
-      <p:sp>
-        <p:nvSpPr>
-          <p:cNvPr id="7" name="Rounded Rectangle 6"/>
-          <p:cNvSpPr/>
+        </p:spPr>
+      </p:pic>
+      <p:sp>
+        <p:nvSpPr>
+          <p:cNvPr id="7" name="TextBox 6"/>
+          <p:cNvSpPr txBox="1"/>
           <p:nvPr/>
         </p:nvSpPr>
         <p:spPr>
           <a:xfrm>
-            <a:off x="8366760" y="2834640"/>
-            <a:ext cx="2651760" cy="1051560"/>
-          </a:xfrm>
-          <a:prstGeom prst="roundRect">
+            <a:off x="7543800" y="5166360"/>
+            <a:ext cx="3977639" cy="502920"/>
+          </a:xfrm>
+          <a:prstGeom prst="rect">
             <a:avLst/>
           </a:prstGeom>
-          <a:solidFill>
-            <a:srgbClr val="008577"/>
-          </a:solidFill>
-          <a:ln>
-            <a:noFill/>
-          </a:ln>
-        </p:spPr>
-        <p:style>
-          <a:lnRef idx="1">
-            <a:schemeClr val="accent1"/>
-          </a:lnRef>
-          <a:fillRef idx="3">
-            <a:schemeClr val="accent1"/>
-          </a:fillRef>
-          <a:effectRef idx="2">
-            <a:schemeClr val="accent1"/>
-          </a:effectRef>
-          <a:fontRef idx="minor">
-            <a:schemeClr val="lt1"/>
-          </a:fontRef>
-        </p:style>
-        <p:txBody>
-          <a:bodyPr rtlCol="0" anchor="ctr"/>
-          <a:lstStyle/>
-          <a:p>
-            <a:pPr algn="ctr">
-              <a:defRPr sz="2000" b="1">
-                <a:solidFill>
-                  <a:srgbClr val="FFFFFF"/>
-                </a:solidFill>
-                <a:latin typeface="Aptos Display"/>
-              </a:defRPr>
-            </a:pPr>
-            <a:r>
-              <a:t>NATIVE</a:t>
+          <a:noFill/>
+        </p:spPr>
+        <p:txBody>
+          <a:bodyPr wrap="none">
+            <a:spAutoFit/>
+          </a:bodyPr>
+          <a:lstStyle/>
+          <a:p>
+            <a:pPr>
+              <a:defRPr sz="1700" b="1">
+                <a:solidFill>
+                  <a:srgbClr val="008577"/>
+                </a:solidFill>
+                <a:latin typeface="Aptos"/>
+              </a:defRPr>
+            </a:pPr>
+            <a:r>
+              <a:t>No routine telemetry export</a:t>
             </a:r>
           </a:p>
         </p:txBody>
@@ -5307,7 +5272,7 @@
               </a:defRPr>
             </a:pPr>
             <a:r>
-              <a:t>Target architecture</a:t>
+              <a:t>The seven-step demo journey</a:t>
             </a:r>
           </a:p>
         </p:txBody>
@@ -5400,7 +5365,7 @@
         <p:spPr>
           <a:xfrm>
             <a:off x="868680" y="1417320"/>
-            <a:ext cx="6537960" cy="4526280"/>
+            <a:ext cx="6400800" cy="4526280"/>
           </a:xfrm>
           <a:prstGeom prst="rect">
             <a:avLst/>
@@ -5417,7 +5382,7 @@
               <a:spcAft>
                 <a:spcPts val="1800"/>
               </a:spcAft>
-              <a:defRPr sz="2200">
+              <a:defRPr sz="2000">
                 <a:solidFill>
                   <a:srgbClr val="182530"/>
                 </a:solidFill>
@@ -5425,7 +5390,7 @@
               </a:defRPr>
             </a:pPr>
             <a:r>
-              <a:t>•  One raw table triggers source-specific update policies</a:t>
+              <a:t>•  1  Raw inbox</a:t>
             </a:r>
           </a:p>
           <a:p>
@@ -5433,7 +5398,7 @@
               <a:spcAft>
                 <a:spcPts val="1800"/>
               </a:spcAft>
-              <a:defRPr sz="2200">
+              <a:defRPr sz="2000">
                 <a:solidFill>
                   <a:srgbClr val="182530"/>
                 </a:solidFill>
@@ -5441,7 +5406,7 @@
               </a:defRPr>
             </a:pPr>
             <a:r>
-              <a:t>•  Ordinary typed tables remain available for OneLake mirroring</a:t>
+              <a:t>•  2  DropMappedFields mapping</a:t>
             </a:r>
           </a:p>
           <a:p>
@@ -5449,7 +5414,7 @@
               <a:spcAft>
                 <a:spcPts val="1800"/>
               </a:spcAft>
-              <a:defRPr sz="2200">
+              <a:defRPr sz="2000">
                 <a:solidFill>
                   <a:srgbClr val="182530"/>
                 </a:solidFill>
@@ -5457,7 +5422,7 @@
               </a:defRPr>
             </a:pPr>
             <a:r>
-              <a:t>•  A separate policy records unknown fields</a:t>
+              <a:t>•  3  Stable target tables</a:t>
             </a:r>
           </a:p>
           <a:p>
@@ -5465,7 +5430,7 @@
               <a:spcAft>
                 <a:spcPts val="1800"/>
               </a:spcAft>
-              <a:defRPr sz="2200">
+              <a:defRPr sz="2000">
                 <a:solidFill>
                   <a:srgbClr val="182530"/>
                 </a:solidFill>
@@ -5473,7 +5438,55 @@
               </a:defRPr>
             </a:pPr>
             <a:r>
-              <a:t>•  Routine telemetry stays inside Eventhouse</a:t>
+              <a:t>•  4  KQL transform functions</a:t>
+            </a:r>
+          </a:p>
+          <a:p>
+            <a:pPr>
+              <a:spcAft>
+                <a:spcPts val="1800"/>
+              </a:spcAft>
+              <a:defRPr sz="2000">
+                <a:solidFill>
+                  <a:srgbClr val="182530"/>
+                </a:solidFill>
+                <a:latin typeface="Aptos"/>
+              </a:defRPr>
+            </a:pPr>
+            <a:r>
+              <a:t>•  5  Automatic policies and drift detection</a:t>
+            </a:r>
+          </a:p>
+          <a:p>
+            <a:pPr>
+              <a:spcAft>
+                <a:spcPts val="1800"/>
+              </a:spcAft>
+              <a:defRPr sz="2000">
+                <a:solidFill>
+                  <a:srgbClr val="182530"/>
+                </a:solidFill>
+                <a:latin typeface="Aptos"/>
+              </a:defRPr>
+            </a:pPr>
+            <a:r>
+              <a:t>•  6  Ingest and prove</a:t>
+            </a:r>
+          </a:p>
+          <a:p>
+            <a:pPr>
+              <a:spcAft>
+                <a:spcPts val="1800"/>
+              </a:spcAft>
+              <a:defRPr sz="2000">
+                <a:solidFill>
+                  <a:srgbClr val="182530"/>
+                </a:solidFill>
+                <a:latin typeface="Aptos"/>
+              </a:defRPr>
+            </a:pPr>
+            <a:r>
+              <a:t>•  7  Promote and backfill</a:t>
             </a:r>
           </a:p>
         </p:txBody>
@@ -5571,7 +5584,7 @@
               </a:defRPr>
             </a:pPr>
             <a:r>
-              <a:t>CAST</a:t>
+              <a:t>BUILD → PROVE → PROMOTE</a:t>
             </a:r>
           </a:p>
         </p:txBody>
@@ -5633,7 +5646,7 @@
               </a:defRPr>
             </a:pPr>
             <a:r>
-              <a:t>Per-record processing</a:t>
+              <a:t>Technique 1: preserve future fields</a:t>
             </a:r>
           </a:p>
         </p:txBody>
@@ -5726,7 +5739,7 @@
         <p:spPr>
           <a:xfrm>
             <a:off x="868680" y="1417320"/>
-            <a:ext cx="6537960" cy="4526280"/>
+            <a:ext cx="6400800" cy="4526280"/>
           </a:xfrm>
           <a:prstGeom prst="rect">
             <a:avLst/>
@@ -5751,7 +5764,7 @@
               </a:defRPr>
             </a:pPr>
             <a:r>
-              <a:t>•  Route by source type</a:t>
+              <a:t>•  Map stable envelope values to columns</a:t>
             </a:r>
           </a:p>
           <a:p>
@@ -5767,7 +5780,7 @@
               </a:defRPr>
             </a:pPr>
             <a:r>
-              <a:t>•  Cast known values to the target contract</a:t>
+              <a:t>•  Keep the rest of the JSON in RawRecord</a:t>
             </a:r>
           </a:p>
           <a:p>
@@ -5783,23 +5796,7 @@
               </a:defRPr>
             </a:pPr>
             <a:r>
-              <a:t>•  Preserve unknown values in a dynamic residual</a:t>
-            </a:r>
-          </a:p>
-          <a:p>
-            <a:pPr>
-              <a:spcAft>
-                <a:spcPts val="1800"/>
-              </a:spcAft>
-              <a:defRPr sz="2200">
-                <a:solidFill>
-                  <a:srgbClr val="182530"/>
-                </a:solidFill>
-                <a:latin typeface="Aptos"/>
-              </a:defRPr>
-            </a:pPr>
-            <a:r>
-              <a:t>•  Record field path, observed type, sample, and event time</a:t>
+              <a:t>•  A producer can add a field without changing the landing table</a:t>
             </a:r>
           </a:p>
         </p:txBody>
@@ -5812,18 +5809,18 @@
         </p:nvSpPr>
         <p:spPr>
           <a:xfrm>
-            <a:off x="7818120" y="1371600"/>
-            <a:ext cx="3749039" cy="4526280"/>
+            <a:off x="7543800" y="1417320"/>
+            <a:ext cx="4069080" cy="4389120"/>
           </a:xfrm>
           <a:prstGeom prst="rect">
             <a:avLst/>
           </a:prstGeom>
           <a:solidFill>
-            <a:srgbClr val="EFF5F7"/>
+            <a:srgbClr val="182530"/>
           </a:solidFill>
           <a:ln>
             <a:solidFill>
-              <a:srgbClr val="D3E0E4"/>
+              <a:srgbClr val="384852"/>
             </a:solidFill>
           </a:ln>
         </p:spPr>
@@ -5842,62 +5839,27 @@
           </a:fontRef>
         </p:style>
         <p:txBody>
-          <a:bodyPr rtlCol="0" anchor="ctr"/>
-          <a:lstStyle/>
-          <a:p>
-            <a:pPr algn="ctr"/>
-          </a:p>
-        </p:txBody>
-      </p:sp>
-      <p:sp>
-        <p:nvSpPr>
-          <p:cNvPr id="7" name="Rounded Rectangle 6"/>
-          <p:cNvSpPr/>
-          <p:nvPr/>
-        </p:nvSpPr>
-        <p:spPr>
-          <a:xfrm>
-            <a:off x="8366760" y="2834640"/>
-            <a:ext cx="2651760" cy="1051560"/>
-          </a:xfrm>
-          <a:prstGeom prst="roundRect">
-            <a:avLst/>
-          </a:prstGeom>
-          <a:solidFill>
-            <a:srgbClr val="008577"/>
-          </a:solidFill>
-          <a:ln>
-            <a:noFill/>
-          </a:ln>
-        </p:spPr>
-        <p:style>
-          <a:lnRef idx="1">
-            <a:schemeClr val="accent1"/>
-          </a:lnRef>
-          <a:fillRef idx="3">
-            <a:schemeClr val="accent1"/>
-          </a:fillRef>
-          <a:effectRef idx="2">
-            <a:schemeClr val="accent1"/>
-          </a:effectRef>
-          <a:fontRef idx="minor">
-            <a:schemeClr val="lt1"/>
-          </a:fontRef>
-        </p:style>
-        <p:txBody>
-          <a:bodyPr rtlCol="0" anchor="ctr"/>
+          <a:bodyPr rtlCol="0" anchor="ctr" lIns="228600" rIns="182880" tIns="228600"/>
           <a:lstStyle/>
           <a:p>
             <a:pPr algn="ctr">
-              <a:defRPr sz="2000" b="1">
-                <a:solidFill>
-                  <a:srgbClr val="FFFFFF"/>
-                </a:solidFill>
-                <a:latin typeface="Aptos Display"/>
-              </a:defRPr>
-            </a:pPr>
-            <a:r>
-              <a:t>ROWS</a:t>
+              <a:defRPr sz="1400">
+                <a:solidFill>
+                  <a:srgbClr val="DCEEF1"/>
+                </a:solidFill>
+                <a:latin typeface="Cascadia Mono"/>
+              </a:defRPr>
+            </a:pPr>
+            <a:r>
+              <a:t>{"Column":"RawRecord",</a:t>
+            </a:r>
+            <a:br/>
+            <a:r>
+              <a:t> "Properties":{"Path":"$",</a:t>
+            </a:r>
+            <a:br/>
+            <a:r>
+              <a:t> "Transform":"DropMappedFields"}}</a:t>
             </a:r>
           </a:p>
         </p:txBody>
@@ -5959,7 +5921,7 @@
               </a:defRPr>
             </a:pPr>
             <a:r>
-              <a:t>Arrays become child rows</a:t>
+              <a:t>Technique 2: guarantee a fixed output</a:t>
             </a:r>
           </a:p>
         </p:txBody>
@@ -6052,7 +6014,7 @@
         <p:spPr>
           <a:xfrm>
             <a:off x="868680" y="1417320"/>
-            <a:ext cx="6537960" cy="4526280"/>
+            <a:ext cx="6400800" cy="4526280"/>
           </a:xfrm>
           <a:prstGeom prst="rect">
             <a:avLst/>
@@ -6077,7 +6039,7 @@
               </a:defRPr>
             </a:pPr>
             <a:r>
-              <a:t>•  Variable zone arrays do not become variable columns</a:t>
+              <a:t>•  Name and cast every approved field</a:t>
             </a:r>
           </a:p>
           <a:p>
@@ -6093,7 +6055,7 @@
               </a:defRPr>
             </a:pPr>
             <a:r>
-              <a:t>•  mv-expand emits one row per zone</a:t>
+              <a:t>•  Remove known keys from the original bag</a:t>
             </a:r>
           </a:p>
           <a:p>
@@ -6109,23 +6071,7 @@
               </a:defRPr>
             </a:pPr>
             <a:r>
-              <a:t>•  Original zone identity is retained</a:t>
-            </a:r>
-          </a:p>
-          <a:p>
-            <a:pPr>
-              <a:spcAft>
-                <a:spcPts val="1800"/>
-              </a:spcAft>
-              <a:defRPr sz="2200">
-                <a:solidFill>
-                  <a:srgbClr val="182530"/>
-                </a:solidFill>
-                <a:latin typeface="Aptos"/>
-              </a:defRPr>
-            </a:pPr>
-            <a:r>
-              <a:t>•  Empty arrays intentionally emit no child rows</a:t>
+              <a:t>•  Anything new remains in ResidualTelemetry</a:t>
             </a:r>
           </a:p>
         </p:txBody>
@@ -6138,18 +6084,18 @@
         </p:nvSpPr>
         <p:spPr>
           <a:xfrm>
-            <a:off x="7818120" y="1371600"/>
-            <a:ext cx="3749039" cy="4526280"/>
+            <a:off x="7543800" y="1417320"/>
+            <a:ext cx="4069080" cy="4389120"/>
           </a:xfrm>
           <a:prstGeom prst="rect">
             <a:avLst/>
           </a:prstGeom>
           <a:solidFill>
-            <a:srgbClr val="EFF5F7"/>
+            <a:srgbClr val="182530"/>
           </a:solidFill>
           <a:ln>
             <a:solidFill>
-              <a:srgbClr val="D3E0E4"/>
+              <a:srgbClr val="384852"/>
             </a:solidFill>
           </a:ln>
         </p:spPr>
@@ -6168,62 +6114,35 @@
           </a:fontRef>
         </p:style>
         <p:txBody>
-          <a:bodyPr rtlCol="0" anchor="ctr"/>
-          <a:lstStyle/>
-          <a:p>
-            <a:pPr algn="ctr"/>
-          </a:p>
-        </p:txBody>
-      </p:sp>
-      <p:sp>
-        <p:nvSpPr>
-          <p:cNvPr id="7" name="Rounded Rectangle 6"/>
-          <p:cNvSpPr/>
-          <p:nvPr/>
-        </p:nvSpPr>
-        <p:spPr>
-          <a:xfrm>
-            <a:off x="8366760" y="2834640"/>
-            <a:ext cx="2651760" cy="1051560"/>
-          </a:xfrm>
-          <a:prstGeom prst="roundRect">
-            <a:avLst/>
-          </a:prstGeom>
-          <a:solidFill>
-            <a:srgbClr val="E67E22"/>
-          </a:solidFill>
-          <a:ln>
-            <a:noFill/>
-          </a:ln>
-        </p:spPr>
-        <p:style>
-          <a:lnRef idx="1">
-            <a:schemeClr val="accent1"/>
-          </a:lnRef>
-          <a:fillRef idx="3">
-            <a:schemeClr val="accent1"/>
-          </a:fillRef>
-          <a:effectRef idx="2">
-            <a:schemeClr val="accent1"/>
-          </a:effectRef>
-          <a:fontRef idx="minor">
-            <a:schemeClr val="lt1"/>
-          </a:fontRef>
-        </p:style>
-        <p:txBody>
-          <a:bodyPr rtlCol="0" anchor="ctr"/>
+          <a:bodyPr rtlCol="0" anchor="ctr" lIns="228600" rIns="182880" tIns="228600"/>
           <a:lstStyle/>
           <a:p>
             <a:pPr algn="ctr">
-              <a:defRPr sz="2000" b="1">
-                <a:solidFill>
-                  <a:srgbClr val="FFFFFF"/>
-                </a:solidFill>
-                <a:latin typeface="Aptos Display"/>
-              </a:defRPr>
-            </a:pPr>
-            <a:r>
-              <a:t>REVIEW</a:t>
+              <a:defRPr sz="1400">
+                <a:solidFill>
+                  <a:srgbClr val="DCEEF1"/>
+                </a:solidFill>
+                <a:latin typeface="Cascadia Mono"/>
+              </a:defRPr>
+            </a:pPr>
+            <a:r>
+              <a:t>ControllerStatus=tostring(Telemetry.controllerStatus),</a:t>
+            </a:r>
+            <a:br/>
+            <a:r>
+              <a:t>EngineHours=toreal(Telemetry.engineHours),</a:t>
+            </a:r>
+            <a:br/>
+            <a:r>
+              <a:t>ResidualTelemetry=bag_remove_keys(</a:t>
+            </a:r>
+            <a:br/>
+            <a:r>
+              <a:t>  Telemetry, dynamic(['controllerStatus',</a:t>
+            </a:r>
+            <a:br/>
+            <a:r>
+              <a:t>  'engineHours', 'fuelConsumption']))</a:t>
             </a:r>
           </a:p>
         </p:txBody>
@@ -6285,7 +6204,7 @@
               </a:defRPr>
             </a:pPr>
             <a:r>
-              <a:t>Drift review</a:t>
+              <a:t>Technique 3: remove the scheduled export</a:t>
             </a:r>
           </a:p>
         </p:txBody>
@@ -6378,7 +6297,7 @@
         <p:spPr>
           <a:xfrm>
             <a:off x="868680" y="1417320"/>
-            <a:ext cx="6537960" cy="4526280"/>
+            <a:ext cx="6400800" cy="4526280"/>
           </a:xfrm>
           <a:prstGeom prst="rect">
             <a:avLst/>
@@ -6403,7 +6322,7 @@
               </a:defRPr>
             </a:pPr>
             <a:r>
-              <a:t>•  Aggregate append-only observations by source and path</a:t>
+              <a:t>•  An update policy reacts when raw data arrives</a:t>
             </a:r>
           </a:p>
           <a:p>
@@ -6419,7 +6338,7 @@
               </a:defRPr>
             </a:pPr>
             <a:r>
-              <a:t>•  Profile type stability, null rate, and cardinality</a:t>
+              <a:t>•  The policy calls the stored KQL function</a:t>
             </a:r>
           </a:p>
           <a:p>
@@ -6435,23 +6354,7 @@
               </a:defRPr>
             </a:pPr>
             <a:r>
-              <a:t>•  Promote only fields with agreed semantics and ownership</a:t>
-            </a:r>
-          </a:p>
-          <a:p>
-            <a:pPr>
-              <a:spcAft>
-                <a:spcPts val="1800"/>
-              </a:spcAft>
-              <a:defRPr sz="2200">
-                <a:solidFill>
-                  <a:srgbClr val="182530"/>
-                </a:solidFill>
-                <a:latin typeface="Aptos"/>
-              </a:defRPr>
-            </a:pPr>
-            <a:r>
-              <a:t>•  Keep sparse or unstable fields dynamic</a:t>
+              <a:t>•  IsTransactional:false keeps raw ingestion available for replay</a:t>
             </a:r>
           </a:p>
         </p:txBody>
@@ -6464,18 +6367,18 @@
         </p:nvSpPr>
         <p:spPr>
           <a:xfrm>
-            <a:off x="7818120" y="1371600"/>
-            <a:ext cx="3749039" cy="4526280"/>
+            <a:off x="7543800" y="1417320"/>
+            <a:ext cx="4069080" cy="4389120"/>
           </a:xfrm>
           <a:prstGeom prst="rect">
             <a:avLst/>
           </a:prstGeom>
           <a:solidFill>
-            <a:srgbClr val="EFF5F7"/>
+            <a:srgbClr val="182530"/>
           </a:solidFill>
           <a:ln>
             <a:solidFill>
-              <a:srgbClr val="D3E0E4"/>
+              <a:srgbClr val="384852"/>
             </a:solidFill>
           </a:ln>
         </p:spPr>
@@ -6494,62 +6397,27 @@
           </a:fontRef>
         </p:style>
         <p:txBody>
-          <a:bodyPr rtlCol="0" anchor="ctr"/>
-          <a:lstStyle/>
-          <a:p>
-            <a:pPr algn="ctr"/>
-          </a:p>
-        </p:txBody>
-      </p:sp>
-      <p:sp>
-        <p:nvSpPr>
-          <p:cNvPr id="7" name="Rounded Rectangle 6"/>
-          <p:cNvSpPr/>
-          <p:nvPr/>
-        </p:nvSpPr>
-        <p:spPr>
-          <a:xfrm>
-            <a:off x="8366760" y="2834640"/>
-            <a:ext cx="2651760" cy="1051560"/>
-          </a:xfrm>
-          <a:prstGeom prst="roundRect">
-            <a:avLst/>
-          </a:prstGeom>
-          <a:solidFill>
-            <a:srgbClr val="E67E22"/>
-          </a:solidFill>
-          <a:ln>
-            <a:noFill/>
-          </a:ln>
-        </p:spPr>
-        <p:style>
-          <a:lnRef idx="1">
-            <a:schemeClr val="accent1"/>
-          </a:lnRef>
-          <a:fillRef idx="3">
-            <a:schemeClr val="accent1"/>
-          </a:fillRef>
-          <a:effectRef idx="2">
-            <a:schemeClr val="accent1"/>
-          </a:effectRef>
-          <a:fontRef idx="minor">
-            <a:schemeClr val="lt1"/>
-          </a:fontRef>
-        </p:style>
-        <p:txBody>
-          <a:bodyPr rtlCol="0" anchor="ctr"/>
+          <a:bodyPr rtlCol="0" anchor="ctr" lIns="228600" rIns="182880" tIns="228600"/>
           <a:lstStyle/>
           <a:p>
             <a:pPr algn="ctr">
-              <a:defRPr sz="2000" b="1">
-                <a:solidFill>
-                  <a:srgbClr val="FFFFFF"/>
-                </a:solidFill>
-                <a:latin typeface="Aptos Display"/>
-              </a:defRPr>
-            </a:pPr>
-            <a:r>
-              <a:t>PROMOTE</a:t>
+              <a:defRPr sz="1400">
+                <a:solidFill>
+                  <a:srgbClr val="DCEEF1"/>
+                </a:solidFill>
+                <a:latin typeface="Cascadia Mono"/>
+              </a:defRPr>
+            </a:pPr>
+            <a:r>
+              <a:t>{"Source":"RawTelemetry",</a:t>
+            </a:r>
+            <a:br/>
+            <a:r>
+              <a:t> "Query":"TransformControllerTelemetry()",</a:t>
+            </a:r>
+            <a:br/>
+            <a:r>
+              <a:t> "IsTransactional":false}</a:t>
             </a:r>
           </a:p>
         </p:txBody>
@@ -6611,7 +6479,7 @@
               </a:defRPr>
             </a:pPr>
             <a:r>
-              <a:t>Promotion and backfill</a:t>
+              <a:t>Technique 4: detect keys and expand arrays</a:t>
             </a:r>
           </a:p>
         </p:txBody>
@@ -6704,7 +6572,7 @@
         <p:spPr>
           <a:xfrm>
             <a:off x="868680" y="1417320"/>
-            <a:ext cx="6537960" cy="4526280"/>
+            <a:ext cx="6400800" cy="4526280"/>
           </a:xfrm>
           <a:prstGeom prst="rect">
             <a:avLst/>
@@ -6729,7 +6597,7 @@
               </a:defRPr>
             </a:pPr>
             <a:r>
-              <a:t>•  Add the physical column</a:t>
+              <a:t>•  bag_keys lists fields that actually arrived</a:t>
             </a:r>
           </a:p>
           <a:p>
@@ -6745,7 +6613,7 @@
               </a:defRPr>
             </a:pPr>
             <a:r>
-              <a:t>•  Revise and schema-check the stored function</a:t>
+              <a:t>•  set_has_element compares them with the approved list</a:t>
             </a:r>
           </a:p>
           <a:p>
@@ -6761,39 +6629,7 @@
               </a:defRPr>
             </a:pPr>
             <a:r>
-              <a:t>•  Monitor new ingestion</a:t>
-            </a:r>
-          </a:p>
-          <a:p>
-            <a:pPr>
-              <a:spcAft>
-                <a:spcPts val="1800"/>
-              </a:spcAft>
-              <a:defRPr sz="2200">
-                <a:solidFill>
-                  <a:srgbClr val="182530"/>
-                </a:solidFill>
-                <a:latin typeface="Aptos"/>
-              </a:defRPr>
-            </a:pPr>
-            <a:r>
-              <a:t>•  Replay a bounded raw interval</a:t>
-            </a:r>
-          </a:p>
-          <a:p>
-            <a:pPr>
-              <a:spcAft>
-                <a:spcPts val="1800"/>
-              </a:spcAft>
-              <a:defRPr sz="2200">
-                <a:solidFill>
-                  <a:srgbClr val="182530"/>
-                </a:solidFill>
-                <a:latin typeface="Aptos"/>
-              </a:defRPr>
-            </a:pPr>
-            <a:r>
-              <a:t>•  Deduplicate appended versions or migrate to a replacement table</a:t>
+              <a:t>•  mv-expand turns unknown keys or array items into rows</a:t>
             </a:r>
           </a:p>
         </p:txBody>
@@ -6806,18 +6642,18 @@
         </p:nvSpPr>
         <p:spPr>
           <a:xfrm>
-            <a:off x="7818120" y="1371600"/>
-            <a:ext cx="3749039" cy="4526280"/>
+            <a:off x="7543800" y="1417320"/>
+            <a:ext cx="4069080" cy="4389120"/>
           </a:xfrm>
           <a:prstGeom prst="rect">
             <a:avLst/>
           </a:prstGeom>
           <a:solidFill>
-            <a:srgbClr val="EFF5F7"/>
+            <a:srgbClr val="182530"/>
           </a:solidFill>
           <a:ln>
             <a:solidFill>
-              <a:srgbClr val="D3E0E4"/>
+              <a:srgbClr val="384852"/>
             </a:solidFill>
           </a:ln>
         </p:spPr>
@@ -6836,62 +6672,28 @@
           </a:fontRef>
         </p:style>
         <p:txBody>
-          <a:bodyPr rtlCol="0" anchor="ctr"/>
-          <a:lstStyle/>
-          <a:p>
-            <a:pPr algn="ctr"/>
-          </a:p>
-        </p:txBody>
-      </p:sp>
-      <p:sp>
-        <p:nvSpPr>
-          <p:cNvPr id="7" name="Rounded Rectangle 6"/>
-          <p:cNvSpPr/>
-          <p:nvPr/>
-        </p:nvSpPr>
-        <p:spPr>
-          <a:xfrm>
-            <a:off x="8366760" y="2834640"/>
-            <a:ext cx="2651760" cy="1051560"/>
-          </a:xfrm>
-          <a:prstGeom prst="roundRect">
-            <a:avLst/>
-          </a:prstGeom>
-          <a:solidFill>
-            <a:srgbClr val="008577"/>
-          </a:solidFill>
-          <a:ln>
-            <a:noFill/>
-          </a:ln>
-        </p:spPr>
-        <p:style>
-          <a:lnRef idx="1">
-            <a:schemeClr val="accent1"/>
-          </a:lnRef>
-          <a:fillRef idx="3">
-            <a:schemeClr val="accent1"/>
-          </a:fillRef>
-          <a:effectRef idx="2">
-            <a:schemeClr val="accent1"/>
-          </a:effectRef>
-          <a:fontRef idx="minor">
-            <a:schemeClr val="lt1"/>
-          </a:fontRef>
-        </p:style>
-        <p:txBody>
-          <a:bodyPr rtlCol="0" anchor="ctr"/>
+          <a:bodyPr rtlCol="0" anchor="ctr" lIns="228600" rIns="182880" tIns="228600"/>
           <a:lstStyle/>
           <a:p>
             <a:pPr algn="ctr">
-              <a:defRPr sz="2000" b="1">
-                <a:solidFill>
-                  <a:srgbClr val="FFFFFF"/>
-                </a:solidFill>
-                <a:latin typeface="Aptos Display"/>
-              </a:defRPr>
-            </a:pPr>
-            <a:r>
-              <a:t>DELTA</a:t>
+              <a:defRPr sz="1400">
+                <a:solidFill>
+                  <a:srgbClr val="DCEEF1"/>
+                </a:solidFill>
+                <a:latin typeface="Cascadia Mono"/>
+              </a:defRPr>
+            </a:pPr>
+            <a:r>
+              <a:t>| mv-expand FieldName=bag_keys(Telemetry)</a:t>
+            </a:r>
+            <a:br/>
+            <a:r>
+              <a:t>| where not(set_has_element(KnownKeys, FieldName))</a:t>
+            </a:r>
+            <a:br/>
+            <a:br/>
+            <a:r>
+              <a:t>| mv-expand Zone=Zones</a:t>
             </a:r>
           </a:p>
         </p:txBody>

</xml_diff>

<commit_message>
Apply dark theme to presentation
</commit_message>
<xml_diff>
--- a/presentation/eventhouse-schema-drift-reference.pptx
+++ b/presentation/eventhouse-schema-drift-reference.pptx
@@ -3095,7 +3095,7 @@
     <p:bg>
       <p:bgPr>
         <a:solidFill>
-          <a:srgbClr val="FFFFFF"/>
+          <a:srgbClr val="0E161D"/>
         </a:solidFill>
         <a:effectLst/>
       </p:bgPr>
@@ -3175,7 +3175,7 @@
             <a:pPr>
               <a:defRPr sz="3800" b="1">
                 <a:solidFill>
-                  <a:srgbClr val="182530"/>
+                  <a:srgbClr val="EBF2F4"/>
                 </a:solidFill>
                 <a:latin typeface="Aptos"/>
               </a:defRPr>
@@ -3211,7 +3211,7 @@
             <a:pPr>
               <a:defRPr sz="2100" b="0">
                 <a:solidFill>
-                  <a:srgbClr val="52646D"/>
+                  <a:srgbClr val="AABEC6"/>
                 </a:solidFill>
                 <a:latin typeface="Aptos"/>
               </a:defRPr>
@@ -3276,7 +3276,7 @@
     <p:bg>
       <p:bgPr>
         <a:solidFill>
-          <a:srgbClr val="FFFFFF"/>
+          <a:srgbClr val="0E161D"/>
         </a:solidFill>
         <a:effectLst/>
       </p:bgPr>
@@ -3313,7 +3313,7 @@
             <a:pPr>
               <a:defRPr sz="2800" b="1">
                 <a:solidFill>
-                  <a:srgbClr val="182530"/>
+                  <a:srgbClr val="EBF2F4"/>
                 </a:solidFill>
                 <a:latin typeface="Aptos"/>
               </a:defRPr>
@@ -3431,7 +3431,7 @@
               </a:spcAft>
               <a:defRPr sz="2200">
                 <a:solidFill>
-                  <a:srgbClr val="182530"/>
+                  <a:srgbClr val="EBF2F4"/>
                 </a:solidFill>
                 <a:latin typeface="Aptos"/>
               </a:defRPr>
@@ -3447,7 +3447,7 @@
               </a:spcAft>
               <a:defRPr sz="2200">
                 <a:solidFill>
-                  <a:srgbClr val="182530"/>
+                  <a:srgbClr val="EBF2F4"/>
                 </a:solidFill>
                 <a:latin typeface="Aptos"/>
               </a:defRPr>
@@ -3463,7 +3463,7 @@
               </a:spcAft>
               <a:defRPr sz="2200">
                 <a:solidFill>
-                  <a:srgbClr val="182530"/>
+                  <a:srgbClr val="EBF2F4"/>
                 </a:solidFill>
                 <a:latin typeface="Aptos"/>
               </a:defRPr>
@@ -3479,7 +3479,7 @@
               </a:spcAft>
               <a:defRPr sz="2200">
                 <a:solidFill>
-                  <a:srgbClr val="182530"/>
+                  <a:srgbClr val="EBF2F4"/>
                 </a:solidFill>
                 <a:latin typeface="Aptos"/>
               </a:defRPr>
@@ -3495,7 +3495,7 @@
               </a:spcAft>
               <a:defRPr sz="2200">
                 <a:solidFill>
-                  <a:srgbClr val="182530"/>
+                  <a:srgbClr val="EBF2F4"/>
                 </a:solidFill>
                 <a:latin typeface="Aptos"/>
               </a:defRPr>
@@ -3521,11 +3521,11 @@
             <a:avLst/>
           </a:prstGeom>
           <a:solidFill>
-            <a:srgbClr val="EFF5F7"/>
+            <a:srgbClr val="1B2932"/>
           </a:solidFill>
           <a:ln>
             <a:solidFill>
-              <a:srgbClr val="D3E0E4"/>
+              <a:srgbClr val="3C525C"/>
             </a:solidFill>
           </a:ln>
         </p:spPr>
@@ -3618,7 +3618,7 @@
     <p:bg>
       <p:bgPr>
         <a:solidFill>
-          <a:srgbClr val="FFFFFF"/>
+          <a:srgbClr val="0E161D"/>
         </a:solidFill>
         <a:effectLst/>
       </p:bgPr>
@@ -3655,7 +3655,7 @@
             <a:pPr>
               <a:defRPr sz="2800" b="1">
                 <a:solidFill>
-                  <a:srgbClr val="182530"/>
+                  <a:srgbClr val="EBF2F4"/>
                 </a:solidFill>
                 <a:latin typeface="Aptos"/>
               </a:defRPr>
@@ -3773,7 +3773,7 @@
               </a:spcAft>
               <a:defRPr sz="2200">
                 <a:solidFill>
-                  <a:srgbClr val="182530"/>
+                  <a:srgbClr val="EBF2F4"/>
                 </a:solidFill>
                 <a:latin typeface="Aptos"/>
               </a:defRPr>
@@ -3789,7 +3789,7 @@
               </a:spcAft>
               <a:defRPr sz="2200">
                 <a:solidFill>
-                  <a:srgbClr val="182530"/>
+                  <a:srgbClr val="EBF2F4"/>
                 </a:solidFill>
                 <a:latin typeface="Aptos"/>
               </a:defRPr>
@@ -3805,7 +3805,7 @@
               </a:spcAft>
               <a:defRPr sz="2200">
                 <a:solidFill>
-                  <a:srgbClr val="182530"/>
+                  <a:srgbClr val="EBF2F4"/>
                 </a:solidFill>
                 <a:latin typeface="Aptos"/>
               </a:defRPr>
@@ -3821,7 +3821,7 @@
               </a:spcAft>
               <a:defRPr sz="2200">
                 <a:solidFill>
-                  <a:srgbClr val="182530"/>
+                  <a:srgbClr val="EBF2F4"/>
                 </a:solidFill>
                 <a:latin typeface="Aptos"/>
               </a:defRPr>
@@ -3837,7 +3837,7 @@
               </a:spcAft>
               <a:defRPr sz="2200">
                 <a:solidFill>
-                  <a:srgbClr val="182530"/>
+                  <a:srgbClr val="EBF2F4"/>
                 </a:solidFill>
                 <a:latin typeface="Aptos"/>
               </a:defRPr>
@@ -3863,11 +3863,11 @@
             <a:avLst/>
           </a:prstGeom>
           <a:solidFill>
-            <a:srgbClr val="182530"/>
+            <a:srgbClr val="080F14"/>
           </a:solidFill>
           <a:ln>
             <a:solidFill>
-              <a:srgbClr val="384852"/>
+              <a:srgbClr val="3C525C"/>
             </a:solidFill>
           </a:ln>
         </p:spPr>
@@ -3931,7 +3931,7 @@
     <p:bg>
       <p:bgPr>
         <a:solidFill>
-          <a:srgbClr val="FFFFFF"/>
+          <a:srgbClr val="0E161D"/>
         </a:solidFill>
         <a:effectLst/>
       </p:bgPr>
@@ -3968,7 +3968,7 @@
             <a:pPr>
               <a:defRPr sz="2800" b="1">
                 <a:solidFill>
-                  <a:srgbClr val="182530"/>
+                  <a:srgbClr val="EBF2F4"/>
                 </a:solidFill>
                 <a:latin typeface="Aptos"/>
               </a:defRPr>
@@ -4086,7 +4086,7 @@
               </a:spcAft>
               <a:defRPr sz="2200">
                 <a:solidFill>
-                  <a:srgbClr val="182530"/>
+                  <a:srgbClr val="EBF2F4"/>
                 </a:solidFill>
                 <a:latin typeface="Aptos"/>
               </a:defRPr>
@@ -4102,7 +4102,7 @@
               </a:spcAft>
               <a:defRPr sz="2200">
                 <a:solidFill>
-                  <a:srgbClr val="182530"/>
+                  <a:srgbClr val="EBF2F4"/>
                 </a:solidFill>
                 <a:latin typeface="Aptos"/>
               </a:defRPr>
@@ -4118,7 +4118,7 @@
               </a:spcAft>
               <a:defRPr sz="2200">
                 <a:solidFill>
-                  <a:srgbClr val="182530"/>
+                  <a:srgbClr val="EBF2F4"/>
                 </a:solidFill>
                 <a:latin typeface="Aptos"/>
               </a:defRPr>
@@ -4134,7 +4134,7 @@
               </a:spcAft>
               <a:defRPr sz="2200">
                 <a:solidFill>
-                  <a:srgbClr val="182530"/>
+                  <a:srgbClr val="EBF2F4"/>
                 </a:solidFill>
                 <a:latin typeface="Aptos"/>
               </a:defRPr>
@@ -4150,7 +4150,7 @@
               </a:spcAft>
               <a:defRPr sz="2200">
                 <a:solidFill>
-                  <a:srgbClr val="182530"/>
+                  <a:srgbClr val="EBF2F4"/>
                 </a:solidFill>
                 <a:latin typeface="Aptos"/>
               </a:defRPr>
@@ -4176,11 +4176,11 @@
             <a:avLst/>
           </a:prstGeom>
           <a:solidFill>
-            <a:srgbClr val="EFF5F7"/>
+            <a:srgbClr val="1B2932"/>
           </a:solidFill>
           <a:ln>
             <a:solidFill>
-              <a:srgbClr val="D3E0E4"/>
+              <a:srgbClr val="3C525C"/>
             </a:solidFill>
           </a:ln>
         </p:spPr>
@@ -4273,7 +4273,7 @@
     <p:bg>
       <p:bgPr>
         <a:solidFill>
-          <a:srgbClr val="FFFFFF"/>
+          <a:srgbClr val="0E161D"/>
         </a:solidFill>
         <a:effectLst/>
       </p:bgPr>
@@ -4310,7 +4310,7 @@
             <a:pPr>
               <a:defRPr sz="2800" b="1">
                 <a:solidFill>
-                  <a:srgbClr val="182530"/>
+                  <a:srgbClr val="EBF2F4"/>
                 </a:solidFill>
                 <a:latin typeface="Aptos"/>
               </a:defRPr>
@@ -4428,7 +4428,7 @@
               </a:spcAft>
               <a:defRPr sz="2200">
                 <a:solidFill>
-                  <a:srgbClr val="182530"/>
+                  <a:srgbClr val="EBF2F4"/>
                 </a:solidFill>
                 <a:latin typeface="Aptos"/>
               </a:defRPr>
@@ -4444,7 +4444,7 @@
               </a:spcAft>
               <a:defRPr sz="2200">
                 <a:solidFill>
-                  <a:srgbClr val="182530"/>
+                  <a:srgbClr val="EBF2F4"/>
                 </a:solidFill>
                 <a:latin typeface="Aptos"/>
               </a:defRPr>
@@ -4460,7 +4460,7 @@
               </a:spcAft>
               <a:defRPr sz="2200">
                 <a:solidFill>
-                  <a:srgbClr val="182530"/>
+                  <a:srgbClr val="EBF2F4"/>
                 </a:solidFill>
                 <a:latin typeface="Aptos"/>
               </a:defRPr>
@@ -4476,7 +4476,7 @@
               </a:spcAft>
               <a:defRPr sz="2200">
                 <a:solidFill>
-                  <a:srgbClr val="182530"/>
+                  <a:srgbClr val="EBF2F4"/>
                 </a:solidFill>
                 <a:latin typeface="Aptos"/>
               </a:defRPr>
@@ -4502,11 +4502,11 @@
             <a:avLst/>
           </a:prstGeom>
           <a:solidFill>
-            <a:srgbClr val="EFF5F7"/>
+            <a:srgbClr val="1B2932"/>
           </a:solidFill>
           <a:ln>
             <a:solidFill>
-              <a:srgbClr val="D3E0E4"/>
+              <a:srgbClr val="3C525C"/>
             </a:solidFill>
           </a:ln>
         </p:spPr>
@@ -4599,7 +4599,7 @@
     <p:bg>
       <p:bgPr>
         <a:solidFill>
-          <a:srgbClr val="FFFFFF"/>
+          <a:srgbClr val="0E161D"/>
         </a:solidFill>
         <a:effectLst/>
       </p:bgPr>
@@ -4636,7 +4636,7 @@
             <a:pPr>
               <a:defRPr sz="2800" b="1">
                 <a:solidFill>
-                  <a:srgbClr val="182530"/>
+                  <a:srgbClr val="EBF2F4"/>
                 </a:solidFill>
                 <a:latin typeface="Aptos"/>
               </a:defRPr>
@@ -4754,7 +4754,7 @@
               </a:spcAft>
               <a:defRPr sz="2200">
                 <a:solidFill>
-                  <a:srgbClr val="182530"/>
+                  <a:srgbClr val="EBF2F4"/>
                 </a:solidFill>
                 <a:latin typeface="Aptos"/>
               </a:defRPr>
@@ -4770,7 +4770,7 @@
               </a:spcAft>
               <a:defRPr sz="2200">
                 <a:solidFill>
-                  <a:srgbClr val="182530"/>
+                  <a:srgbClr val="EBF2F4"/>
                 </a:solidFill>
                 <a:latin typeface="Aptos"/>
               </a:defRPr>
@@ -4786,7 +4786,7 @@
               </a:spcAft>
               <a:defRPr sz="2200">
                 <a:solidFill>
-                  <a:srgbClr val="182530"/>
+                  <a:srgbClr val="EBF2F4"/>
                 </a:solidFill>
                 <a:latin typeface="Aptos"/>
               </a:defRPr>
@@ -4802,7 +4802,7 @@
               </a:spcAft>
               <a:defRPr sz="2200">
                 <a:solidFill>
-                  <a:srgbClr val="182530"/>
+                  <a:srgbClr val="EBF2F4"/>
                 </a:solidFill>
                 <a:latin typeface="Aptos"/>
               </a:defRPr>
@@ -4828,11 +4828,11 @@
             <a:avLst/>
           </a:prstGeom>
           <a:solidFill>
-            <a:srgbClr val="EFF5F7"/>
+            <a:srgbClr val="1B2932"/>
           </a:solidFill>
           <a:ln>
             <a:solidFill>
-              <a:srgbClr val="D3E0E4"/>
+              <a:srgbClr val="3C525C"/>
             </a:solidFill>
           </a:ln>
         </p:spPr>
@@ -4925,7 +4925,7 @@
     <p:bg>
       <p:bgPr>
         <a:solidFill>
-          <a:srgbClr val="FFFFFF"/>
+          <a:srgbClr val="0E161D"/>
         </a:solidFill>
         <a:effectLst/>
       </p:bgPr>
@@ -4962,7 +4962,7 @@
             <a:pPr>
               <a:defRPr sz="2800" b="1">
                 <a:solidFill>
-                  <a:srgbClr val="182530"/>
+                  <a:srgbClr val="EBF2F4"/>
                 </a:solidFill>
                 <a:latin typeface="Aptos"/>
               </a:defRPr>
@@ -5080,7 +5080,7 @@
               </a:spcAft>
               <a:defRPr sz="2200">
                 <a:solidFill>
-                  <a:srgbClr val="182530"/>
+                  <a:srgbClr val="EBF2F4"/>
                 </a:solidFill>
                 <a:latin typeface="Aptos"/>
               </a:defRPr>
@@ -5096,7 +5096,7 @@
               </a:spcAft>
               <a:defRPr sz="2200">
                 <a:solidFill>
-                  <a:srgbClr val="182530"/>
+                  <a:srgbClr val="EBF2F4"/>
                 </a:solidFill>
                 <a:latin typeface="Aptos"/>
               </a:defRPr>
@@ -5112,7 +5112,7 @@
               </a:spcAft>
               <a:defRPr sz="2200">
                 <a:solidFill>
-                  <a:srgbClr val="182530"/>
+                  <a:srgbClr val="EBF2F4"/>
                 </a:solidFill>
                 <a:latin typeface="Aptos"/>
               </a:defRPr>
@@ -5128,7 +5128,7 @@
               </a:spcAft>
               <a:defRPr sz="2200">
                 <a:solidFill>
-                  <a:srgbClr val="182530"/>
+                  <a:srgbClr val="EBF2F4"/>
                 </a:solidFill>
                 <a:latin typeface="Aptos"/>
               </a:defRPr>
@@ -5144,7 +5144,7 @@
               </a:spcAft>
               <a:defRPr sz="2200">
                 <a:solidFill>
-                  <a:srgbClr val="182530"/>
+                  <a:srgbClr val="EBF2F4"/>
                 </a:solidFill>
                 <a:latin typeface="Aptos"/>
               </a:defRPr>
@@ -5229,7 +5229,7 @@
     <p:bg>
       <p:bgPr>
         <a:solidFill>
-          <a:srgbClr val="FFFFFF"/>
+          <a:srgbClr val="0E161D"/>
         </a:solidFill>
         <a:effectLst/>
       </p:bgPr>
@@ -5266,7 +5266,7 @@
             <a:pPr>
               <a:defRPr sz="2800" b="1">
                 <a:solidFill>
-                  <a:srgbClr val="182530"/>
+                  <a:srgbClr val="EBF2F4"/>
                 </a:solidFill>
                 <a:latin typeface="Aptos"/>
               </a:defRPr>
@@ -5384,7 +5384,7 @@
               </a:spcAft>
               <a:defRPr sz="2000">
                 <a:solidFill>
-                  <a:srgbClr val="182530"/>
+                  <a:srgbClr val="EBF2F4"/>
                 </a:solidFill>
                 <a:latin typeface="Aptos"/>
               </a:defRPr>
@@ -5400,7 +5400,7 @@
               </a:spcAft>
               <a:defRPr sz="2000">
                 <a:solidFill>
-                  <a:srgbClr val="182530"/>
+                  <a:srgbClr val="EBF2F4"/>
                 </a:solidFill>
                 <a:latin typeface="Aptos"/>
               </a:defRPr>
@@ -5416,7 +5416,7 @@
               </a:spcAft>
               <a:defRPr sz="2000">
                 <a:solidFill>
-                  <a:srgbClr val="182530"/>
+                  <a:srgbClr val="EBF2F4"/>
                 </a:solidFill>
                 <a:latin typeface="Aptos"/>
               </a:defRPr>
@@ -5432,7 +5432,7 @@
               </a:spcAft>
               <a:defRPr sz="2000">
                 <a:solidFill>
-                  <a:srgbClr val="182530"/>
+                  <a:srgbClr val="EBF2F4"/>
                 </a:solidFill>
                 <a:latin typeface="Aptos"/>
               </a:defRPr>
@@ -5448,7 +5448,7 @@
               </a:spcAft>
               <a:defRPr sz="2000">
                 <a:solidFill>
-                  <a:srgbClr val="182530"/>
+                  <a:srgbClr val="EBF2F4"/>
                 </a:solidFill>
                 <a:latin typeface="Aptos"/>
               </a:defRPr>
@@ -5464,7 +5464,7 @@
               </a:spcAft>
               <a:defRPr sz="2000">
                 <a:solidFill>
-                  <a:srgbClr val="182530"/>
+                  <a:srgbClr val="EBF2F4"/>
                 </a:solidFill>
                 <a:latin typeface="Aptos"/>
               </a:defRPr>
@@ -5480,7 +5480,7 @@
               </a:spcAft>
               <a:defRPr sz="2000">
                 <a:solidFill>
-                  <a:srgbClr val="182530"/>
+                  <a:srgbClr val="EBF2F4"/>
                 </a:solidFill>
                 <a:latin typeface="Aptos"/>
               </a:defRPr>
@@ -5506,11 +5506,11 @@
             <a:avLst/>
           </a:prstGeom>
           <a:solidFill>
-            <a:srgbClr val="EFF5F7"/>
+            <a:srgbClr val="1B2932"/>
           </a:solidFill>
           <a:ln>
             <a:solidFill>
-              <a:srgbClr val="D3E0E4"/>
+              <a:srgbClr val="3C525C"/>
             </a:solidFill>
           </a:ln>
         </p:spPr>
@@ -5603,7 +5603,7 @@
     <p:bg>
       <p:bgPr>
         <a:solidFill>
-          <a:srgbClr val="FFFFFF"/>
+          <a:srgbClr val="0E161D"/>
         </a:solidFill>
         <a:effectLst/>
       </p:bgPr>
@@ -5640,7 +5640,7 @@
             <a:pPr>
               <a:defRPr sz="2800" b="1">
                 <a:solidFill>
-                  <a:srgbClr val="182530"/>
+                  <a:srgbClr val="EBF2F4"/>
                 </a:solidFill>
                 <a:latin typeface="Aptos"/>
               </a:defRPr>
@@ -5758,7 +5758,7 @@
               </a:spcAft>
               <a:defRPr sz="2200">
                 <a:solidFill>
-                  <a:srgbClr val="182530"/>
+                  <a:srgbClr val="EBF2F4"/>
                 </a:solidFill>
                 <a:latin typeface="Aptos"/>
               </a:defRPr>
@@ -5774,7 +5774,7 @@
               </a:spcAft>
               <a:defRPr sz="2200">
                 <a:solidFill>
-                  <a:srgbClr val="182530"/>
+                  <a:srgbClr val="EBF2F4"/>
                 </a:solidFill>
                 <a:latin typeface="Aptos"/>
               </a:defRPr>
@@ -5790,7 +5790,7 @@
               </a:spcAft>
               <a:defRPr sz="2200">
                 <a:solidFill>
-                  <a:srgbClr val="182530"/>
+                  <a:srgbClr val="EBF2F4"/>
                 </a:solidFill>
                 <a:latin typeface="Aptos"/>
               </a:defRPr>
@@ -5816,11 +5816,11 @@
             <a:avLst/>
           </a:prstGeom>
           <a:solidFill>
-            <a:srgbClr val="182530"/>
+            <a:srgbClr val="080F14"/>
           </a:solidFill>
           <a:ln>
             <a:solidFill>
-              <a:srgbClr val="384852"/>
+              <a:srgbClr val="3C525C"/>
             </a:solidFill>
           </a:ln>
         </p:spPr>
@@ -5878,7 +5878,7 @@
     <p:bg>
       <p:bgPr>
         <a:solidFill>
-          <a:srgbClr val="FFFFFF"/>
+          <a:srgbClr val="0E161D"/>
         </a:solidFill>
         <a:effectLst/>
       </p:bgPr>
@@ -5915,7 +5915,7 @@
             <a:pPr>
               <a:defRPr sz="2800" b="1">
                 <a:solidFill>
-                  <a:srgbClr val="182530"/>
+                  <a:srgbClr val="EBF2F4"/>
                 </a:solidFill>
                 <a:latin typeface="Aptos"/>
               </a:defRPr>
@@ -6033,7 +6033,7 @@
               </a:spcAft>
               <a:defRPr sz="2200">
                 <a:solidFill>
-                  <a:srgbClr val="182530"/>
+                  <a:srgbClr val="EBF2F4"/>
                 </a:solidFill>
                 <a:latin typeface="Aptos"/>
               </a:defRPr>
@@ -6049,7 +6049,7 @@
               </a:spcAft>
               <a:defRPr sz="2200">
                 <a:solidFill>
-                  <a:srgbClr val="182530"/>
+                  <a:srgbClr val="EBF2F4"/>
                 </a:solidFill>
                 <a:latin typeface="Aptos"/>
               </a:defRPr>
@@ -6065,7 +6065,7 @@
               </a:spcAft>
               <a:defRPr sz="2200">
                 <a:solidFill>
-                  <a:srgbClr val="182530"/>
+                  <a:srgbClr val="EBF2F4"/>
                 </a:solidFill>
                 <a:latin typeface="Aptos"/>
               </a:defRPr>
@@ -6091,11 +6091,11 @@
             <a:avLst/>
           </a:prstGeom>
           <a:solidFill>
-            <a:srgbClr val="182530"/>
+            <a:srgbClr val="080F14"/>
           </a:solidFill>
           <a:ln>
             <a:solidFill>
-              <a:srgbClr val="384852"/>
+              <a:srgbClr val="3C525C"/>
             </a:solidFill>
           </a:ln>
         </p:spPr>
@@ -6161,7 +6161,7 @@
     <p:bg>
       <p:bgPr>
         <a:solidFill>
-          <a:srgbClr val="FFFFFF"/>
+          <a:srgbClr val="0E161D"/>
         </a:solidFill>
         <a:effectLst/>
       </p:bgPr>
@@ -6198,7 +6198,7 @@
             <a:pPr>
               <a:defRPr sz="2800" b="1">
                 <a:solidFill>
-                  <a:srgbClr val="182530"/>
+                  <a:srgbClr val="EBF2F4"/>
                 </a:solidFill>
                 <a:latin typeface="Aptos"/>
               </a:defRPr>
@@ -6316,7 +6316,7 @@
               </a:spcAft>
               <a:defRPr sz="2200">
                 <a:solidFill>
-                  <a:srgbClr val="182530"/>
+                  <a:srgbClr val="EBF2F4"/>
                 </a:solidFill>
                 <a:latin typeface="Aptos"/>
               </a:defRPr>
@@ -6332,7 +6332,7 @@
               </a:spcAft>
               <a:defRPr sz="2200">
                 <a:solidFill>
-                  <a:srgbClr val="182530"/>
+                  <a:srgbClr val="EBF2F4"/>
                 </a:solidFill>
                 <a:latin typeface="Aptos"/>
               </a:defRPr>
@@ -6348,7 +6348,7 @@
               </a:spcAft>
               <a:defRPr sz="2200">
                 <a:solidFill>
-                  <a:srgbClr val="182530"/>
+                  <a:srgbClr val="EBF2F4"/>
                 </a:solidFill>
                 <a:latin typeface="Aptos"/>
               </a:defRPr>
@@ -6374,11 +6374,11 @@
             <a:avLst/>
           </a:prstGeom>
           <a:solidFill>
-            <a:srgbClr val="182530"/>
+            <a:srgbClr val="080F14"/>
           </a:solidFill>
           <a:ln>
             <a:solidFill>
-              <a:srgbClr val="384852"/>
+              <a:srgbClr val="3C525C"/>
             </a:solidFill>
           </a:ln>
         </p:spPr>
@@ -6436,7 +6436,7 @@
     <p:bg>
       <p:bgPr>
         <a:solidFill>
-          <a:srgbClr val="FFFFFF"/>
+          <a:srgbClr val="0E161D"/>
         </a:solidFill>
         <a:effectLst/>
       </p:bgPr>
@@ -6473,7 +6473,7 @@
             <a:pPr>
               <a:defRPr sz="2800" b="1">
                 <a:solidFill>
-                  <a:srgbClr val="182530"/>
+                  <a:srgbClr val="EBF2F4"/>
                 </a:solidFill>
                 <a:latin typeface="Aptos"/>
               </a:defRPr>
@@ -6591,7 +6591,7 @@
               </a:spcAft>
               <a:defRPr sz="2200">
                 <a:solidFill>
-                  <a:srgbClr val="182530"/>
+                  <a:srgbClr val="EBF2F4"/>
                 </a:solidFill>
                 <a:latin typeface="Aptos"/>
               </a:defRPr>
@@ -6607,7 +6607,7 @@
               </a:spcAft>
               <a:defRPr sz="2200">
                 <a:solidFill>
-                  <a:srgbClr val="182530"/>
+                  <a:srgbClr val="EBF2F4"/>
                 </a:solidFill>
                 <a:latin typeface="Aptos"/>
               </a:defRPr>
@@ -6623,7 +6623,7 @@
               </a:spcAft>
               <a:defRPr sz="2200">
                 <a:solidFill>
-                  <a:srgbClr val="182530"/>
+                  <a:srgbClr val="EBF2F4"/>
                 </a:solidFill>
                 <a:latin typeface="Aptos"/>
               </a:defRPr>
@@ -6649,11 +6649,11 @@
             <a:avLst/>
           </a:prstGeom>
           <a:solidFill>
-            <a:srgbClr val="182530"/>
+            <a:srgbClr val="080F14"/>
           </a:solidFill>
           <a:ln>
             <a:solidFill>
-              <a:srgbClr val="384852"/>
+              <a:srgbClr val="3C525C"/>
             </a:solidFill>
           </a:ln>
         </p:spPr>

</xml_diff>

<commit_message>
Add concrete data journey to demo
</commit_message>
<xml_diff>
--- a/presentation/eventhouse-schema-drift-reference.pptx
+++ b/presentation/eventhouse-schema-drift-reference.pptx
@@ -3319,7 +3319,7 @@
               </a:defRPr>
             </a:pPr>
             <a:r>
-              <a:t>Live proof: what the customer should see</a:t>
+              <a:t>A second example: two zones become rows</a:t>
             </a:r>
           </a:p>
         </p:txBody>
@@ -3437,7 +3437,7 @@
               </a:defRPr>
             </a:pPr>
             <a:r>
-              <a:t>•  Six raw messages route to three typed tables</a:t>
+              <a:t>•  One cooling-unit message contains zones 1 and 2</a:t>
             </a:r>
           </a:p>
           <a:p>
@@ -3453,7 +3453,7 @@
               </a:defRPr>
             </a:pPr>
             <a:r>
-              <a:t>•  A new controller field remains in residual JSON</a:t>
+              <a:t>•  mv-expand produces two stable child rows</a:t>
             </a:r>
           </a:p>
           <a:p>
@@ -3469,39 +3469,7 @@
               </a:defRPr>
             </a:pPr>
             <a:r>
-              <a:t>•  Drift review identifies new paths and observed types</a:t>
-            </a:r>
-          </a:p>
-          <a:p>
-            <a:pPr>
-              <a:spcAft>
-                <a:spcPts val="1800"/>
-              </a:spcAft>
-              <a:defRPr sz="2200">
-                <a:solidFill>
-                  <a:srgbClr val="EBF2F4"/>
-                </a:solidFill>
-                <a:latin typeface="Aptos"/>
-              </a:defRPr>
-            </a:pPr>
-            <a:r>
-              <a:t>•  Two zones create two child rows; an empty array creates none</a:t>
-            </a:r>
-          </a:p>
-          <a:p>
-            <a:pPr>
-              <a:spcAft>
-                <a:spcPts val="1800"/>
-              </a:spcAft>
-              <a:defRPr sz="2200">
-                <a:solidFill>
-                  <a:srgbClr val="EBF2F4"/>
-                </a:solidFill>
-                <a:latin typeface="Aptos"/>
-              </a:defRPr>
-            </a:pPr>
-            <a:r>
-              <a:t>•  An incompatible value is still recoverable from RawRecord</a:t>
+              <a:t>•  An empty zones array produces zero child rows</a:t>
             </a:r>
           </a:p>
         </p:txBody>
@@ -3514,14 +3482,14 @@
         </p:nvSpPr>
         <p:spPr>
           <a:xfrm>
-            <a:off x="7818120" y="1371600"/>
-            <a:ext cx="3749039" cy="4526280"/>
+            <a:off x="7543800" y="1417320"/>
+            <a:ext cx="4069080" cy="4389120"/>
           </a:xfrm>
           <a:prstGeom prst="rect">
             <a:avLst/>
           </a:prstGeom>
           <a:solidFill>
-            <a:srgbClr val="1B2932"/>
+            <a:srgbClr val="080F14"/>
           </a:solidFill>
           <a:ln>
             <a:solidFill>
@@ -3544,62 +3512,32 @@
           </a:fontRef>
         </p:style>
         <p:txBody>
-          <a:bodyPr rtlCol="0" anchor="ctr"/>
-          <a:lstStyle/>
-          <a:p>
-            <a:pPr algn="ctr"/>
-          </a:p>
-        </p:txBody>
-      </p:sp>
-      <p:sp>
-        <p:nvSpPr>
-          <p:cNvPr id="7" name="Rounded Rectangle 6"/>
-          <p:cNvSpPr/>
-          <p:nvPr/>
-        </p:nvSpPr>
-        <p:spPr>
-          <a:xfrm>
-            <a:off x="8366760" y="2834640"/>
-            <a:ext cx="2651760" cy="1051560"/>
-          </a:xfrm>
-          <a:prstGeom prst="roundRect">
-            <a:avLst/>
-          </a:prstGeom>
-          <a:solidFill>
-            <a:srgbClr val="008577"/>
-          </a:solidFill>
-          <a:ln>
-            <a:noFill/>
-          </a:ln>
-        </p:spPr>
-        <p:style>
-          <a:lnRef idx="1">
-            <a:schemeClr val="accent1"/>
-          </a:lnRef>
-          <a:fillRef idx="3">
-            <a:schemeClr val="accent1"/>
-          </a:fillRef>
-          <a:effectRef idx="2">
-            <a:schemeClr val="accent1"/>
-          </a:effectRef>
-          <a:fontRef idx="minor">
-            <a:schemeClr val="lt1"/>
-          </a:fontRef>
-        </p:style>
-        <p:txBody>
-          <a:bodyPr rtlCol="0" anchor="ctr"/>
+          <a:bodyPr rtlCol="0" anchor="ctr" lIns="228600" rIns="182880" tIns="228600"/>
           <a:lstStyle/>
           <a:p>
             <a:pPr algn="ctr">
-              <a:defRPr sz="2000" b="1">
-                <a:solidFill>
-                  <a:srgbClr val="FFFFFF"/>
-                </a:solidFill>
-                <a:latin typeface="Aptos Display"/>
-              </a:defRPr>
-            </a:pPr>
-            <a:r>
-              <a:t>DRIFT SURVIVES</a:t>
+              <a:defRPr sz="1400">
+                <a:solidFill>
+                  <a:srgbClr val="DCEEF1"/>
+                </a:solidFill>
+                <a:latin typeface="Cascadia Mono"/>
+              </a:defRPr>
+            </a:pPr>
+            <a:r>
+              <a:t>Device      Zone  Mode     Return  Setpoint</a:t>
+            </a:r>
+            <a:br/>
+            <a:r>
+              <a:t>cooling-01  1     cool     2.8     2.0</a:t>
+            </a:r>
+            <a:br/>
+            <a:r>
+              <a:t>cooling-01  2     defrost  5.1     4.0</a:t>
+            </a:r>
+            <a:br/>
+            <a:br/>
+            <a:r>
+              <a:t>| mv-expand Zone=Zones</a:t>
             </a:r>
           </a:p>
         </p:txBody>
@@ -3661,7 +3599,7 @@
               </a:defRPr>
             </a:pPr>
             <a:r>
-              <a:t>Governed promotion stays simple</a:t>
+              <a:t>Step 5: promote the reviewed field</a:t>
             </a:r>
           </a:p>
         </p:txBody>
@@ -3779,7 +3717,7 @@
               </a:defRPr>
             </a:pPr>
             <a:r>
-              <a:t>•  Add the approved column</a:t>
+              <a:t>•  Add ServiceCountdownHours:real</a:t>
             </a:r>
           </a:p>
           <a:p>
@@ -3795,7 +3733,7 @@
               </a:defRPr>
             </a:pPr>
             <a:r>
-              <a:t>•  Revise the stored function and residual key list</a:t>
+              <a:t>•  Revise and schema-check the stored function</a:t>
             </a:r>
           </a:p>
           <a:p>
@@ -3811,7 +3749,7 @@
               </a:defRPr>
             </a:pPr>
             <a:r>
-              <a:t>•  Compare function schema with the table</a:t>
+              <a:t>•  Replay only the approved interval</a:t>
             </a:r>
           </a:p>
           <a:p>
@@ -3827,23 +3765,7 @@
               </a:defRPr>
             </a:pPr>
             <a:r>
-              <a:t>•  Replay only the approved raw interval</a:t>
-            </a:r>
-          </a:p>
-          <a:p>
-            <a:pPr>
-              <a:spcAft>
-                <a:spcPts val="1800"/>
-              </a:spcAft>
-              <a:defRPr sz="2200">
-                <a:solidFill>
-                  <a:srgbClr val="EBF2F4"/>
-                </a:solidFill>
-                <a:latin typeface="Aptos"/>
-              </a:defRPr>
-            </a:pPr>
-            <a:r>
-              <a:t>•  Handle appended versions explicitly</a:t>
+              <a:t>•  The residual bag is now empty for this message</a:t>
             </a:r>
           </a:p>
         </p:txBody>
@@ -3898,21 +3820,29 @@
               </a:defRPr>
             </a:pPr>
             <a:r>
-              <a:t>.alter-merge table ControllerTelemetry</a:t>
+              <a:t>BEFORE</a:t>
             </a:r>
             <a:br/>
             <a:r>
-              <a:t>  (ServiceCountdownHours:real)</a:t>
+              <a:t>Residual {"serviceCountdownHours":120}</a:t>
             </a:r>
             <a:br/>
             <a:br/>
             <a:r>
-              <a:t>TransformControllerTelemetry | getschema</a:t>
+              <a:t>AFTER</a:t>
+            </a:r>
+            <a:br/>
+            <a:r>
+              <a:t>ServiceCountdownHours  120.0</a:t>
+            </a:r>
+            <a:br/>
+            <a:r>
+              <a:t>Residual               {}</a:t>
             </a:r>
             <a:br/>
             <a:br/>
             <a:r>
-              <a:t>.set-or-append ControllerTelemetry &lt;| ...</a:t>
+              <a:t>.alter-merge + .set-or-append</a:t>
             </a:r>
           </a:p>
         </p:txBody>
@@ -5272,7 +5202,7 @@
               </a:defRPr>
             </a:pPr>
             <a:r>
-              <a:t>The seven-step demo journey</a:t>
+              <a:t>Meet the message we will follow</a:t>
             </a:r>
           </a:p>
         </p:txBody>
@@ -5382,7 +5312,7 @@
               <a:spcAft>
                 <a:spcPts val="1800"/>
               </a:spcAft>
-              <a:defRPr sz="2000">
+              <a:defRPr sz="2200">
                 <a:solidFill>
                   <a:srgbClr val="EBF2F4"/>
                 </a:solidFill>
@@ -5390,7 +5320,7 @@
               </a:defRPr>
             </a:pPr>
             <a:r>
-              <a:t>•  1  Raw inbox</a:t>
+              <a:t>•  Controller 01 reports normal operating values</a:t>
             </a:r>
           </a:p>
           <a:p>
@@ -5398,7 +5328,7 @@
               <a:spcAft>
                 <a:spcPts val="1800"/>
               </a:spcAft>
-              <a:defRPr sz="2000">
+              <a:defRPr sz="2200">
                 <a:solidFill>
                   <a:srgbClr val="EBF2F4"/>
                 </a:solidFill>
@@ -5406,7 +5336,7 @@
               </a:defRPr>
             </a:pPr>
             <a:r>
-              <a:t>•  2  DropMappedFields mapping</a:t>
+              <a:t>•  The producer adds serviceCountdownHours: 120</a:t>
             </a:r>
           </a:p>
           <a:p>
@@ -5414,7 +5344,7 @@
               <a:spcAft>
                 <a:spcPts val="1800"/>
               </a:spcAft>
-              <a:defRPr sz="2000">
+              <a:defRPr sz="2200">
                 <a:solidFill>
                   <a:srgbClr val="EBF2F4"/>
                 </a:solidFill>
@@ -5422,7 +5352,7 @@
               </a:defRPr>
             </a:pPr>
             <a:r>
-              <a:t>•  3  Stable target tables</a:t>
+              <a:t>•  The target table does not have that column yet</a:t>
             </a:r>
           </a:p>
           <a:p>
@@ -5430,7 +5360,7 @@
               <a:spcAft>
                 <a:spcPts val="1800"/>
               </a:spcAft>
-              <a:defRPr sz="2000">
+              <a:defRPr sz="2200">
                 <a:solidFill>
                   <a:srgbClr val="EBF2F4"/>
                 </a:solidFill>
@@ -5438,55 +5368,7 @@
               </a:defRPr>
             </a:pPr>
             <a:r>
-              <a:t>•  4  KQL transform functions</a:t>
-            </a:r>
-          </a:p>
-          <a:p>
-            <a:pPr>
-              <a:spcAft>
-                <a:spcPts val="1800"/>
-              </a:spcAft>
-              <a:defRPr sz="2000">
-                <a:solidFill>
-                  <a:srgbClr val="EBF2F4"/>
-                </a:solidFill>
-                <a:latin typeface="Aptos"/>
-              </a:defRPr>
-            </a:pPr>
-            <a:r>
-              <a:t>•  5  Automatic policies and drift detection</a:t>
-            </a:r>
-          </a:p>
-          <a:p>
-            <a:pPr>
-              <a:spcAft>
-                <a:spcPts val="1800"/>
-              </a:spcAft>
-              <a:defRPr sz="2000">
-                <a:solidFill>
-                  <a:srgbClr val="EBF2F4"/>
-                </a:solidFill>
-                <a:latin typeface="Aptos"/>
-              </a:defRPr>
-            </a:pPr>
-            <a:r>
-              <a:t>•  6  Ingest and prove</a:t>
-            </a:r>
-          </a:p>
-          <a:p>
-            <a:pPr>
-              <a:spcAft>
-                <a:spcPts val="1800"/>
-              </a:spcAft>
-              <a:defRPr sz="2000">
-                <a:solidFill>
-                  <a:srgbClr val="EBF2F4"/>
-                </a:solidFill>
-                <a:latin typeface="Aptos"/>
-              </a:defRPr>
-            </a:pPr>
-            <a:r>
-              <a:t>•  7  Promote and backfill</a:t>
+              <a:t>•  Success means preserving 120 without breaking typed ingestion</a:t>
             </a:r>
           </a:p>
         </p:txBody>
@@ -5499,14 +5381,14 @@
         </p:nvSpPr>
         <p:spPr>
           <a:xfrm>
-            <a:off x="7818120" y="1371600"/>
-            <a:ext cx="3749039" cy="4526280"/>
+            <a:off x="7543800" y="1417320"/>
+            <a:ext cx="4069080" cy="4389120"/>
           </a:xfrm>
           <a:prstGeom prst="rect">
             <a:avLst/>
           </a:prstGeom>
           <a:solidFill>
-            <a:srgbClr val="1B2932"/>
+            <a:srgbClr val="080F14"/>
           </a:solidFill>
           <a:ln>
             <a:solidFill>
@@ -5529,62 +5411,47 @@
           </a:fontRef>
         </p:style>
         <p:txBody>
-          <a:bodyPr rtlCol="0" anchor="ctr"/>
-          <a:lstStyle/>
-          <a:p>
-            <a:pPr algn="ctr"/>
-          </a:p>
-        </p:txBody>
-      </p:sp>
-      <p:sp>
-        <p:nvSpPr>
-          <p:cNvPr id="7" name="Rounded Rectangle 6"/>
-          <p:cNvSpPr/>
-          <p:nvPr/>
-        </p:nvSpPr>
-        <p:spPr>
-          <a:xfrm>
-            <a:off x="8366760" y="2834640"/>
-            <a:ext cx="2651760" cy="1051560"/>
-          </a:xfrm>
-          <a:prstGeom prst="roundRect">
-            <a:avLst/>
-          </a:prstGeom>
-          <a:solidFill>
-            <a:srgbClr val="0078D4"/>
-          </a:solidFill>
-          <a:ln>
-            <a:noFill/>
-          </a:ln>
-        </p:spPr>
-        <p:style>
-          <a:lnRef idx="1">
-            <a:schemeClr val="accent1"/>
-          </a:lnRef>
-          <a:fillRef idx="3">
-            <a:schemeClr val="accent1"/>
-          </a:fillRef>
-          <a:effectRef idx="2">
-            <a:schemeClr val="accent1"/>
-          </a:effectRef>
-          <a:fontRef idx="minor">
-            <a:schemeClr val="lt1"/>
-          </a:fontRef>
-        </p:style>
-        <p:txBody>
-          <a:bodyPr rtlCol="0" anchor="ctr"/>
+          <a:bodyPr rtlCol="0" anchor="ctr" lIns="228600" rIns="182880" tIns="228600"/>
           <a:lstStyle/>
           <a:p>
             <a:pPr algn="ctr">
-              <a:defRPr sz="2000" b="1">
-                <a:solidFill>
-                  <a:srgbClr val="FFFFFF"/>
-                </a:solidFill>
-                <a:latin typeface="Aptos Display"/>
-              </a:defRPr>
-            </a:pPr>
-            <a:r>
-              <a:t>BUILD → PROVE → PROMOTE</a:t>
+              <a:defRPr sz="1400">
+                <a:solidFill>
+                  <a:srgbClr val="DCEEF1"/>
+                </a:solidFill>
+                <a:latin typeface="Cascadia Mono"/>
+              </a:defRPr>
+            </a:pPr>
+            <a:r>
+              <a:t>"sourceType":"controller",</a:t>
+            </a:r>
+            <a:br/>
+            <a:r>
+              <a:t>"schemaVersion":2,</a:t>
+            </a:r>
+            <a:br/>
+            <a:r>
+              <a:t>"telemetry": {</a:t>
+            </a:r>
+            <a:br/>
+            <a:r>
+              <a:t>  "controllerStatus":"running",</a:t>
+            </a:r>
+            <a:br/>
+            <a:r>
+              <a:t>  "engineHours":1251.0,</a:t>
+            </a:r>
+            <a:br/>
+            <a:r>
+              <a:t>  "fuelConsumption":8.2,</a:t>
+            </a:r>
+            <a:br/>
+            <a:r>
+              <a:t>  "serviceCountdownHours":120</a:t>
+            </a:r>
+            <a:br/>
+            <a:r>
+              <a:t>}</a:t>
             </a:r>
           </a:p>
         </p:txBody>
@@ -5646,7 +5513,7 @@
               </a:defRPr>
             </a:pPr>
             <a:r>
-              <a:t>Technique 1: preserve future fields</a:t>
+              <a:t>Step 1: raw mapping loses nothing</a:t>
             </a:r>
           </a:p>
         </p:txBody>
@@ -5764,7 +5631,7 @@
               </a:defRPr>
             </a:pPr>
             <a:r>
-              <a:t>•  Map stable envelope values to columns</a:t>
+              <a:t>•  Stable envelope values become columns</a:t>
             </a:r>
           </a:p>
           <a:p>
@@ -5780,7 +5647,7 @@
               </a:defRPr>
             </a:pPr>
             <a:r>
-              <a:t>•  Keep the rest of the JSON in RawRecord</a:t>
+              <a:t>•  DropMappedFields keeps the remaining payload</a:t>
             </a:r>
           </a:p>
           <a:p>
@@ -5796,7 +5663,7 @@
               </a:defRPr>
             </a:pPr>
             <a:r>
-              <a:t>•  A producer can add a field without changing the landing table</a:t>
+              <a:t>•  No landing-table alteration is needed</a:t>
             </a:r>
           </a:p>
         </p:txBody>
@@ -5851,15 +5718,31 @@
               </a:defRPr>
             </a:pPr>
             <a:r>
-              <a:t>{"Column":"RawRecord",</a:t>
+              <a:t>SourceType     controller</a:t>
             </a:r>
             <a:br/>
             <a:r>
-              <a:t> "Properties":{"Path":"$",</a:t>
+              <a:t>SchemaVersion  2</a:t>
             </a:r>
             <a:br/>
             <a:r>
-              <a:t> "Transform":"DropMappedFields"}}</a:t>
+              <a:t>RawRecord      {</a:t>
+            </a:r>
+            <a:br/>
+            <a:r>
+              <a:t> "payload":{"telemetry":{</a:t>
+            </a:r>
+            <a:br/>
+            <a:r>
+              <a:t>  ...,</a:t>
+            </a:r>
+            <a:br/>
+            <a:r>
+              <a:t>  "serviceCountdownHours":120</a:t>
+            </a:r>
+            <a:br/>
+            <a:r>
+              <a:t> }}}</a:t>
             </a:r>
           </a:p>
         </p:txBody>
@@ -5921,7 +5804,7 @@
               </a:defRPr>
             </a:pPr>
             <a:r>
-              <a:t>Technique 2: guarantee a fixed output</a:t>
+              <a:t>Step 2: typed row stays predictable</a:t>
             </a:r>
           </a:p>
         </p:txBody>
@@ -6039,7 +5922,7 @@
               </a:defRPr>
             </a:pPr>
             <a:r>
-              <a:t>•  Name and cast every approved field</a:t>
+              <a:t>•  Explicit casts produce the approved columns</a:t>
             </a:r>
           </a:p>
           <a:p>
@@ -6055,7 +5938,7 @@
               </a:defRPr>
             </a:pPr>
             <a:r>
-              <a:t>•  Remove known keys from the original bag</a:t>
+              <a:t>•  bag_remove_keys moves the new key to residual JSON</a:t>
             </a:r>
           </a:p>
           <a:p>
@@ -6071,7 +5954,7 @@
               </a:defRPr>
             </a:pPr>
             <a:r>
-              <a:t>•  Anything new remains in ResidualTelemetry</a:t>
+              <a:t>•  Existing consumers see the same table schema</a:t>
             </a:r>
           </a:p>
         </p:txBody>
@@ -6126,23 +6009,27 @@
               </a:defRPr>
             </a:pPr>
             <a:r>
-              <a:t>ControllerStatus=tostring(Telemetry.controllerStatus),</a:t>
+              <a:t>ControllerStatus  running</a:t>
             </a:r>
             <a:br/>
             <a:r>
-              <a:t>EngineHours=toreal(Telemetry.engineHours),</a:t>
+              <a:t>EngineHours       1251.0</a:t>
             </a:r>
             <a:br/>
             <a:r>
-              <a:t>ResidualTelemetry=bag_remove_keys(</a:t>
+              <a:t>FuelConsumption   8.2</a:t>
             </a:r>
             <a:br/>
             <a:r>
-              <a:t>  Telemetry, dynamic(['controllerStatus',</a:t>
+              <a:t>ResidualTelemetry {</a:t>
             </a:r>
             <a:br/>
             <a:r>
-              <a:t>  'engineHours', 'fuelConsumption']))</a:t>
+              <a:t> "serviceCountdownHours":120</a:t>
+            </a:r>
+            <a:br/>
+            <a:r>
+              <a:t>}</a:t>
             </a:r>
           </a:p>
         </p:txBody>
@@ -6204,7 +6091,7 @@
               </a:defRPr>
             </a:pPr>
             <a:r>
-              <a:t>Technique 3: remove the scheduled export</a:t>
+              <a:t>Step 3: policies process it automatically</a:t>
             </a:r>
           </a:p>
         </p:txBody>
@@ -6322,7 +6209,7 @@
               </a:defRPr>
             </a:pPr>
             <a:r>
-              <a:t>•  An update policy reacts when raw data arrives</a:t>
+              <a:t>•  The typed policy writes the controller row</a:t>
             </a:r>
           </a:p>
           <a:p>
@@ -6338,7 +6225,7 @@
               </a:defRPr>
             </a:pPr>
             <a:r>
-              <a:t>•  The policy calls the stored KQL function</a:t>
+              <a:t>•  The drift policy examines the same raw message</a:t>
             </a:r>
           </a:p>
           <a:p>
@@ -6354,7 +6241,7 @@
               </a:defRPr>
             </a:pPr>
             <a:r>
-              <a:t>•  IsTransactional:false keeps raw ingestion available for replay</a:t>
+              <a:t>•  No scheduled connector export or watermark is required</a:t>
             </a:r>
           </a:p>
         </p:txBody>
@@ -6418,6 +6305,15 @@
             <a:br/>
             <a:r>
               <a:t> "IsTransactional":false}</a:t>
+            </a:r>
+            <a:br/>
+            <a:br/>
+            <a:r>
+              <a:t>Raw row  →  typed row</a:t>
+            </a:r>
+            <a:br/>
+            <a:r>
+              <a:t>         →  drift evidence</a:t>
             </a:r>
           </a:p>
         </p:txBody>
@@ -6479,7 +6375,7 @@
               </a:defRPr>
             </a:pPr>
             <a:r>
-              <a:t>Technique 4: detect keys and expand arrays</a:t>
+              <a:t>Step 4: drift becomes review evidence</a:t>
             </a:r>
           </a:p>
         </p:txBody>
@@ -6597,7 +6493,7 @@
               </a:defRPr>
             </a:pPr>
             <a:r>
-              <a:t>•  bag_keys lists fields that actually arrived</a:t>
+              <a:t>•  bag_keys discovers serviceCountdownHours</a:t>
             </a:r>
           </a:p>
           <a:p>
@@ -6613,7 +6509,7 @@
               </a:defRPr>
             </a:pPr>
             <a:r>
-              <a:t>•  set_has_element compares them with the approved list</a:t>
+              <a:t>•  gettype records long and a sample value of 120</a:t>
             </a:r>
           </a:p>
           <a:p>
@@ -6629,7 +6525,7 @@
               </a:defRPr>
             </a:pPr>
             <a:r>
-              <a:t>•  mv-expand turns unknown keys or array items into rows</a:t>
+              <a:t>•  Known processing continues while the field is reviewed</a:t>
             </a:r>
           </a:p>
         </p:txBody>
@@ -6684,16 +6580,28 @@
               </a:defRPr>
             </a:pPr>
             <a:r>
-              <a:t>| mv-expand FieldName=bag_keys(Telemetry)</a:t>
+              <a:t>SourceType    controller</a:t>
             </a:r>
             <a:br/>
             <a:r>
-              <a:t>| where not(set_has_element(KnownKeys, FieldName))</a:t>
+              <a:t>FieldPath     serviceCountdownHours</a:t>
+            </a:r>
+            <a:br/>
+            <a:r>
+              <a:t>ObservedType  long</a:t>
+            </a:r>
+            <a:br/>
+            <a:r>
+              <a:t>SampleValue   120</a:t>
             </a:r>
             <a:br/>
             <a:br/>
             <a:r>
-              <a:t>| mv-expand Zone=Zones</a:t>
+              <a:t>bag_keys + mv-expand</a:t>
+            </a:r>
+            <a:br/>
+            <a:r>
+              <a:t>+ set_has_element + gettype</a:t>
             </a:r>
           </a:p>
         </p:txBody>

</xml_diff>

<commit_message>
Add drift alerting and operations dashboard
</commit_message>
<xml_diff>
--- a/presentation/eventhouse-schema-drift-reference.pptx
+++ b/presentation/eventhouse-schema-drift-reference.pptx
@@ -17,6 +17,10 @@
     <p:sldId id="265" r:id="rId16"/>
     <p:sldId id="266" r:id="rId17"/>
     <p:sldId id="267" r:id="rId18"/>
+    <p:sldId id="268" r:id="rId19"/>
+    <p:sldId id="269" r:id="rId20"/>
+    <p:sldId id="270" r:id="rId21"/>
+    <p:sldId id="271" r:id="rId22"/>
   </p:sldIdLst>
   <p:sldSz cx="12191695" cy="6858000" type="screen4x3"/>
   <p:notesSz cx="6858000" cy="9144000"/>
@@ -3904,7 +3908,7 @@
               </a:defRPr>
             </a:pPr>
             <a:r>
-              <a:t>Adopt with evidence, not promises</a:t>
+              <a:t>Alert only when action is needed</a:t>
             </a:r>
           </a:p>
         </p:txBody>
@@ -3984,6 +3988,1356 @@
             </a:pPr>
             <a:r>
               <a:t>12</a:t>
+            </a:r>
+          </a:p>
+        </p:txBody>
+      </p:sp>
+      <p:sp>
+        <p:nvSpPr>
+          <p:cNvPr id="5" name="TextBox 4"/>
+          <p:cNvSpPr txBox="1"/>
+          <p:nvPr/>
+        </p:nvSpPr>
+        <p:spPr>
+          <a:xfrm>
+            <a:off x="868680" y="1417320"/>
+            <a:ext cx="6400800" cy="4526280"/>
+          </a:xfrm>
+          <a:prstGeom prst="rect">
+            <a:avLst/>
+          </a:prstGeom>
+          <a:noFill/>
+        </p:spPr>
+        <p:txBody>
+          <a:bodyPr wrap="none">
+            <a:spAutoFit/>
+          </a:bodyPr>
+          <a:lstStyle/>
+          <a:p>
+            <a:pPr>
+              <a:spcAft>
+                <a:spcPts val="1800"/>
+              </a:spcAft>
+              <a:defRPr sz="2200">
+                <a:solidFill>
+                  <a:srgbClr val="EBF2F4"/>
+                </a:solidFill>
+                <a:latin typeface="Aptos"/>
+              </a:defRPr>
+            </a:pPr>
+            <a:r>
+              <a:t>•  Aggregate repeated observations instead of alerting per message</a:t>
+            </a:r>
+          </a:p>
+          <a:p>
+            <a:pPr>
+              <a:spcAft>
+                <a:spcPts val="1800"/>
+              </a:spcAft>
+              <a:defRPr sz="2200">
+                <a:solidFill>
+                  <a:srgbClr val="EBF2F4"/>
+                </a:solidFill>
+                <a:latin typeface="Aptos"/>
+              </a:defRPr>
+            </a:pPr>
+            <a:r>
+              <a:t>•  Example threshold: 10 observations in 15 minutes</a:t>
+            </a:r>
+          </a:p>
+          <a:p>
+            <a:pPr>
+              <a:spcAft>
+                <a:spcPts val="1800"/>
+              </a:spcAft>
+              <a:defRPr sz="2200">
+                <a:solidFill>
+                  <a:srgbClr val="EBF2F4"/>
+                </a:solidFill>
+                <a:latin typeface="Aptos"/>
+              </a:defRPr>
+            </a:pPr>
+            <a:r>
+              <a:t>•  Send field, type, sample, assets, and first/last seen</a:t>
+            </a:r>
+          </a:p>
+          <a:p>
+            <a:pPr>
+              <a:spcAft>
+                <a:spcPts val="1800"/>
+              </a:spcAft>
+              <a:defRPr sz="2200">
+                <a:solidFill>
+                  <a:srgbClr val="EBF2F4"/>
+                </a:solidFill>
+                <a:latin typeface="Aptos"/>
+              </a:defRPr>
+            </a:pPr>
+            <a:r>
+              <a:t>•  Create or update one review ticket per source and field</a:t>
+            </a:r>
+          </a:p>
+        </p:txBody>
+      </p:sp>
+      <p:sp>
+        <p:nvSpPr>
+          <p:cNvPr id="6" name="Rectangle 5"/>
+          <p:cNvSpPr/>
+          <p:nvPr/>
+        </p:nvSpPr>
+        <p:spPr>
+          <a:xfrm>
+            <a:off x="7543800" y="1417320"/>
+            <a:ext cx="4069080" cy="4389120"/>
+          </a:xfrm>
+          <a:prstGeom prst="rect">
+            <a:avLst/>
+          </a:prstGeom>
+          <a:solidFill>
+            <a:srgbClr val="080F14"/>
+          </a:solidFill>
+          <a:ln>
+            <a:solidFill>
+              <a:srgbClr val="3C525C"/>
+            </a:solidFill>
+          </a:ln>
+        </p:spPr>
+        <p:style>
+          <a:lnRef idx="1">
+            <a:schemeClr val="accent1"/>
+          </a:lnRef>
+          <a:fillRef idx="3">
+            <a:schemeClr val="accent1"/>
+          </a:fillRef>
+          <a:effectRef idx="2">
+            <a:schemeClr val="accent1"/>
+          </a:effectRef>
+          <a:fontRef idx="minor">
+            <a:schemeClr val="lt1"/>
+          </a:fontRef>
+        </p:style>
+        <p:txBody>
+          <a:bodyPr rtlCol="0" anchor="ctr" lIns="228600" rIns="182880" tIns="228600"/>
+          <a:lstStyle/>
+          <a:p>
+            <a:pPr algn="ctr">
+              <a:defRPr sz="1400">
+                <a:solidFill>
+                  <a:srgbClr val="DCEEF1"/>
+                </a:solidFill>
+                <a:latin typeface="Cascadia Mono"/>
+              </a:defRPr>
+            </a:pPr>
+            <a:r>
+              <a:t>controller</a:t>
+            </a:r>
+            <a:br/>
+            <a:r>
+              <a:t>serviceCountdownHours</a:t>
+            </a:r>
+            <a:br/>
+            <a:r>
+              <a:t>Type       long</a:t>
+            </a:r>
+            <a:br/>
+            <a:r>
+              <a:t>Sample     120</a:t>
+            </a:r>
+            <a:br/>
+            <a:r>
+              <a:t>Assets     47</a:t>
+            </a:r>
+            <a:br/>
+            <a:r>
+              <a:t>Events     8,212</a:t>
+            </a:r>
+            <a:br/>
+            <a:br/>
+            <a:r>
+              <a:t>→ Teams  → DATA-1842</a:t>
+            </a:r>
+          </a:p>
+        </p:txBody>
+      </p:sp>
+    </p:spTree>
+  </p:cSld>
+  <p:clrMapOvr>
+    <a:masterClrMapping/>
+  </p:clrMapOvr>
+</p:sld>
+</file>
+
+<file path=ppt/slides/slide13.xml><?xml version="1.0" encoding="utf-8"?>
+<p:sld xmlns:a="http://schemas.openxmlformats.org/drawingml/2006/main" xmlns:p="http://schemas.openxmlformats.org/presentationml/2006/main" xmlns:r="http://schemas.openxmlformats.org/officeDocument/2006/relationships">
+  <p:cSld>
+    <p:bg>
+      <p:bgPr>
+        <a:solidFill>
+          <a:srgbClr val="0E161D"/>
+        </a:solidFill>
+        <a:effectLst/>
+      </p:bgPr>
+    </p:bg>
+    <p:spTree>
+      <p:nvGrpSpPr>
+        <p:cNvPr id="1" name=""/>
+        <p:cNvGrpSpPr/>
+        <p:nvPr/>
+      </p:nvGrpSpPr>
+      <p:grpSpPr/>
+      <p:sp>
+        <p:nvSpPr>
+          <p:cNvPr id="2" name="TextBox 1"/>
+          <p:cNvSpPr txBox="1"/>
+          <p:nvPr/>
+        </p:nvSpPr>
+        <p:spPr>
+          <a:xfrm>
+            <a:off x="640080" y="411480"/>
+            <a:ext cx="10789920" cy="548640"/>
+          </a:xfrm>
+          <a:prstGeom prst="rect">
+            <a:avLst/>
+          </a:prstGeom>
+          <a:noFill/>
+        </p:spPr>
+        <p:txBody>
+          <a:bodyPr wrap="none">
+            <a:spAutoFit/>
+          </a:bodyPr>
+          <a:lstStyle/>
+          <a:p>
+            <a:pPr>
+              <a:defRPr sz="2800" b="1">
+                <a:solidFill>
+                  <a:srgbClr val="EBF2F4"/>
+                </a:solidFill>
+                <a:latin typeface="Aptos"/>
+              </a:defRPr>
+            </a:pPr>
+            <a:r>
+              <a:t>People make the promotion decision</a:t>
+            </a:r>
+          </a:p>
+        </p:txBody>
+      </p:sp>
+      <p:sp>
+        <p:nvSpPr>
+          <p:cNvPr id="3" name="Rectangle 2"/>
+          <p:cNvSpPr/>
+          <p:nvPr/>
+        </p:nvSpPr>
+        <p:spPr>
+          <a:xfrm>
+            <a:off x="640080" y="1060704"/>
+            <a:ext cx="1051560" cy="64008"/>
+          </a:xfrm>
+          <a:prstGeom prst="rect">
+            <a:avLst/>
+          </a:prstGeom>
+          <a:solidFill>
+            <a:srgbClr val="0078D4"/>
+          </a:solidFill>
+          <a:ln>
+            <a:noFill/>
+          </a:ln>
+        </p:spPr>
+        <p:style>
+          <a:lnRef idx="1">
+            <a:schemeClr val="accent1"/>
+          </a:lnRef>
+          <a:fillRef idx="3">
+            <a:schemeClr val="accent1"/>
+          </a:fillRef>
+          <a:effectRef idx="2">
+            <a:schemeClr val="accent1"/>
+          </a:effectRef>
+          <a:fontRef idx="minor">
+            <a:schemeClr val="lt1"/>
+          </a:fontRef>
+        </p:style>
+        <p:txBody>
+          <a:bodyPr rtlCol="0" anchor="ctr"/>
+          <a:lstStyle/>
+          <a:p>
+            <a:pPr algn="ctr"/>
+          </a:p>
+        </p:txBody>
+      </p:sp>
+      <p:sp>
+        <p:nvSpPr>
+          <p:cNvPr id="4" name="TextBox 3"/>
+          <p:cNvSpPr txBox="1"/>
+          <p:nvPr/>
+        </p:nvSpPr>
+        <p:spPr>
+          <a:xfrm>
+            <a:off x="11155680" y="457200"/>
+            <a:ext cx="457200" cy="365760"/>
+          </a:xfrm>
+          <a:prstGeom prst="rect">
+            <a:avLst/>
+          </a:prstGeom>
+          <a:noFill/>
+        </p:spPr>
+        <p:txBody>
+          <a:bodyPr wrap="none">
+            <a:spAutoFit/>
+          </a:bodyPr>
+          <a:lstStyle/>
+          <a:p>
+            <a:pPr>
+              <a:defRPr sz="1100" b="1">
+                <a:solidFill>
+                  <a:srgbClr val="0078D4"/>
+                </a:solidFill>
+                <a:latin typeface="Aptos"/>
+              </a:defRPr>
+            </a:pPr>
+            <a:r>
+              <a:t>13</a:t>
+            </a:r>
+          </a:p>
+        </p:txBody>
+      </p:sp>
+      <p:sp>
+        <p:nvSpPr>
+          <p:cNvPr id="5" name="TextBox 4"/>
+          <p:cNvSpPr txBox="1"/>
+          <p:nvPr/>
+        </p:nvSpPr>
+        <p:spPr>
+          <a:xfrm>
+            <a:off x="868680" y="1417320"/>
+            <a:ext cx="6400800" cy="4526280"/>
+          </a:xfrm>
+          <a:prstGeom prst="rect">
+            <a:avLst/>
+          </a:prstGeom>
+          <a:noFill/>
+        </p:spPr>
+        <p:txBody>
+          <a:bodyPr wrap="none">
+            <a:spAutoFit/>
+          </a:bodyPr>
+          <a:lstStyle/>
+          <a:p>
+            <a:pPr>
+              <a:spcAft>
+                <a:spcPts val="1800"/>
+              </a:spcAft>
+              <a:defRPr sz="2000">
+                <a:solidFill>
+                  <a:srgbClr val="EBF2F4"/>
+                </a:solidFill>
+                <a:latin typeface="Aptos"/>
+              </a:defRPr>
+            </a:pPr>
+            <a:r>
+              <a:t>•  Data operations confirms ingestion health</a:t>
+            </a:r>
+          </a:p>
+          <a:p>
+            <a:pPr>
+              <a:spcAft>
+                <a:spcPts val="1800"/>
+              </a:spcAft>
+              <a:defRPr sz="2000">
+                <a:solidFill>
+                  <a:srgbClr val="EBF2F4"/>
+                </a:solidFill>
+                <a:latin typeface="Aptos"/>
+              </a:defRPr>
+            </a:pPr>
+            <a:r>
+              <a:t>•  Source owner confirms the release</a:t>
+            </a:r>
+          </a:p>
+          <a:p>
+            <a:pPr>
+              <a:spcAft>
+                <a:spcPts val="1800"/>
+              </a:spcAft>
+              <a:defRPr sz="2000">
+                <a:solidFill>
+                  <a:srgbClr val="EBF2F4"/>
+                </a:solidFill>
+                <a:latin typeface="Aptos"/>
+              </a:defRPr>
+            </a:pPr>
+            <a:r>
+              <a:t>•  Domain owner defines meaning and unit</a:t>
+            </a:r>
+          </a:p>
+          <a:p>
+            <a:pPr>
+              <a:spcAft>
+                <a:spcPts val="1800"/>
+              </a:spcAft>
+              <a:defRPr sz="2000">
+                <a:solidFill>
+                  <a:srgbClr val="EBF2F4"/>
+                </a:solidFill>
+                <a:latin typeface="Aptos"/>
+              </a:defRPr>
+            </a:pPr>
+            <a:r>
+              <a:t>•  Data engineer profiles quality and usage</a:t>
+            </a:r>
+          </a:p>
+          <a:p>
+            <a:pPr>
+              <a:spcAft>
+                <a:spcPts val="1800"/>
+              </a:spcAft>
+              <a:defRPr sz="2000">
+                <a:solidFill>
+                  <a:srgbClr val="EBF2F4"/>
+                </a:solidFill>
+                <a:latin typeface="Aptos"/>
+              </a:defRPr>
+            </a:pPr>
+            <a:r>
+              <a:t>•  Platform engineer submits tested KQL</a:t>
+            </a:r>
+          </a:p>
+          <a:p>
+            <a:pPr>
+              <a:spcAft>
+                <a:spcPts val="1800"/>
+              </a:spcAft>
+              <a:defRPr sz="2000">
+                <a:solidFill>
+                  <a:srgbClr val="EBF2F4"/>
+                </a:solidFill>
+                <a:latin typeface="Aptos"/>
+              </a:defRPr>
+            </a:pPr>
+            <a:r>
+              <a:t>•  Consumer owner and approver authorize deployment</a:t>
+            </a:r>
+          </a:p>
+        </p:txBody>
+      </p:sp>
+      <p:sp>
+        <p:nvSpPr>
+          <p:cNvPr id="6" name="Rectangle 5"/>
+          <p:cNvSpPr/>
+          <p:nvPr/>
+        </p:nvSpPr>
+        <p:spPr>
+          <a:xfrm>
+            <a:off x="7818120" y="1371600"/>
+            <a:ext cx="3749039" cy="4526280"/>
+          </a:xfrm>
+          <a:prstGeom prst="rect">
+            <a:avLst/>
+          </a:prstGeom>
+          <a:solidFill>
+            <a:srgbClr val="1B2932"/>
+          </a:solidFill>
+          <a:ln>
+            <a:solidFill>
+              <a:srgbClr val="3C525C"/>
+            </a:solidFill>
+          </a:ln>
+        </p:spPr>
+        <p:style>
+          <a:lnRef idx="1">
+            <a:schemeClr val="accent1"/>
+          </a:lnRef>
+          <a:fillRef idx="3">
+            <a:schemeClr val="accent1"/>
+          </a:fillRef>
+          <a:effectRef idx="2">
+            <a:schemeClr val="accent1"/>
+          </a:effectRef>
+          <a:fontRef idx="minor">
+            <a:schemeClr val="lt1"/>
+          </a:fontRef>
+        </p:style>
+        <p:txBody>
+          <a:bodyPr rtlCol="0" anchor="ctr"/>
+          <a:lstStyle/>
+          <a:p>
+            <a:pPr algn="ctr"/>
+          </a:p>
+        </p:txBody>
+      </p:sp>
+      <p:sp>
+        <p:nvSpPr>
+          <p:cNvPr id="7" name="Rounded Rectangle 6"/>
+          <p:cNvSpPr/>
+          <p:nvPr/>
+        </p:nvSpPr>
+        <p:spPr>
+          <a:xfrm>
+            <a:off x="8366760" y="2834640"/>
+            <a:ext cx="2651760" cy="1051560"/>
+          </a:xfrm>
+          <a:prstGeom prst="roundRect">
+            <a:avLst/>
+          </a:prstGeom>
+          <a:solidFill>
+            <a:srgbClr val="E67E22"/>
+          </a:solidFill>
+          <a:ln>
+            <a:noFill/>
+          </a:ln>
+        </p:spPr>
+        <p:style>
+          <a:lnRef idx="1">
+            <a:schemeClr val="accent1"/>
+          </a:lnRef>
+          <a:fillRef idx="3">
+            <a:schemeClr val="accent1"/>
+          </a:fillRef>
+          <a:effectRef idx="2">
+            <a:schemeClr val="accent1"/>
+          </a:effectRef>
+          <a:fontRef idx="minor">
+            <a:schemeClr val="lt1"/>
+          </a:fontRef>
+        </p:style>
+        <p:txBody>
+          <a:bodyPr rtlCol="0" anchor="ctr"/>
+          <a:lstStyle/>
+          <a:p>
+            <a:pPr algn="ctr">
+              <a:defRPr sz="2000" b="1">
+                <a:solidFill>
+                  <a:srgbClr val="FFFFFF"/>
+                </a:solidFill>
+                <a:latin typeface="Aptos Display"/>
+              </a:defRPr>
+            </a:pPr>
+            <a:r>
+              <a:t>PROFILE → APPROVE</a:t>
+            </a:r>
+          </a:p>
+        </p:txBody>
+      </p:sp>
+    </p:spTree>
+  </p:cSld>
+  <p:clrMapOvr>
+    <a:masterClrMapping/>
+  </p:clrMapOvr>
+</p:sld>
+</file>
+
+<file path=ppt/slides/slide14.xml><?xml version="1.0" encoding="utf-8"?>
+<p:sld xmlns:a="http://schemas.openxmlformats.org/drawingml/2006/main" xmlns:p="http://schemas.openxmlformats.org/presentationml/2006/main" xmlns:r="http://schemas.openxmlformats.org/officeDocument/2006/relationships">
+  <p:cSld>
+    <p:bg>
+      <p:bgPr>
+        <a:solidFill>
+          <a:srgbClr val="0E161D"/>
+        </a:solidFill>
+        <a:effectLst/>
+      </p:bgPr>
+    </p:bg>
+    <p:spTree>
+      <p:nvGrpSpPr>
+        <p:cNvPr id="1" name=""/>
+        <p:cNvGrpSpPr/>
+        <p:nvPr/>
+      </p:nvGrpSpPr>
+      <p:grpSpPr/>
+      <p:sp>
+        <p:nvSpPr>
+          <p:cNvPr id="2" name="TextBox 1"/>
+          <p:cNvSpPr txBox="1"/>
+          <p:nvPr/>
+        </p:nvSpPr>
+        <p:spPr>
+          <a:xfrm>
+            <a:off x="640080" y="411480"/>
+            <a:ext cx="10789920" cy="548640"/>
+          </a:xfrm>
+          <a:prstGeom prst="rect">
+            <a:avLst/>
+          </a:prstGeom>
+          <a:noFill/>
+        </p:spPr>
+        <p:txBody>
+          <a:bodyPr wrap="none">
+            <a:spAutoFit/>
+          </a:bodyPr>
+          <a:lstStyle/>
+          <a:p>
+            <a:pPr>
+              <a:defRPr sz="2800" b="1">
+                <a:solidFill>
+                  <a:srgbClr val="EBF2F4"/>
+                </a:solidFill>
+                <a:latin typeface="Aptos"/>
+              </a:defRPr>
+            </a:pPr>
+            <a:r>
+              <a:t>The engineer sees one operational view</a:t>
+            </a:r>
+          </a:p>
+        </p:txBody>
+      </p:sp>
+      <p:sp>
+        <p:nvSpPr>
+          <p:cNvPr id="3" name="Rectangle 2"/>
+          <p:cNvSpPr/>
+          <p:nvPr/>
+        </p:nvSpPr>
+        <p:spPr>
+          <a:xfrm>
+            <a:off x="640080" y="1060704"/>
+            <a:ext cx="1051560" cy="64008"/>
+          </a:xfrm>
+          <a:prstGeom prst="rect">
+            <a:avLst/>
+          </a:prstGeom>
+          <a:solidFill>
+            <a:srgbClr val="0078D4"/>
+          </a:solidFill>
+          <a:ln>
+            <a:noFill/>
+          </a:ln>
+        </p:spPr>
+        <p:style>
+          <a:lnRef idx="1">
+            <a:schemeClr val="accent1"/>
+          </a:lnRef>
+          <a:fillRef idx="3">
+            <a:schemeClr val="accent1"/>
+          </a:fillRef>
+          <a:effectRef idx="2">
+            <a:schemeClr val="accent1"/>
+          </a:effectRef>
+          <a:fontRef idx="minor">
+            <a:schemeClr val="lt1"/>
+          </a:fontRef>
+        </p:style>
+        <p:txBody>
+          <a:bodyPr rtlCol="0" anchor="ctr"/>
+          <a:lstStyle/>
+          <a:p>
+            <a:pPr algn="ctr"/>
+          </a:p>
+        </p:txBody>
+      </p:sp>
+      <p:sp>
+        <p:nvSpPr>
+          <p:cNvPr id="4" name="TextBox 3"/>
+          <p:cNvSpPr txBox="1"/>
+          <p:nvPr/>
+        </p:nvSpPr>
+        <p:spPr>
+          <a:xfrm>
+            <a:off x="11155680" y="457200"/>
+            <a:ext cx="457200" cy="365760"/>
+          </a:xfrm>
+          <a:prstGeom prst="rect">
+            <a:avLst/>
+          </a:prstGeom>
+          <a:noFill/>
+        </p:spPr>
+        <p:txBody>
+          <a:bodyPr wrap="none">
+            <a:spAutoFit/>
+          </a:bodyPr>
+          <a:lstStyle/>
+          <a:p>
+            <a:pPr>
+              <a:defRPr sz="1100" b="1">
+                <a:solidFill>
+                  <a:srgbClr val="0078D4"/>
+                </a:solidFill>
+                <a:latin typeface="Aptos"/>
+              </a:defRPr>
+            </a:pPr>
+            <a:r>
+              <a:t>14</a:t>
+            </a:r>
+          </a:p>
+        </p:txBody>
+      </p:sp>
+      <p:sp>
+        <p:nvSpPr>
+          <p:cNvPr id="5" name="TextBox 4"/>
+          <p:cNvSpPr txBox="1"/>
+          <p:nvPr/>
+        </p:nvSpPr>
+        <p:spPr>
+          <a:xfrm>
+            <a:off x="868680" y="1417320"/>
+            <a:ext cx="6400800" cy="4526280"/>
+          </a:xfrm>
+          <a:prstGeom prst="rect">
+            <a:avLst/>
+          </a:prstGeom>
+          <a:noFill/>
+        </p:spPr>
+        <p:txBody>
+          <a:bodyPr wrap="none">
+            <a:spAutoFit/>
+          </a:bodyPr>
+          <a:lstStyle/>
+          <a:p>
+            <a:pPr>
+              <a:spcAft>
+                <a:spcPts val="1800"/>
+              </a:spcAft>
+              <a:defRPr sz="2000">
+                <a:solidFill>
+                  <a:srgbClr val="EBF2F4"/>
+                </a:solidFill>
+                <a:latin typeface="Aptos"/>
+              </a:defRPr>
+            </a:pPr>
+            <a:r>
+              <a:t>•  Ingestion rate and raw-to-target gap</a:t>
+            </a:r>
+          </a:p>
+          <a:p>
+            <a:pPr>
+              <a:spcAft>
+                <a:spcPts val="1800"/>
+              </a:spcAft>
+              <a:defRPr sz="2000">
+                <a:solidFill>
+                  <a:srgbClr val="EBF2F4"/>
+                </a:solidFill>
+                <a:latin typeface="Aptos"/>
+              </a:defRPr>
+            </a:pPr>
+            <a:r>
+              <a:t>•  New fields and drift trend</a:t>
+            </a:r>
+          </a:p>
+          <a:p>
+            <a:pPr>
+              <a:spcAft>
+                <a:spcPts val="1800"/>
+              </a:spcAft>
+              <a:defRPr sz="2000">
+                <a:solidFill>
+                  <a:srgbClr val="EBF2F4"/>
+                </a:solidFill>
+                <a:latin typeface="Aptos"/>
+              </a:defRPr>
+            </a:pPr>
+            <a:r>
+              <a:t>•  Type-conversion failures</a:t>
+            </a:r>
+          </a:p>
+          <a:p>
+            <a:pPr>
+              <a:spcAft>
+                <a:spcPts val="1800"/>
+              </a:spcAft>
+              <a:defRPr sz="2000">
+                <a:solidFill>
+                  <a:srgbClr val="EBF2F4"/>
+                </a:solidFill>
+                <a:latin typeface="Aptos"/>
+              </a:defRPr>
+            </a:pPr>
+            <a:r>
+              <a:t>•  Residual governance backlog</a:t>
+            </a:r>
+          </a:p>
+          <a:p>
+            <a:pPr>
+              <a:spcAft>
+                <a:spcPts val="1800"/>
+              </a:spcAft>
+              <a:defRPr sz="2000">
+                <a:solidFill>
+                  <a:srgbClr val="EBF2F4"/>
+                </a:solidFill>
+                <a:latin typeface="Aptos"/>
+              </a:defRPr>
+            </a:pPr>
+            <a:r>
+              <a:t>•  Array row amplification</a:t>
+            </a:r>
+          </a:p>
+          <a:p>
+            <a:pPr>
+              <a:spcAft>
+                <a:spcPts val="1800"/>
+              </a:spcAft>
+              <a:defRPr sz="2000">
+                <a:solidFill>
+                  <a:srgbClr val="EBF2F4"/>
+                </a:solidFill>
+                <a:latin typeface="Aptos"/>
+              </a:defRPr>
+            </a:pPr>
+            <a:r>
+              <a:t>•  Alert evaluation runs even when the dashboard is closed</a:t>
+            </a:r>
+          </a:p>
+        </p:txBody>
+      </p:sp>
+      <p:sp>
+        <p:nvSpPr>
+          <p:cNvPr id="6" name="Rectangle 5"/>
+          <p:cNvSpPr/>
+          <p:nvPr/>
+        </p:nvSpPr>
+        <p:spPr>
+          <a:xfrm>
+            <a:off x="7818120" y="1371600"/>
+            <a:ext cx="3749039" cy="4526280"/>
+          </a:xfrm>
+          <a:prstGeom prst="rect">
+            <a:avLst/>
+          </a:prstGeom>
+          <a:solidFill>
+            <a:srgbClr val="1B2932"/>
+          </a:solidFill>
+          <a:ln>
+            <a:solidFill>
+              <a:srgbClr val="3C525C"/>
+            </a:solidFill>
+          </a:ln>
+        </p:spPr>
+        <p:style>
+          <a:lnRef idx="1">
+            <a:schemeClr val="accent1"/>
+          </a:lnRef>
+          <a:fillRef idx="3">
+            <a:schemeClr val="accent1"/>
+          </a:fillRef>
+          <a:effectRef idx="2">
+            <a:schemeClr val="accent1"/>
+          </a:effectRef>
+          <a:fontRef idx="minor">
+            <a:schemeClr val="lt1"/>
+          </a:fontRef>
+        </p:style>
+        <p:txBody>
+          <a:bodyPr rtlCol="0" anchor="ctr"/>
+          <a:lstStyle/>
+          <a:p>
+            <a:pPr algn="ctr"/>
+          </a:p>
+        </p:txBody>
+      </p:sp>
+      <p:sp>
+        <p:nvSpPr>
+          <p:cNvPr id="7" name="Rounded Rectangle 6"/>
+          <p:cNvSpPr/>
+          <p:nvPr/>
+        </p:nvSpPr>
+        <p:spPr>
+          <a:xfrm>
+            <a:off x="8366760" y="2834640"/>
+            <a:ext cx="2651760" cy="1051560"/>
+          </a:xfrm>
+          <a:prstGeom prst="roundRect">
+            <a:avLst/>
+          </a:prstGeom>
+          <a:solidFill>
+            <a:srgbClr val="008577"/>
+          </a:solidFill>
+          <a:ln>
+            <a:noFill/>
+          </a:ln>
+        </p:spPr>
+        <p:style>
+          <a:lnRef idx="1">
+            <a:schemeClr val="accent1"/>
+          </a:lnRef>
+          <a:fillRef idx="3">
+            <a:schemeClr val="accent1"/>
+          </a:fillRef>
+          <a:effectRef idx="2">
+            <a:schemeClr val="accent1"/>
+          </a:effectRef>
+          <a:fontRef idx="minor">
+            <a:schemeClr val="lt1"/>
+          </a:fontRef>
+        </p:style>
+        <p:txBody>
+          <a:bodyPr rtlCol="0" anchor="ctr"/>
+          <a:lstStyle/>
+          <a:p>
+            <a:pPr algn="ctr">
+              <a:defRPr sz="2000" b="1">
+                <a:solidFill>
+                  <a:srgbClr val="FFFFFF"/>
+                </a:solidFill>
+                <a:latin typeface="Aptos Display"/>
+              </a:defRPr>
+            </a:pPr>
+            <a:r>
+              <a:t>OPERATIONS VIEW</a:t>
+            </a:r>
+          </a:p>
+        </p:txBody>
+      </p:sp>
+    </p:spTree>
+  </p:cSld>
+  <p:clrMapOvr>
+    <a:masterClrMapping/>
+  </p:clrMapOvr>
+</p:sld>
+</file>
+
+<file path=ppt/slides/slide15.xml><?xml version="1.0" encoding="utf-8"?>
+<p:sld xmlns:a="http://schemas.openxmlformats.org/drawingml/2006/main" xmlns:p="http://schemas.openxmlformats.org/presentationml/2006/main" xmlns:r="http://schemas.openxmlformats.org/officeDocument/2006/relationships">
+  <p:cSld>
+    <p:bg>
+      <p:bgPr>
+        <a:solidFill>
+          <a:srgbClr val="0E161D"/>
+        </a:solidFill>
+        <a:effectLst/>
+      </p:bgPr>
+    </p:bg>
+    <p:spTree>
+      <p:nvGrpSpPr>
+        <p:cNvPr id="1" name=""/>
+        <p:cNvGrpSpPr/>
+        <p:nvPr/>
+      </p:nvGrpSpPr>
+      <p:grpSpPr/>
+      <p:sp>
+        <p:nvSpPr>
+          <p:cNvPr id="2" name="TextBox 1"/>
+          <p:cNvSpPr txBox="1"/>
+          <p:nvPr/>
+        </p:nvSpPr>
+        <p:spPr>
+          <a:xfrm>
+            <a:off x="640080" y="411480"/>
+            <a:ext cx="10789920" cy="548640"/>
+          </a:xfrm>
+          <a:prstGeom prst="rect">
+            <a:avLst/>
+          </a:prstGeom>
+          <a:noFill/>
+        </p:spPr>
+        <p:txBody>
+          <a:bodyPr wrap="none">
+            <a:spAutoFit/>
+          </a:bodyPr>
+          <a:lstStyle/>
+          <a:p>
+            <a:pPr>
+              <a:defRPr sz="2800" b="1">
+                <a:solidFill>
+                  <a:srgbClr val="EBF2F4"/>
+                </a:solidFill>
+                <a:latin typeface="Aptos"/>
+              </a:defRPr>
+            </a:pPr>
+            <a:r>
+              <a:t>Review produces one of three outcomes</a:t>
+            </a:r>
+          </a:p>
+        </p:txBody>
+      </p:sp>
+      <p:sp>
+        <p:nvSpPr>
+          <p:cNvPr id="3" name="Rectangle 2"/>
+          <p:cNvSpPr/>
+          <p:nvPr/>
+        </p:nvSpPr>
+        <p:spPr>
+          <a:xfrm>
+            <a:off x="640080" y="1060704"/>
+            <a:ext cx="1051560" cy="64008"/>
+          </a:xfrm>
+          <a:prstGeom prst="rect">
+            <a:avLst/>
+          </a:prstGeom>
+          <a:solidFill>
+            <a:srgbClr val="0078D4"/>
+          </a:solidFill>
+          <a:ln>
+            <a:noFill/>
+          </a:ln>
+        </p:spPr>
+        <p:style>
+          <a:lnRef idx="1">
+            <a:schemeClr val="accent1"/>
+          </a:lnRef>
+          <a:fillRef idx="3">
+            <a:schemeClr val="accent1"/>
+          </a:fillRef>
+          <a:effectRef idx="2">
+            <a:schemeClr val="accent1"/>
+          </a:effectRef>
+          <a:fontRef idx="minor">
+            <a:schemeClr val="lt1"/>
+          </a:fontRef>
+        </p:style>
+        <p:txBody>
+          <a:bodyPr rtlCol="0" anchor="ctr"/>
+          <a:lstStyle/>
+          <a:p>
+            <a:pPr algn="ctr"/>
+          </a:p>
+        </p:txBody>
+      </p:sp>
+      <p:sp>
+        <p:nvSpPr>
+          <p:cNvPr id="4" name="TextBox 3"/>
+          <p:cNvSpPr txBox="1"/>
+          <p:nvPr/>
+        </p:nvSpPr>
+        <p:spPr>
+          <a:xfrm>
+            <a:off x="11155680" y="457200"/>
+            <a:ext cx="457200" cy="365760"/>
+          </a:xfrm>
+          <a:prstGeom prst="rect">
+            <a:avLst/>
+          </a:prstGeom>
+          <a:noFill/>
+        </p:spPr>
+        <p:txBody>
+          <a:bodyPr wrap="none">
+            <a:spAutoFit/>
+          </a:bodyPr>
+          <a:lstStyle/>
+          <a:p>
+            <a:pPr>
+              <a:defRPr sz="1100" b="1">
+                <a:solidFill>
+                  <a:srgbClr val="0078D4"/>
+                </a:solidFill>
+                <a:latin typeface="Aptos"/>
+              </a:defRPr>
+            </a:pPr>
+            <a:r>
+              <a:t>15</a:t>
+            </a:r>
+          </a:p>
+        </p:txBody>
+      </p:sp>
+      <p:sp>
+        <p:nvSpPr>
+          <p:cNvPr id="5" name="TextBox 4"/>
+          <p:cNvSpPr txBox="1"/>
+          <p:nvPr/>
+        </p:nvSpPr>
+        <p:spPr>
+          <a:xfrm>
+            <a:off x="868680" y="1417320"/>
+            <a:ext cx="6400800" cy="4526280"/>
+          </a:xfrm>
+          <a:prstGeom prst="rect">
+            <a:avLst/>
+          </a:prstGeom>
+          <a:noFill/>
+        </p:spPr>
+        <p:txBody>
+          <a:bodyPr wrap="none">
+            <a:spAutoFit/>
+          </a:bodyPr>
+          <a:lstStyle/>
+          <a:p>
+            <a:pPr>
+              <a:spcAft>
+                <a:spcPts val="1800"/>
+              </a:spcAft>
+              <a:defRPr sz="2200">
+                <a:solidFill>
+                  <a:srgbClr val="EBF2F4"/>
+                </a:solidFill>
+                <a:latin typeface="Aptos"/>
+              </a:defRPr>
+            </a:pPr>
+            <a:r>
+              <a:t>•  Promote: PR, approvals, deploy, monitor, bounded backfill</a:t>
+            </a:r>
+          </a:p>
+          <a:p>
+            <a:pPr>
+              <a:spcAft>
+                <a:spcPts val="1800"/>
+              </a:spcAft>
+              <a:defRPr sz="2200">
+                <a:solidFill>
+                  <a:srgbClr val="EBF2F4"/>
+                </a:solidFill>
+                <a:latin typeface="Aptos"/>
+              </a:defRPr>
+            </a:pPr>
+            <a:r>
+              <a:t>•  Keep dynamic: record rationale and suppress duplicate tickets</a:t>
+            </a:r>
+          </a:p>
+          <a:p>
+            <a:pPr>
+              <a:spcAft>
+                <a:spcPts val="1800"/>
+              </a:spcAft>
+              <a:defRPr sz="2200">
+                <a:solidFill>
+                  <a:srgbClr val="EBF2F4"/>
+                </a:solidFill>
+                <a:latin typeface="Aptos"/>
+              </a:defRPr>
+            </a:pPr>
+            <a:r>
+              <a:t>•  Reject: quarantine or ask the producer to fix its contract</a:t>
+            </a:r>
+          </a:p>
+          <a:p>
+            <a:pPr>
+              <a:spcAft>
+                <a:spcPts val="1800"/>
+              </a:spcAft>
+              <a:defRPr sz="2200">
+                <a:solidFill>
+                  <a:srgbClr val="EBF2F4"/>
+                </a:solidFill>
+                <a:latin typeface="Aptos"/>
+              </a:defRPr>
+            </a:pPr>
+            <a:r>
+              <a:t>•  Never let drift detection alter production schemas automatically</a:t>
+            </a:r>
+          </a:p>
+        </p:txBody>
+      </p:sp>
+      <p:sp>
+        <p:nvSpPr>
+          <p:cNvPr id="6" name="Rectangle 5"/>
+          <p:cNvSpPr/>
+          <p:nvPr/>
+        </p:nvSpPr>
+        <p:spPr>
+          <a:xfrm>
+            <a:off x="7818120" y="1371600"/>
+            <a:ext cx="3749039" cy="4526280"/>
+          </a:xfrm>
+          <a:prstGeom prst="rect">
+            <a:avLst/>
+          </a:prstGeom>
+          <a:solidFill>
+            <a:srgbClr val="1B2932"/>
+          </a:solidFill>
+          <a:ln>
+            <a:solidFill>
+              <a:srgbClr val="3C525C"/>
+            </a:solidFill>
+          </a:ln>
+        </p:spPr>
+        <p:style>
+          <a:lnRef idx="1">
+            <a:schemeClr val="accent1"/>
+          </a:lnRef>
+          <a:fillRef idx="3">
+            <a:schemeClr val="accent1"/>
+          </a:fillRef>
+          <a:effectRef idx="2">
+            <a:schemeClr val="accent1"/>
+          </a:effectRef>
+          <a:fontRef idx="minor">
+            <a:schemeClr val="lt1"/>
+          </a:fontRef>
+        </p:style>
+        <p:txBody>
+          <a:bodyPr rtlCol="0" anchor="ctr"/>
+          <a:lstStyle/>
+          <a:p>
+            <a:pPr algn="ctr"/>
+          </a:p>
+        </p:txBody>
+      </p:sp>
+      <p:sp>
+        <p:nvSpPr>
+          <p:cNvPr id="7" name="Rounded Rectangle 6"/>
+          <p:cNvSpPr/>
+          <p:nvPr/>
+        </p:nvSpPr>
+        <p:spPr>
+          <a:xfrm>
+            <a:off x="8366760" y="2834640"/>
+            <a:ext cx="2651760" cy="1051560"/>
+          </a:xfrm>
+          <a:prstGeom prst="roundRect">
+            <a:avLst/>
+          </a:prstGeom>
+          <a:solidFill>
+            <a:srgbClr val="0078D4"/>
+          </a:solidFill>
+          <a:ln>
+            <a:noFill/>
+          </a:ln>
+        </p:spPr>
+        <p:style>
+          <a:lnRef idx="1">
+            <a:schemeClr val="accent1"/>
+          </a:lnRef>
+          <a:fillRef idx="3">
+            <a:schemeClr val="accent1"/>
+          </a:fillRef>
+          <a:effectRef idx="2">
+            <a:schemeClr val="accent1"/>
+          </a:effectRef>
+          <a:fontRef idx="minor">
+            <a:schemeClr val="lt1"/>
+          </a:fontRef>
+        </p:style>
+        <p:txBody>
+          <a:bodyPr rtlCol="0" anchor="ctr"/>
+          <a:lstStyle/>
+          <a:p>
+            <a:pPr algn="ctr">
+              <a:defRPr sz="2000" b="1">
+                <a:solidFill>
+                  <a:srgbClr val="FFFFFF"/>
+                </a:solidFill>
+                <a:latin typeface="Aptos Display"/>
+              </a:defRPr>
+            </a:pPr>
+            <a:r>
+              <a:t>3 DECISIONS</a:t>
+            </a:r>
+          </a:p>
+        </p:txBody>
+      </p:sp>
+    </p:spTree>
+  </p:cSld>
+  <p:clrMapOvr>
+    <a:masterClrMapping/>
+  </p:clrMapOvr>
+</p:sld>
+</file>
+
+<file path=ppt/slides/slide16.xml><?xml version="1.0" encoding="utf-8"?>
+<p:sld xmlns:a="http://schemas.openxmlformats.org/drawingml/2006/main" xmlns:p="http://schemas.openxmlformats.org/presentationml/2006/main" xmlns:r="http://schemas.openxmlformats.org/officeDocument/2006/relationships">
+  <p:cSld>
+    <p:bg>
+      <p:bgPr>
+        <a:solidFill>
+          <a:srgbClr val="0E161D"/>
+        </a:solidFill>
+        <a:effectLst/>
+      </p:bgPr>
+    </p:bg>
+    <p:spTree>
+      <p:nvGrpSpPr>
+        <p:cNvPr id="1" name=""/>
+        <p:cNvGrpSpPr/>
+        <p:nvPr/>
+      </p:nvGrpSpPr>
+      <p:grpSpPr/>
+      <p:sp>
+        <p:nvSpPr>
+          <p:cNvPr id="2" name="TextBox 1"/>
+          <p:cNvSpPr txBox="1"/>
+          <p:nvPr/>
+        </p:nvSpPr>
+        <p:spPr>
+          <a:xfrm>
+            <a:off x="640080" y="411480"/>
+            <a:ext cx="10789920" cy="548640"/>
+          </a:xfrm>
+          <a:prstGeom prst="rect">
+            <a:avLst/>
+          </a:prstGeom>
+          <a:noFill/>
+        </p:spPr>
+        <p:txBody>
+          <a:bodyPr wrap="none">
+            <a:spAutoFit/>
+          </a:bodyPr>
+          <a:lstStyle/>
+          <a:p>
+            <a:pPr>
+              <a:defRPr sz="2800" b="1">
+                <a:solidFill>
+                  <a:srgbClr val="EBF2F4"/>
+                </a:solidFill>
+                <a:latin typeface="Aptos"/>
+              </a:defRPr>
+            </a:pPr>
+            <a:r>
+              <a:t>Adopt with evidence, not promises</a:t>
+            </a:r>
+          </a:p>
+        </p:txBody>
+      </p:sp>
+      <p:sp>
+        <p:nvSpPr>
+          <p:cNvPr id="3" name="Rectangle 2"/>
+          <p:cNvSpPr/>
+          <p:nvPr/>
+        </p:nvSpPr>
+        <p:spPr>
+          <a:xfrm>
+            <a:off x="640080" y="1060704"/>
+            <a:ext cx="1051560" cy="64008"/>
+          </a:xfrm>
+          <a:prstGeom prst="rect">
+            <a:avLst/>
+          </a:prstGeom>
+          <a:solidFill>
+            <a:srgbClr val="0078D4"/>
+          </a:solidFill>
+          <a:ln>
+            <a:noFill/>
+          </a:ln>
+        </p:spPr>
+        <p:style>
+          <a:lnRef idx="1">
+            <a:schemeClr val="accent1"/>
+          </a:lnRef>
+          <a:fillRef idx="3">
+            <a:schemeClr val="accent1"/>
+          </a:fillRef>
+          <a:effectRef idx="2">
+            <a:schemeClr val="accent1"/>
+          </a:effectRef>
+          <a:fontRef idx="minor">
+            <a:schemeClr val="lt1"/>
+          </a:fontRef>
+        </p:style>
+        <p:txBody>
+          <a:bodyPr rtlCol="0" anchor="ctr"/>
+          <a:lstStyle/>
+          <a:p>
+            <a:pPr algn="ctr"/>
+          </a:p>
+        </p:txBody>
+      </p:sp>
+      <p:sp>
+        <p:nvSpPr>
+          <p:cNvPr id="4" name="TextBox 3"/>
+          <p:cNvSpPr txBox="1"/>
+          <p:nvPr/>
+        </p:nvSpPr>
+        <p:spPr>
+          <a:xfrm>
+            <a:off x="11155680" y="457200"/>
+            <a:ext cx="457200" cy="365760"/>
+          </a:xfrm>
+          <a:prstGeom prst="rect">
+            <a:avLst/>
+          </a:prstGeom>
+          <a:noFill/>
+        </p:spPr>
+        <p:txBody>
+          <a:bodyPr wrap="none">
+            <a:spAutoFit/>
+          </a:bodyPr>
+          <a:lstStyle/>
+          <a:p>
+            <a:pPr>
+              <a:defRPr sz="1100" b="1">
+                <a:solidFill>
+                  <a:srgbClr val="0078D4"/>
+                </a:solidFill>
+                <a:latin typeface="Aptos"/>
+              </a:defRPr>
+            </a:pPr>
+            <a:r>
+              <a:t>16</a:t>
             </a:r>
           </a:p>
         </p:txBody>

</xml_diff>

<commit_message>
Rewrite demo materials in a natural voice
</commit_message>
<xml_diff>
--- a/presentation/eventhouse-schema-drift-reference.pptx
+++ b/presentation/eventhouse-schema-drift-reference.pptx
@@ -3185,7 +3185,7 @@
               </a:defRPr>
             </a:pPr>
             <a:r>
-              <a:t>Move schema drift from Spark to Eventhouse</a:t>
+              <a:t>Handling schema drift in Eventhouse</a:t>
             </a:r>
           </a:p>
         </p:txBody>
@@ -3221,11 +3221,11 @@
               </a:defRPr>
             </a:pPr>
             <a:r>
-              <a:t>A step-by-step customer demo</a:t>
+              <a:t>A practical alternative to exporting every telemetry batch to Spark</a:t>
             </a:r>
             <a:br/>
             <a:r>
-              <a:t>Prove stable schemas, preserved drift, and governed promotion</a:t>
+              <a:t>Raw messages stay available; reporting tables stay stable</a:t>
             </a:r>
           </a:p>
         </p:txBody>
@@ -3323,7 +3323,7 @@
               </a:defRPr>
             </a:pPr>
             <a:r>
-              <a:t>A second example: two zones become rows</a:t>
+              <a:t>Arrays are handled as rows</a:t>
             </a:r>
           </a:p>
         </p:txBody>
@@ -3441,7 +3441,7 @@
               </a:defRPr>
             </a:pPr>
             <a:r>
-              <a:t>•  One cooling-unit message contains zones 1 and 2</a:t>
+              <a:t>•  This cooling-unit message has two zones</a:t>
             </a:r>
           </a:p>
           <a:p>
@@ -3457,7 +3457,7 @@
               </a:defRPr>
             </a:pPr>
             <a:r>
-              <a:t>•  mv-expand produces two stable child rows</a:t>
+              <a:t>•  mv-expand writes two child rows and keeps the zone IDs</a:t>
             </a:r>
           </a:p>
           <a:p>
@@ -3473,7 +3473,7 @@
               </a:defRPr>
             </a:pPr>
             <a:r>
-              <a:t>•  An empty zones array produces zero child rows</a:t>
+              <a:t>•  A message with an empty zones array writes no child rows</a:t>
             </a:r>
           </a:p>
         </p:txBody>
@@ -3603,7 +3603,7 @@
               </a:defRPr>
             </a:pPr>
             <a:r>
-              <a:t>Step 5: promote the reviewed field</a:t>
+              <a:t>Promotion is a normal code change</a:t>
             </a:r>
           </a:p>
         </p:txBody>
@@ -3721,7 +3721,7 @@
               </a:defRPr>
             </a:pPr>
             <a:r>
-              <a:t>•  Add ServiceCountdownHours:real</a:t>
+              <a:t>•  The team agrees the name, meaning, unit, and type</a:t>
             </a:r>
           </a:p>
           <a:p>
@@ -3737,7 +3737,7 @@
               </a:defRPr>
             </a:pPr>
             <a:r>
-              <a:t>•  Revise and schema-check the stored function</a:t>
+              <a:t>•  The PR adds the column and updates the stored function</a:t>
             </a:r>
           </a:p>
           <a:p>
@@ -3753,23 +3753,7 @@
               </a:defRPr>
             </a:pPr>
             <a:r>
-              <a:t>•  Replay only the approved interval</a:t>
-            </a:r>
-          </a:p>
-          <a:p>
-            <a:pPr>
-              <a:spcAft>
-                <a:spcPts val="1800"/>
-              </a:spcAft>
-              <a:defRPr sz="2200">
-                <a:solidFill>
-                  <a:srgbClr val="EBF2F4"/>
-                </a:solidFill>
-                <a:latin typeface="Aptos"/>
-              </a:defRPr>
-            </a:pPr>
-            <a:r>
-              <a:t>•  The residual bag is now empty for this message</a:t>
+              <a:t>•  After a schema check, only the agreed history is replayed</a:t>
             </a:r>
           </a:p>
         </p:txBody>
@@ -3908,7 +3892,7 @@
               </a:defRPr>
             </a:pPr>
             <a:r>
-              <a:t>Alert only when action is needed</a:t>
+              <a:t>An alert starts the conversation</a:t>
             </a:r>
           </a:p>
         </p:txBody>
@@ -4026,7 +4010,7 @@
               </a:defRPr>
             </a:pPr>
             <a:r>
-              <a:t>•  Aggregate repeated observations instead of alerting per message</a:t>
+              <a:t>•  Do not alert for every message; aggregate first</a:t>
             </a:r>
           </a:p>
           <a:p>
@@ -4042,7 +4026,7 @@
               </a:defRPr>
             </a:pPr>
             <a:r>
-              <a:t>•  Example threshold: 10 observations in 15 minutes</a:t>
+              <a:t>•  Here, 10 observations in 15 minutes is enough to open a ticket</a:t>
             </a:r>
           </a:p>
           <a:p>
@@ -4058,23 +4042,7 @@
               </a:defRPr>
             </a:pPr>
             <a:r>
-              <a:t>•  Send field, type, sample, assets, and first/last seen</a:t>
-            </a:r>
-          </a:p>
-          <a:p>
-            <a:pPr>
-              <a:spcAft>
-                <a:spcPts val="1800"/>
-              </a:spcAft>
-              <a:defRPr sz="2200">
-                <a:solidFill>
-                  <a:srgbClr val="EBF2F4"/>
-                </a:solidFill>
-                <a:latin typeface="Aptos"/>
-              </a:defRPr>
-            </a:pPr>
-            <a:r>
-              <a:t>•  Create or update one review ticket per source and field</a:t>
+              <a:t>•  The ticket carries the type, sample, asset count, and time range</a:t>
             </a:r>
           </a:p>
         </p:txBody>
@@ -4216,7 +4184,7 @@
               </a:defRPr>
             </a:pPr>
             <a:r>
-              <a:t>People make the promotion decision</a:t>
+              <a:t>Who looks at the ticket?</a:t>
             </a:r>
           </a:p>
         </p:txBody>
@@ -4326,7 +4294,7 @@
               <a:spcAft>
                 <a:spcPts val="1800"/>
               </a:spcAft>
-              <a:defRPr sz="2000">
+              <a:defRPr sz="2200">
                 <a:solidFill>
                   <a:srgbClr val="EBF2F4"/>
                 </a:solidFill>
@@ -4334,7 +4302,7 @@
               </a:defRPr>
             </a:pPr>
             <a:r>
-              <a:t>•  Data operations confirms ingestion health</a:t>
+              <a:t>•  Operations checks that ingestion is healthy</a:t>
             </a:r>
           </a:p>
           <a:p>
@@ -4342,7 +4310,7 @@
               <a:spcAft>
                 <a:spcPts val="1800"/>
               </a:spcAft>
-              <a:defRPr sz="2000">
+              <a:defRPr sz="2200">
                 <a:solidFill>
                   <a:srgbClr val="EBF2F4"/>
                 </a:solidFill>
@@ -4350,7 +4318,7 @@
               </a:defRPr>
             </a:pPr>
             <a:r>
-              <a:t>•  Source owner confirms the release</a:t>
+              <a:t>•  The source owner confirms the firmware change</a:t>
             </a:r>
           </a:p>
           <a:p>
@@ -4358,7 +4326,7 @@
               <a:spcAft>
                 <a:spcPts val="1800"/>
               </a:spcAft>
-              <a:defRPr sz="2000">
+              <a:defRPr sz="2200">
                 <a:solidFill>
                   <a:srgbClr val="EBF2F4"/>
                 </a:solidFill>
@@ -4366,7 +4334,7 @@
               </a:defRPr>
             </a:pPr>
             <a:r>
-              <a:t>•  Domain owner defines meaning and unit</a:t>
+              <a:t>•  The domain owner explains what the field means</a:t>
             </a:r>
           </a:p>
           <a:p>
@@ -4374,7 +4342,7 @@
               <a:spcAft>
                 <a:spcPts val="1800"/>
               </a:spcAft>
-              <a:defRPr sz="2000">
+              <a:defRPr sz="2200">
                 <a:solidFill>
                   <a:srgbClr val="EBF2F4"/>
                 </a:solidFill>
@@ -4382,7 +4350,7 @@
               </a:defRPr>
             </a:pPr>
             <a:r>
-              <a:t>•  Data engineer profiles quality and usage</a:t>
+              <a:t>•  Engineering profiles the data and prepares the change</a:t>
             </a:r>
           </a:p>
           <a:p>
@@ -4390,7 +4358,7 @@
               <a:spcAft>
                 <a:spcPts val="1800"/>
               </a:spcAft>
-              <a:defRPr sz="2000">
+              <a:defRPr sz="2200">
                 <a:solidFill>
                   <a:srgbClr val="EBF2F4"/>
                 </a:solidFill>
@@ -4398,23 +4366,7 @@
               </a:defRPr>
             </a:pPr>
             <a:r>
-              <a:t>•  Platform engineer submits tested KQL</a:t>
-            </a:r>
-          </a:p>
-          <a:p>
-            <a:pPr>
-              <a:spcAft>
-                <a:spcPts val="1800"/>
-              </a:spcAft>
-              <a:defRPr sz="2000">
-                <a:solidFill>
-                  <a:srgbClr val="EBF2F4"/>
-                </a:solidFill>
-                <a:latin typeface="Aptos"/>
-              </a:defRPr>
-            </a:pPr>
-            <a:r>
-              <a:t>•  Consumer owner and approver authorize deployment</a:t>
+              <a:t>•  Consumer and change owners sign off before deployment</a:t>
             </a:r>
           </a:p>
         </p:txBody>
@@ -4574,7 +4526,7 @@
               </a:defRPr>
             </a:pPr>
             <a:r>
-              <a:t>The engineer sees one operational view</a:t>
+              <a:t>What the on-call engineer sees</a:t>
             </a:r>
           </a:p>
         </p:txBody>
@@ -4684,7 +4636,7 @@
               <a:spcAft>
                 <a:spcPts val="1800"/>
               </a:spcAft>
-              <a:defRPr sz="2000">
+              <a:defRPr sz="2200">
                 <a:solidFill>
                   <a:srgbClr val="EBF2F4"/>
                 </a:solidFill>
@@ -4692,7 +4644,7 @@
               </a:defRPr>
             </a:pPr>
             <a:r>
-              <a:t>•  Ingestion rate and raw-to-target gap</a:t>
+              <a:t>•  Is data arriving, and are typed tables keeping up?</a:t>
             </a:r>
           </a:p>
           <a:p>
@@ -4700,7 +4652,7 @@
               <a:spcAft>
                 <a:spcPts val="1800"/>
               </a:spcAft>
-              <a:defRPr sz="2000">
+              <a:defRPr sz="2200">
                 <a:solidFill>
                   <a:srgbClr val="EBF2F4"/>
                 </a:solidFill>
@@ -4708,7 +4660,7 @@
               </a:defRPr>
             </a:pPr>
             <a:r>
-              <a:t>•  New fields and drift trend</a:t>
+              <a:t>•  Which new fields appeared after the latest release?</a:t>
             </a:r>
           </a:p>
           <a:p>
@@ -4716,7 +4668,7 @@
               <a:spcAft>
                 <a:spcPts val="1800"/>
               </a:spcAft>
-              <a:defRPr sz="2000">
+              <a:defRPr sz="2200">
                 <a:solidFill>
                   <a:srgbClr val="EBF2F4"/>
                 </a:solidFill>
@@ -4724,7 +4676,7 @@
               </a:defRPr>
             </a:pPr>
             <a:r>
-              <a:t>•  Type-conversion failures</a:t>
+              <a:t>•  Are known fields failing type conversion?</a:t>
             </a:r>
           </a:p>
           <a:p>
@@ -4732,7 +4684,7 @@
               <a:spcAft>
                 <a:spcPts val="1800"/>
               </a:spcAft>
-              <a:defRPr sz="2000">
+              <a:defRPr sz="2200">
                 <a:solidFill>
                   <a:srgbClr val="EBF2F4"/>
                 </a:solidFill>
@@ -4740,7 +4692,7 @@
               </a:defRPr>
             </a:pPr>
             <a:r>
-              <a:t>•  Residual governance backlog</a:t>
+              <a:t>•  How large is the residual backlog?</a:t>
             </a:r>
           </a:p>
           <a:p>
@@ -4748,7 +4700,7 @@
               <a:spcAft>
                 <a:spcPts val="1800"/>
               </a:spcAft>
-              <a:defRPr sz="2000">
+              <a:defRPr sz="2200">
                 <a:solidFill>
                   <a:srgbClr val="EBF2F4"/>
                 </a:solidFill>
@@ -4756,23 +4708,7 @@
               </a:defRPr>
             </a:pPr>
             <a:r>
-              <a:t>•  Array row amplification</a:t>
-            </a:r>
-          </a:p>
-          <a:p>
-            <a:pPr>
-              <a:spcAft>
-                <a:spcPts val="1800"/>
-              </a:spcAft>
-              <a:defRPr sz="2000">
-                <a:solidFill>
-                  <a:srgbClr val="EBF2F4"/>
-                </a:solidFill>
-                <a:latin typeface="Aptos"/>
-              </a:defRPr>
-            </a:pPr>
-            <a:r>
-              <a:t>•  Alert evaluation runs even when the dashboard is closed</a:t>
+              <a:t>•  Are arrays producing an unexpected number of rows?</a:t>
             </a:r>
           </a:p>
         </p:txBody>
@@ -4932,7 +4868,7 @@
               </a:defRPr>
             </a:pPr>
             <a:r>
-              <a:t>Review produces one of three outcomes</a:t>
+              <a:t>Not every field becomes a column</a:t>
             </a:r>
           </a:p>
         </p:txBody>
@@ -5050,7 +4986,7 @@
               </a:defRPr>
             </a:pPr>
             <a:r>
-              <a:t>•  Promote: PR, approvals, deploy, monitor, bounded backfill</a:t>
+              <a:t>•  Promote it when the meaning is stable and consumers need it</a:t>
             </a:r>
           </a:p>
           <a:p>
@@ -5066,7 +5002,7 @@
               </a:defRPr>
             </a:pPr>
             <a:r>
-              <a:t>•  Keep dynamic: record rationale and suppress duplicate tickets</a:t>
+              <a:t>•  Keep it in residual JSON when it is sparse or diagnostic</a:t>
             </a:r>
           </a:p>
           <a:p>
@@ -5082,7 +5018,7 @@
               </a:defRPr>
             </a:pPr>
             <a:r>
-              <a:t>•  Reject: quarantine or ask the producer to fix its contract</a:t>
+              <a:t>•  Reject or quarantine accidental, malformed, or sensitive data</a:t>
             </a:r>
           </a:p>
           <a:p>
@@ -5098,7 +5034,7 @@
               </a:defRPr>
             </a:pPr>
             <a:r>
-              <a:t>•  Never let drift detection alter production schemas automatically</a:t>
+              <a:t>•  Record the decision so the same ticket does not return tomorrow</a:t>
             </a:r>
           </a:p>
         </p:txBody>
@@ -5258,7 +5194,7 @@
               </a:defRPr>
             </a:pPr>
             <a:r>
-              <a:t>Adopt with evidence, not promises</a:t>
+              <a:t>A sensible way to start</a:t>
             </a:r>
           </a:p>
         </p:txBody>
@@ -5376,7 +5312,7 @@
               </a:defRPr>
             </a:pPr>
             <a:r>
-              <a:t>•  Shadow one source type first</a:t>
+              <a:t>•  Shadow one source type before changing the current path</a:t>
             </a:r>
           </a:p>
           <a:p>
@@ -5392,7 +5328,7 @@
               </a:defRPr>
             </a:pPr>
             <a:r>
-              <a:t>•  Benchmark policy CPU, ingestion latency, and array amplification</a:t>
+              <a:t>•  Measure ingestion cost, latency, array growth, and completeness</a:t>
             </a:r>
           </a:p>
           <a:p>
@@ -5408,7 +5344,7 @@
               </a:defRPr>
             </a:pPr>
             <a:r>
-              <a:t>•  Validate failure monitoring and bounded replay</a:t>
+              <a:t>•  Exercise failure and replay while the blast radius is small</a:t>
             </a:r>
           </a:p>
           <a:p>
@@ -5424,23 +5360,7 @@
               </a:defRPr>
             </a:pPr>
             <a:r>
-              <a:t>•  Measure duplicate arrivals before choosing a lookback</a:t>
-            </a:r>
-          </a:p>
-          <a:p>
-            <a:pPr>
-              <a:spcAft>
-                <a:spcPts val="1800"/>
-              </a:spcAft>
-              <a:defRPr sz="2200">
-                <a:solidFill>
-                  <a:srgbClr val="EBF2F4"/>
-                </a:solidFill>
-                <a:latin typeface="Aptos"/>
-              </a:defRPr>
-            </a:pPr>
-            <a:r>
-              <a:t>•  Retire Spark bulk reads only after completeness gates pass</a:t>
+              <a:t>•  Remove the Spark reads only after the numbers and outputs agree</a:t>
             </a:r>
           </a:p>
         </p:txBody>
@@ -5600,7 +5520,7 @@
               </a:defRPr>
             </a:pPr>
             <a:r>
-              <a:t>Start with today's Spark journey</a:t>
+              <a:t>Where we started</a:t>
             </a:r>
           </a:p>
         </p:txBody>
@@ -5718,7 +5638,7 @@
               </a:defRPr>
             </a:pPr>
             <a:r>
-              <a:t>•  Telemetry lands in Eventhouse</a:t>
+              <a:t>•  Telemetry lands in Eventhouse, then a notebook reads it back out</a:t>
             </a:r>
           </a:p>
           <a:p>
@@ -5734,7 +5654,7 @@
               </a:defRPr>
             </a:pPr>
             <a:r>
-              <a:t>•  A notebook exports the batch through the Kusto connector</a:t>
+              <a:t>•  Spark infers and flattens the JSON before writing Delta</a:t>
             </a:r>
           </a:p>
           <a:p>
@@ -5750,23 +5670,7 @@
               </a:defRPr>
             </a:pPr>
             <a:r>
-              <a:t>•  Spark infers JSON, flattens, compares schemas, and manages buffers</a:t>
-            </a:r>
-          </a:p>
-          <a:p>
-            <a:pPr>
-              <a:spcAft>
-                <a:spcPts val="1800"/>
-              </a:spcAft>
-              <a:defRPr sz="2200">
-                <a:solidFill>
-                  <a:srgbClr val="EBF2F4"/>
-                </a:solidFill>
-                <a:latin typeface="Aptos"/>
-              </a:defRPr>
-            </a:pPr>
-            <a:r>
-              <a:t>•  Delta writes require watermarks and merge orchestration</a:t>
+              <a:t>•  Watermarks, drift buffers, and merge jobs keep the batches coordinated</a:t>
             </a:r>
           </a:p>
         </p:txBody>
@@ -5926,7 +5830,7 @@
               </a:defRPr>
             </a:pPr>
             <a:r>
-              <a:t>Why the current loop is less efficient</a:t>
+              <a:t>The extra work adds up</a:t>
             </a:r>
           </a:p>
         </p:txBody>
@@ -6044,7 +5948,7 @@
               </a:defRPr>
             </a:pPr>
             <a:r>
-              <a:t>•  Routine processing moves data out of its serving engine</a:t>
+              <a:t>•  Each run starts Spark and exports another batch</a:t>
             </a:r>
           </a:p>
           <a:p>
@@ -6060,7 +5964,7 @@
               </a:defRPr>
             </a:pPr>
             <a:r>
-              <a:t>•  Every run pays Spark startup and JSON inference cost</a:t>
+              <a:t>•  Parallel connector reads can compete for export capacity</a:t>
             </a:r>
           </a:p>
           <a:p>
@@ -6076,7 +5980,7 @@
               </a:defRPr>
             </a:pPr>
             <a:r>
-              <a:t>•  Parallel bulk reads compete for export capacity</a:t>
+              <a:t>•  A parsing problem now has its own scheduling and recovery process</a:t>
             </a:r>
           </a:p>
           <a:p>
@@ -6092,7 +5996,7 @@
               </a:defRPr>
             </a:pPr>
             <a:r>
-              <a:t>•  Buffers, watermarks, and merge jobs increase operational state</a:t>
+              <a:t>•  We only want to remove the work Eventhouse can already do</a:t>
             </a:r>
           </a:p>
         </p:txBody>
@@ -6252,7 +6156,7 @@
               </a:defRPr>
             </a:pPr>
             <a:r>
-              <a:t>What the demo builds instead</a:t>
+              <a:t>The revised data path</a:t>
             </a:r>
           </a:p>
         </p:txBody>
@@ -6370,7 +6274,7 @@
               </a:defRPr>
             </a:pPr>
             <a:r>
-              <a:t>•  Raw ingestion remains the replay point</a:t>
+              <a:t>•  Keep one raw copy for investigation and replay</a:t>
             </a:r>
           </a:p>
           <a:p>
@@ -6386,7 +6290,7 @@
               </a:defRPr>
             </a:pPr>
             <a:r>
-              <a:t>•  Update policies create stable typed tables</a:t>
+              <a:t>•  Use update policies to fill ordinary typed tables</a:t>
             </a:r>
           </a:p>
           <a:p>
@@ -6402,7 +6306,7 @@
               </a:defRPr>
             </a:pPr>
             <a:r>
-              <a:t>•  Unknown values remain in residual JSON</a:t>
+              <a:t>•  Leave unfamiliar fields in residual JSON</a:t>
             </a:r>
           </a:p>
           <a:p>
@@ -6418,23 +6322,7 @@
               </a:defRPr>
             </a:pPr>
             <a:r>
-              <a:t>•  A drift policy creates review evidence</a:t>
-            </a:r>
-          </a:p>
-          <a:p>
-            <a:pPr>
-              <a:spcAft>
-                <a:spcPts val="1800"/>
-              </a:spcAft>
-              <a:defRPr sz="2200">
-                <a:solidFill>
-                  <a:srgbClr val="EBF2F4"/>
-                </a:solidFill>
-                <a:latin typeface="Aptos"/>
-              </a:defRPr>
-            </a:pPr>
-            <a:r>
-              <a:t>•  Arrays become child rows</a:t>
+              <a:t>•  Record drift in a separate table for review</a:t>
             </a:r>
           </a:p>
         </p:txBody>
@@ -6556,7 +6444,7 @@
               </a:defRPr>
             </a:pPr>
             <a:r>
-              <a:t>Meet the message we will follow</a:t>
+              <a:t>A new field arrives</a:t>
             </a:r>
           </a:p>
         </p:txBody>
@@ -6674,7 +6562,7 @@
               </a:defRPr>
             </a:pPr>
             <a:r>
-              <a:t>•  Controller 01 reports normal operating values</a:t>
+              <a:t>•  Controller 01 is still reporting its usual measurements</a:t>
             </a:r>
           </a:p>
           <a:p>
@@ -6690,7 +6578,7 @@
               </a:defRPr>
             </a:pPr>
             <a:r>
-              <a:t>•  The producer adds serviceCountdownHours: 120</a:t>
+              <a:t>•  Firmware version 2 adds serviceCountdownHours: 120</a:t>
             </a:r>
           </a:p>
           <a:p>
@@ -6706,7 +6594,7 @@
               </a:defRPr>
             </a:pPr>
             <a:r>
-              <a:t>•  The target table does not have that column yet</a:t>
+              <a:t>•  There is no matching target column yet</a:t>
             </a:r>
           </a:p>
           <a:p>
@@ -6722,7 +6610,7 @@
               </a:defRPr>
             </a:pPr>
             <a:r>
-              <a:t>•  Success means preserving 120 without breaking typed ingestion</a:t>
+              <a:t>•  The value must survive without holding up the rest of the row</a:t>
             </a:r>
           </a:p>
         </p:txBody>
@@ -6867,7 +6755,7 @@
               </a:defRPr>
             </a:pPr>
             <a:r>
-              <a:t>Step 1: raw mapping loses nothing</a:t>
+              <a:t>First, keep the whole payload</a:t>
             </a:r>
           </a:p>
         </p:txBody>
@@ -6985,7 +6873,7 @@
               </a:defRPr>
             </a:pPr>
             <a:r>
-              <a:t>•  Stable envelope values become columns</a:t>
+              <a:t>•  A few envelope values are mapped to columns</a:t>
             </a:r>
           </a:p>
           <a:p>
@@ -7001,7 +6889,7 @@
               </a:defRPr>
             </a:pPr>
             <a:r>
-              <a:t>•  DropMappedFields keeps the remaining payload</a:t>
+              <a:t>•  DropMappedFields leaves everything else in RawRecord</a:t>
             </a:r>
           </a:p>
           <a:p>
@@ -7017,7 +6905,7 @@
               </a:defRPr>
             </a:pPr>
             <a:r>
-              <a:t>•  No landing-table alteration is needed</a:t>
+              <a:t>•  The landing table does not change when the payload does</a:t>
             </a:r>
           </a:p>
         </p:txBody>
@@ -7158,7 +7046,7 @@
               </a:defRPr>
             </a:pPr>
             <a:r>
-              <a:t>Step 2: typed row stays predictable</a:t>
+              <a:t>Then write the fields we know</a:t>
             </a:r>
           </a:p>
         </p:txBody>
@@ -7276,7 +7164,7 @@
               </a:defRPr>
             </a:pPr>
             <a:r>
-              <a:t>•  Explicit casts produce the approved columns</a:t>
+              <a:t>•  The transform casts each approved value explicitly</a:t>
             </a:r>
           </a:p>
           <a:p>
@@ -7292,7 +7180,7 @@
               </a:defRPr>
             </a:pPr>
             <a:r>
-              <a:t>•  bag_remove_keys moves the new key to residual JSON</a:t>
+              <a:t>•  bag_remove_keys leaves the new property in ResidualTelemetry</a:t>
             </a:r>
           </a:p>
           <a:p>
@@ -7308,7 +7196,7 @@
               </a:defRPr>
             </a:pPr>
             <a:r>
-              <a:t>•  Existing consumers see the same table schema</a:t>
+              <a:t>•  Reports continue to see the same columns as before</a:t>
             </a:r>
           </a:p>
         </p:txBody>
@@ -7445,7 +7333,7 @@
               </a:defRPr>
             </a:pPr>
             <a:r>
-              <a:t>Step 3: policies process it automatically</a:t>
+              <a:t>Update policies do the routine work</a:t>
             </a:r>
           </a:p>
         </p:txBody>
@@ -7563,7 +7451,7 @@
               </a:defRPr>
             </a:pPr>
             <a:r>
-              <a:t>•  The typed policy writes the controller row</a:t>
+              <a:t>•  One policy writes the controller row</a:t>
             </a:r>
           </a:p>
           <a:p>
@@ -7579,7 +7467,7 @@
               </a:defRPr>
             </a:pPr>
             <a:r>
-              <a:t>•  The drift policy examines the same raw message</a:t>
+              <a:t>•  Another checks the same message for unknown fields</a:t>
             </a:r>
           </a:p>
           <a:p>
@@ -7595,7 +7483,7 @@
               </a:defRPr>
             </a:pPr>
             <a:r>
-              <a:t>•  No scheduled connector export or watermark is required</a:t>
+              <a:t>•  There is no notebook schedule or export watermark in between</a:t>
             </a:r>
           </a:p>
         </p:txBody>
@@ -7667,7 +7555,7 @@
             </a:r>
             <a:br/>
             <a:r>
-              <a:t>         →  drift evidence</a:t>
+              <a:t>         →  drift observation</a:t>
             </a:r>
           </a:p>
         </p:txBody>
@@ -7729,7 +7617,7 @@
               </a:defRPr>
             </a:pPr>
             <a:r>
-              <a:t>Step 4: drift becomes review evidence</a:t>
+              <a:t>The new field goes onto the review list</a:t>
             </a:r>
           </a:p>
         </p:txBody>
@@ -7847,7 +7735,7 @@
               </a:defRPr>
             </a:pPr>
             <a:r>
-              <a:t>•  bag_keys discovers serviceCountdownHours</a:t>
+              <a:t>•  bag_keys finds serviceCountdownHours</a:t>
             </a:r>
           </a:p>
           <a:p>
@@ -7863,7 +7751,7 @@
               </a:defRPr>
             </a:pPr>
             <a:r>
-              <a:t>•  gettype records long and a sample value of 120</a:t>
+              <a:t>•  gettype records long; the sample value is 120</a:t>
             </a:r>
           </a:p>
           <a:p>
@@ -7879,7 +7767,7 @@
               </a:defRPr>
             </a:pPr>
             <a:r>
-              <a:t>•  Known processing continues while the field is reviewed</a:t>
+              <a:t>•  Normal controller processing carries on while the team reviews it</a:t>
             </a:r>
           </a:p>
         </p:txBody>

</xml_diff>

<commit_message>
Explain schema drift principles for new readers
</commit_message>
<xml_diff>
--- a/presentation/eventhouse-schema-drift-reference.pptx
+++ b/presentation/eventhouse-schema-drift-reference.pptx
@@ -21,6 +21,8 @@
     <p:sldId id="269" r:id="rId20"/>
     <p:sldId id="270" r:id="rId21"/>
     <p:sldId id="271" r:id="rId22"/>
+    <p:sldId id="272" r:id="rId23"/>
+    <p:sldId id="273" r:id="rId24"/>
   </p:sldIdLst>
   <p:sldSz cx="12191695" cy="6858000" type="screen4x3"/>
   <p:notesSz cx="6858000" cy="9144000"/>
@@ -3221,11 +3223,11 @@
               </a:defRPr>
             </a:pPr>
             <a:r>
-              <a:t>A practical alternative to exporting every telemetry batch to Spark</a:t>
+              <a:t>A reusable pattern for JSON that changes over time</a:t>
             </a:r>
             <a:br/>
             <a:r>
-              <a:t>Raw messages stay available; reporting tables stay stable</a:t>
+              <a:t>Accept new data without making downstream schemas unpredictable</a:t>
             </a:r>
           </a:p>
         </p:txBody>
@@ -3323,7 +3325,7 @@
               </a:defRPr>
             </a:pPr>
             <a:r>
-              <a:t>Arrays are handled as rows</a:t>
+              <a:t>The new field goes onto the review list</a:t>
             </a:r>
           </a:p>
         </p:txBody>
@@ -3441,7 +3443,7 @@
               </a:defRPr>
             </a:pPr>
             <a:r>
-              <a:t>•  This cooling-unit message has two zones</a:t>
+              <a:t>•  bag_keys finds serviceCountdownHours</a:t>
             </a:r>
           </a:p>
           <a:p>
@@ -3457,7 +3459,7 @@
               </a:defRPr>
             </a:pPr>
             <a:r>
-              <a:t>•  mv-expand writes two child rows and keeps the zone IDs</a:t>
+              <a:t>•  gettype records long; the sample value is 120</a:t>
             </a:r>
           </a:p>
           <a:p>
@@ -3473,7 +3475,7 @@
               </a:defRPr>
             </a:pPr>
             <a:r>
-              <a:t>•  A message with an empty zones array writes no child rows</a:t>
+              <a:t>•  Normal controller processing carries on while the team reviews it</a:t>
             </a:r>
           </a:p>
         </p:txBody>
@@ -3528,20 +3530,28 @@
               </a:defRPr>
             </a:pPr>
             <a:r>
-              <a:t>Device      Zone  Mode     Return  Setpoint</a:t>
+              <a:t>SourceType    controller</a:t>
             </a:r>
             <a:br/>
             <a:r>
-              <a:t>cooling-01  1     cool     2.8     2.0</a:t>
+              <a:t>FieldPath     serviceCountdownHours</a:t>
             </a:r>
             <a:br/>
             <a:r>
-              <a:t>cooling-01  2     defrost  5.1     4.0</a:t>
+              <a:t>ObservedType  long</a:t>
+            </a:r>
+            <a:br/>
+            <a:r>
+              <a:t>SampleValue   120</a:t>
             </a:r>
             <a:br/>
             <a:br/>
             <a:r>
-              <a:t>| mv-expand Zone=Zones</a:t>
+              <a:t>bag_keys + mv-expand</a:t>
+            </a:r>
+            <a:br/>
+            <a:r>
+              <a:t>+ set_has_element + gettype</a:t>
             </a:r>
           </a:p>
         </p:txBody>
@@ -3603,7 +3613,7 @@
               </a:defRPr>
             </a:pPr>
             <a:r>
-              <a:t>Promotion is a normal code change</a:t>
+              <a:t>Arrays are handled as rows</a:t>
             </a:r>
           </a:p>
         </p:txBody>
@@ -3721,7 +3731,7 @@
               </a:defRPr>
             </a:pPr>
             <a:r>
-              <a:t>•  The team agrees the name, meaning, unit, and type</a:t>
+              <a:t>•  This cooling-unit message has two zones</a:t>
             </a:r>
           </a:p>
           <a:p>
@@ -3737,7 +3747,7 @@
               </a:defRPr>
             </a:pPr>
             <a:r>
-              <a:t>•  The PR adds the column and updates the stored function</a:t>
+              <a:t>•  mv-expand writes two child rows and keeps the zone IDs</a:t>
             </a:r>
           </a:p>
           <a:p>
@@ -3753,7 +3763,7 @@
               </a:defRPr>
             </a:pPr>
             <a:r>
-              <a:t>•  After a schema check, only the agreed history is replayed</a:t>
+              <a:t>•  A message with an empty zones array writes no child rows</a:t>
             </a:r>
           </a:p>
         </p:txBody>
@@ -3808,29 +3818,20 @@
               </a:defRPr>
             </a:pPr>
             <a:r>
-              <a:t>BEFORE</a:t>
+              <a:t>Device      Zone  Mode     Return  Setpoint</a:t>
             </a:r>
             <a:br/>
             <a:r>
-              <a:t>Residual {"serviceCountdownHours":120}</a:t>
+              <a:t>cooling-01  1     cool     2.8     2.0</a:t>
+            </a:r>
+            <a:br/>
+            <a:r>
+              <a:t>cooling-01  2     defrost  5.1     4.0</a:t>
             </a:r>
             <a:br/>
             <a:br/>
             <a:r>
-              <a:t>AFTER</a:t>
-            </a:r>
-            <a:br/>
-            <a:r>
-              <a:t>ServiceCountdownHours  120.0</a:t>
-            </a:r>
-            <a:br/>
-            <a:r>
-              <a:t>Residual               {}</a:t>
-            </a:r>
-            <a:br/>
-            <a:br/>
-            <a:r>
-              <a:t>.alter-merge + .set-or-append</a:t>
+              <a:t>| mv-expand Zone=Zones</a:t>
             </a:r>
           </a:p>
         </p:txBody>
@@ -3892,7 +3893,7 @@
               </a:defRPr>
             </a:pPr>
             <a:r>
-              <a:t>An alert starts the conversation</a:t>
+              <a:t>Promotion is a normal code change</a:t>
             </a:r>
           </a:p>
         </p:txBody>
@@ -4010,7 +4011,7 @@
               </a:defRPr>
             </a:pPr>
             <a:r>
-              <a:t>•  Do not alert for every message; aggregate first</a:t>
+              <a:t>•  The team agrees the name, meaning, unit, and type</a:t>
             </a:r>
           </a:p>
           <a:p>
@@ -4026,7 +4027,7 @@
               </a:defRPr>
             </a:pPr>
             <a:r>
-              <a:t>•  Here, 10 observations in 15 minutes is enough to open a ticket</a:t>
+              <a:t>•  The PR adds the column and updates the stored function</a:t>
             </a:r>
           </a:p>
           <a:p>
@@ -4042,7 +4043,7 @@
               </a:defRPr>
             </a:pPr>
             <a:r>
-              <a:t>•  The ticket carries the type, sample, asset count, and time range</a:t>
+              <a:t>•  After a schema check, only the agreed history is replayed</a:t>
             </a:r>
           </a:p>
         </p:txBody>
@@ -4097,32 +4098,29 @@
               </a:defRPr>
             </a:pPr>
             <a:r>
-              <a:t>controller</a:t>
+              <a:t>BEFORE</a:t>
             </a:r>
             <a:br/>
             <a:r>
-              <a:t>serviceCountdownHours</a:t>
-            </a:r>
-            <a:br/>
-            <a:r>
-              <a:t>Type       long</a:t>
-            </a:r>
-            <a:br/>
-            <a:r>
-              <a:t>Sample     120</a:t>
-            </a:r>
-            <a:br/>
-            <a:r>
-              <a:t>Assets     47</a:t>
-            </a:r>
-            <a:br/>
-            <a:r>
-              <a:t>Events     8,212</a:t>
+              <a:t>Residual {"serviceCountdownHours":120}</a:t>
             </a:r>
             <a:br/>
             <a:br/>
             <a:r>
-              <a:t>→ Teams  → DATA-1842</a:t>
+              <a:t>AFTER</a:t>
+            </a:r>
+            <a:br/>
+            <a:r>
+              <a:t>ServiceCountdownHours  120.0</a:t>
+            </a:r>
+            <a:br/>
+            <a:r>
+              <a:t>Residual               {}</a:t>
+            </a:r>
+            <a:br/>
+            <a:br/>
+            <a:r>
+              <a:t>.alter-merge + .set-or-append</a:t>
             </a:r>
           </a:p>
         </p:txBody>
@@ -4184,7 +4182,7 @@
               </a:defRPr>
             </a:pPr>
             <a:r>
-              <a:t>Who looks at the ticket?</a:t>
+              <a:t>An alert starts the conversation</a:t>
             </a:r>
           </a:p>
         </p:txBody>
@@ -4302,7 +4300,7 @@
               </a:defRPr>
             </a:pPr>
             <a:r>
-              <a:t>•  Operations checks that ingestion is healthy</a:t>
+              <a:t>•  Do not alert for every message; aggregate first</a:t>
             </a:r>
           </a:p>
           <a:p>
@@ -4318,7 +4316,7 @@
               </a:defRPr>
             </a:pPr>
             <a:r>
-              <a:t>•  The source owner confirms the firmware change</a:t>
+              <a:t>•  Here, 10 observations in 15 minutes is enough to open a ticket</a:t>
             </a:r>
           </a:p>
           <a:p>
@@ -4334,39 +4332,7 @@
               </a:defRPr>
             </a:pPr>
             <a:r>
-              <a:t>•  The domain owner explains what the field means</a:t>
-            </a:r>
-          </a:p>
-          <a:p>
-            <a:pPr>
-              <a:spcAft>
-                <a:spcPts val="1800"/>
-              </a:spcAft>
-              <a:defRPr sz="2200">
-                <a:solidFill>
-                  <a:srgbClr val="EBF2F4"/>
-                </a:solidFill>
-                <a:latin typeface="Aptos"/>
-              </a:defRPr>
-            </a:pPr>
-            <a:r>
-              <a:t>•  Engineering profiles the data and prepares the change</a:t>
-            </a:r>
-          </a:p>
-          <a:p>
-            <a:pPr>
-              <a:spcAft>
-                <a:spcPts val="1800"/>
-              </a:spcAft>
-              <a:defRPr sz="2200">
-                <a:solidFill>
-                  <a:srgbClr val="EBF2F4"/>
-                </a:solidFill>
-                <a:latin typeface="Aptos"/>
-              </a:defRPr>
-            </a:pPr>
-            <a:r>
-              <a:t>•  Consumer and change owners sign off before deployment</a:t>
+              <a:t>•  The ticket carries the type, sample, asset count, and time range</a:t>
             </a:r>
           </a:p>
         </p:txBody>
@@ -4379,14 +4345,14 @@
         </p:nvSpPr>
         <p:spPr>
           <a:xfrm>
-            <a:off x="7818120" y="1371600"/>
-            <a:ext cx="3749039" cy="4526280"/>
+            <a:off x="7543800" y="1417320"/>
+            <a:ext cx="4069080" cy="4389120"/>
           </a:xfrm>
           <a:prstGeom prst="rect">
             <a:avLst/>
           </a:prstGeom>
           <a:solidFill>
-            <a:srgbClr val="1B2932"/>
+            <a:srgbClr val="080F14"/>
           </a:solidFill>
           <a:ln>
             <a:solidFill>
@@ -4409,62 +4375,44 @@
           </a:fontRef>
         </p:style>
         <p:txBody>
-          <a:bodyPr rtlCol="0" anchor="ctr"/>
-          <a:lstStyle/>
-          <a:p>
-            <a:pPr algn="ctr"/>
-          </a:p>
-        </p:txBody>
-      </p:sp>
-      <p:sp>
-        <p:nvSpPr>
-          <p:cNvPr id="7" name="Rounded Rectangle 6"/>
-          <p:cNvSpPr/>
-          <p:nvPr/>
-        </p:nvSpPr>
-        <p:spPr>
-          <a:xfrm>
-            <a:off x="8366760" y="2834640"/>
-            <a:ext cx="2651760" cy="1051560"/>
-          </a:xfrm>
-          <a:prstGeom prst="roundRect">
-            <a:avLst/>
-          </a:prstGeom>
-          <a:solidFill>
-            <a:srgbClr val="E67E22"/>
-          </a:solidFill>
-          <a:ln>
-            <a:noFill/>
-          </a:ln>
-        </p:spPr>
-        <p:style>
-          <a:lnRef idx="1">
-            <a:schemeClr val="accent1"/>
-          </a:lnRef>
-          <a:fillRef idx="3">
-            <a:schemeClr val="accent1"/>
-          </a:fillRef>
-          <a:effectRef idx="2">
-            <a:schemeClr val="accent1"/>
-          </a:effectRef>
-          <a:fontRef idx="minor">
-            <a:schemeClr val="lt1"/>
-          </a:fontRef>
-        </p:style>
-        <p:txBody>
-          <a:bodyPr rtlCol="0" anchor="ctr"/>
+          <a:bodyPr rtlCol="0" anchor="ctr" lIns="228600" rIns="182880" tIns="228600"/>
           <a:lstStyle/>
           <a:p>
             <a:pPr algn="ctr">
-              <a:defRPr sz="2000" b="1">
-                <a:solidFill>
-                  <a:srgbClr val="FFFFFF"/>
-                </a:solidFill>
-                <a:latin typeface="Aptos Display"/>
-              </a:defRPr>
-            </a:pPr>
-            <a:r>
-              <a:t>PROFILE → APPROVE</a:t>
+              <a:defRPr sz="1400">
+                <a:solidFill>
+                  <a:srgbClr val="DCEEF1"/>
+                </a:solidFill>
+                <a:latin typeface="Cascadia Mono"/>
+              </a:defRPr>
+            </a:pPr>
+            <a:r>
+              <a:t>controller</a:t>
+            </a:r>
+            <a:br/>
+            <a:r>
+              <a:t>serviceCountdownHours</a:t>
+            </a:r>
+            <a:br/>
+            <a:r>
+              <a:t>Type       long</a:t>
+            </a:r>
+            <a:br/>
+            <a:r>
+              <a:t>Sample     120</a:t>
+            </a:r>
+            <a:br/>
+            <a:r>
+              <a:t>Assets     47</a:t>
+            </a:r>
+            <a:br/>
+            <a:r>
+              <a:t>Events     8,212</a:t>
+            </a:r>
+            <a:br/>
+            <a:br/>
+            <a:r>
+              <a:t>→ Teams  → DATA-1842</a:t>
             </a:r>
           </a:p>
         </p:txBody>
@@ -4526,7 +4474,7 @@
               </a:defRPr>
             </a:pPr>
             <a:r>
-              <a:t>What the on-call engineer sees</a:t>
+              <a:t>Who looks at the ticket?</a:t>
             </a:r>
           </a:p>
         </p:txBody>
@@ -4644,7 +4592,7 @@
               </a:defRPr>
             </a:pPr>
             <a:r>
-              <a:t>•  Is data arriving, and are typed tables keeping up?</a:t>
+              <a:t>•  Operations checks that ingestion is healthy</a:t>
             </a:r>
           </a:p>
           <a:p>
@@ -4660,7 +4608,7 @@
               </a:defRPr>
             </a:pPr>
             <a:r>
-              <a:t>•  Which new fields appeared after the latest release?</a:t>
+              <a:t>•  The source owner confirms the firmware change</a:t>
             </a:r>
           </a:p>
           <a:p>
@@ -4676,7 +4624,7 @@
               </a:defRPr>
             </a:pPr>
             <a:r>
-              <a:t>•  Are known fields failing type conversion?</a:t>
+              <a:t>•  The domain owner explains what the field means</a:t>
             </a:r>
           </a:p>
           <a:p>
@@ -4692,7 +4640,7 @@
               </a:defRPr>
             </a:pPr>
             <a:r>
-              <a:t>•  How large is the residual backlog?</a:t>
+              <a:t>•  Engineering profiles the data and prepares the change</a:t>
             </a:r>
           </a:p>
           <a:p>
@@ -4708,7 +4656,7 @@
               </a:defRPr>
             </a:pPr>
             <a:r>
-              <a:t>•  Are arrays producing an unexpected number of rows?</a:t>
+              <a:t>•  Consumer and change owners sign off before deployment</a:t>
             </a:r>
           </a:p>
         </p:txBody>
@@ -4773,7 +4721,7 @@
             <a:avLst/>
           </a:prstGeom>
           <a:solidFill>
-            <a:srgbClr val="008577"/>
+            <a:srgbClr val="E67E22"/>
           </a:solidFill>
           <a:ln>
             <a:noFill/>
@@ -4806,7 +4754,7 @@
               </a:defRPr>
             </a:pPr>
             <a:r>
-              <a:t>OPERATIONS VIEW</a:t>
+              <a:t>PROFILE → APPROVE</a:t>
             </a:r>
           </a:p>
         </p:txBody>
@@ -4868,7 +4816,7 @@
               </a:defRPr>
             </a:pPr>
             <a:r>
-              <a:t>Not every field becomes a column</a:t>
+              <a:t>What the on-call engineer sees</a:t>
             </a:r>
           </a:p>
         </p:txBody>
@@ -4986,7 +4934,7 @@
               </a:defRPr>
             </a:pPr>
             <a:r>
-              <a:t>•  Promote it when the meaning is stable and consumers need it</a:t>
+              <a:t>•  Is data arriving, and are typed tables keeping up?</a:t>
             </a:r>
           </a:p>
           <a:p>
@@ -5002,7 +4950,7 @@
               </a:defRPr>
             </a:pPr>
             <a:r>
-              <a:t>•  Keep it in residual JSON when it is sparse or diagnostic</a:t>
+              <a:t>•  Which new fields appeared after the latest release?</a:t>
             </a:r>
           </a:p>
           <a:p>
@@ -5018,7 +4966,7 @@
               </a:defRPr>
             </a:pPr>
             <a:r>
-              <a:t>•  Reject or quarantine accidental, malformed, or sensitive data</a:t>
+              <a:t>•  Are known fields failing type conversion?</a:t>
             </a:r>
           </a:p>
           <a:p>
@@ -5034,7 +4982,23 @@
               </a:defRPr>
             </a:pPr>
             <a:r>
-              <a:t>•  Record the decision so the same ticket does not return tomorrow</a:t>
+              <a:t>•  How large is the residual backlog?</a:t>
+            </a:r>
+          </a:p>
+          <a:p>
+            <a:pPr>
+              <a:spcAft>
+                <a:spcPts val="1800"/>
+              </a:spcAft>
+              <a:defRPr sz="2200">
+                <a:solidFill>
+                  <a:srgbClr val="EBF2F4"/>
+                </a:solidFill>
+                <a:latin typeface="Aptos"/>
+              </a:defRPr>
+            </a:pPr>
+            <a:r>
+              <a:t>•  Are arrays producing an unexpected number of rows?</a:t>
             </a:r>
           </a:p>
         </p:txBody>
@@ -5099,7 +5063,7 @@
             <a:avLst/>
           </a:prstGeom>
           <a:solidFill>
-            <a:srgbClr val="0078D4"/>
+            <a:srgbClr val="008577"/>
           </a:solidFill>
           <a:ln>
             <a:noFill/>
@@ -5132,7 +5096,7 @@
               </a:defRPr>
             </a:pPr>
             <a:r>
-              <a:t>3 DECISIONS</a:t>
+              <a:t>OPERATIONS VIEW</a:t>
             </a:r>
           </a:p>
         </p:txBody>
@@ -5194,7 +5158,7 @@
               </a:defRPr>
             </a:pPr>
             <a:r>
-              <a:t>A sensible way to start</a:t>
+              <a:t>Not every field becomes a column</a:t>
             </a:r>
           </a:p>
         </p:txBody>
@@ -5312,7 +5276,7 @@
               </a:defRPr>
             </a:pPr>
             <a:r>
-              <a:t>•  Shadow one source type before changing the current path</a:t>
+              <a:t>•  Promote it when the meaning is stable and consumers need it</a:t>
             </a:r>
           </a:p>
           <a:p>
@@ -5328,7 +5292,7 @@
               </a:defRPr>
             </a:pPr>
             <a:r>
-              <a:t>•  Measure ingestion cost, latency, array growth, and completeness</a:t>
+              <a:t>•  Keep it in residual JSON when it is sparse or diagnostic</a:t>
             </a:r>
           </a:p>
           <a:p>
@@ -5344,7 +5308,7 @@
               </a:defRPr>
             </a:pPr>
             <a:r>
-              <a:t>•  Exercise failure and replay while the blast radius is small</a:t>
+              <a:t>•  Reject or quarantine accidental, malformed, or sensitive data</a:t>
             </a:r>
           </a:p>
           <a:p>
@@ -5360,7 +5324,659 @@
               </a:defRPr>
             </a:pPr>
             <a:r>
-              <a:t>•  Remove the Spark reads only after the numbers and outputs agree</a:t>
+              <a:t>•  Record the decision so the same ticket does not return tomorrow</a:t>
+            </a:r>
+          </a:p>
+        </p:txBody>
+      </p:sp>
+      <p:sp>
+        <p:nvSpPr>
+          <p:cNvPr id="6" name="Rectangle 5"/>
+          <p:cNvSpPr/>
+          <p:nvPr/>
+        </p:nvSpPr>
+        <p:spPr>
+          <a:xfrm>
+            <a:off x="7818120" y="1371600"/>
+            <a:ext cx="3749039" cy="4526280"/>
+          </a:xfrm>
+          <a:prstGeom prst="rect">
+            <a:avLst/>
+          </a:prstGeom>
+          <a:solidFill>
+            <a:srgbClr val="1B2932"/>
+          </a:solidFill>
+          <a:ln>
+            <a:solidFill>
+              <a:srgbClr val="3C525C"/>
+            </a:solidFill>
+          </a:ln>
+        </p:spPr>
+        <p:style>
+          <a:lnRef idx="1">
+            <a:schemeClr val="accent1"/>
+          </a:lnRef>
+          <a:fillRef idx="3">
+            <a:schemeClr val="accent1"/>
+          </a:fillRef>
+          <a:effectRef idx="2">
+            <a:schemeClr val="accent1"/>
+          </a:effectRef>
+          <a:fontRef idx="minor">
+            <a:schemeClr val="lt1"/>
+          </a:fontRef>
+        </p:style>
+        <p:txBody>
+          <a:bodyPr rtlCol="0" anchor="ctr"/>
+          <a:lstStyle/>
+          <a:p>
+            <a:pPr algn="ctr"/>
+          </a:p>
+        </p:txBody>
+      </p:sp>
+      <p:sp>
+        <p:nvSpPr>
+          <p:cNvPr id="7" name="Rounded Rectangle 6"/>
+          <p:cNvSpPr/>
+          <p:nvPr/>
+        </p:nvSpPr>
+        <p:spPr>
+          <a:xfrm>
+            <a:off x="8366760" y="2834640"/>
+            <a:ext cx="2651760" cy="1051560"/>
+          </a:xfrm>
+          <a:prstGeom prst="roundRect">
+            <a:avLst/>
+          </a:prstGeom>
+          <a:solidFill>
+            <a:srgbClr val="0078D4"/>
+          </a:solidFill>
+          <a:ln>
+            <a:noFill/>
+          </a:ln>
+        </p:spPr>
+        <p:style>
+          <a:lnRef idx="1">
+            <a:schemeClr val="accent1"/>
+          </a:lnRef>
+          <a:fillRef idx="3">
+            <a:schemeClr val="accent1"/>
+          </a:fillRef>
+          <a:effectRef idx="2">
+            <a:schemeClr val="accent1"/>
+          </a:effectRef>
+          <a:fontRef idx="minor">
+            <a:schemeClr val="lt1"/>
+          </a:fontRef>
+        </p:style>
+        <p:txBody>
+          <a:bodyPr rtlCol="0" anchor="ctr"/>
+          <a:lstStyle/>
+          <a:p>
+            <a:pPr algn="ctr">
+              <a:defRPr sz="2000" b="1">
+                <a:solidFill>
+                  <a:srgbClr val="FFFFFF"/>
+                </a:solidFill>
+                <a:latin typeface="Aptos Display"/>
+              </a:defRPr>
+            </a:pPr>
+            <a:r>
+              <a:t>3 DECISIONS</a:t>
+            </a:r>
+          </a:p>
+        </p:txBody>
+      </p:sp>
+    </p:spTree>
+  </p:cSld>
+  <p:clrMapOvr>
+    <a:masterClrMapping/>
+  </p:clrMapOvr>
+</p:sld>
+</file>
+
+<file path=ppt/slides/slide17.xml><?xml version="1.0" encoding="utf-8"?>
+<p:sld xmlns:a="http://schemas.openxmlformats.org/drawingml/2006/main" xmlns:p="http://schemas.openxmlformats.org/presentationml/2006/main" xmlns:r="http://schemas.openxmlformats.org/officeDocument/2006/relationships">
+  <p:cSld>
+    <p:bg>
+      <p:bgPr>
+        <a:solidFill>
+          <a:srgbClr val="0E161D"/>
+        </a:solidFill>
+        <a:effectLst/>
+      </p:bgPr>
+    </p:bg>
+    <p:spTree>
+      <p:nvGrpSpPr>
+        <p:cNvPr id="1" name=""/>
+        <p:cNvGrpSpPr/>
+        <p:nvPr/>
+      </p:nvGrpSpPr>
+      <p:grpSpPr/>
+      <p:sp>
+        <p:nvSpPr>
+          <p:cNvPr id="2" name="TextBox 1"/>
+          <p:cNvSpPr txBox="1"/>
+          <p:nvPr/>
+        </p:nvSpPr>
+        <p:spPr>
+          <a:xfrm>
+            <a:off x="640080" y="411480"/>
+            <a:ext cx="10789920" cy="548640"/>
+          </a:xfrm>
+          <a:prstGeom prst="rect">
+            <a:avLst/>
+          </a:prstGeom>
+          <a:noFill/>
+        </p:spPr>
+        <p:txBody>
+          <a:bodyPr wrap="none">
+            <a:spAutoFit/>
+          </a:bodyPr>
+          <a:lstStyle/>
+          <a:p>
+            <a:pPr>
+              <a:defRPr sz="2800" b="1">
+                <a:solidFill>
+                  <a:srgbClr val="EBF2F4"/>
+                </a:solidFill>
+                <a:latin typeface="Aptos"/>
+              </a:defRPr>
+            </a:pPr>
+            <a:r>
+              <a:t>Where this can simplify an existing design</a:t>
+            </a:r>
+          </a:p>
+        </p:txBody>
+      </p:sp>
+      <p:sp>
+        <p:nvSpPr>
+          <p:cNvPr id="3" name="Rectangle 2"/>
+          <p:cNvSpPr/>
+          <p:nvPr/>
+        </p:nvSpPr>
+        <p:spPr>
+          <a:xfrm>
+            <a:off x="640080" y="1060704"/>
+            <a:ext cx="1051560" cy="64008"/>
+          </a:xfrm>
+          <a:prstGeom prst="rect">
+            <a:avLst/>
+          </a:prstGeom>
+          <a:solidFill>
+            <a:srgbClr val="0078D4"/>
+          </a:solidFill>
+          <a:ln>
+            <a:noFill/>
+          </a:ln>
+        </p:spPr>
+        <p:style>
+          <a:lnRef idx="1">
+            <a:schemeClr val="accent1"/>
+          </a:lnRef>
+          <a:fillRef idx="3">
+            <a:schemeClr val="accent1"/>
+          </a:fillRef>
+          <a:effectRef idx="2">
+            <a:schemeClr val="accent1"/>
+          </a:effectRef>
+          <a:fontRef idx="minor">
+            <a:schemeClr val="lt1"/>
+          </a:fontRef>
+        </p:style>
+        <p:txBody>
+          <a:bodyPr rtlCol="0" anchor="ctr"/>
+          <a:lstStyle/>
+          <a:p>
+            <a:pPr algn="ctr"/>
+          </a:p>
+        </p:txBody>
+      </p:sp>
+      <p:sp>
+        <p:nvSpPr>
+          <p:cNvPr id="4" name="TextBox 3"/>
+          <p:cNvSpPr txBox="1"/>
+          <p:nvPr/>
+        </p:nvSpPr>
+        <p:spPr>
+          <a:xfrm>
+            <a:off x="11155680" y="457200"/>
+            <a:ext cx="457200" cy="365760"/>
+          </a:xfrm>
+          <a:prstGeom prst="rect">
+            <a:avLst/>
+          </a:prstGeom>
+          <a:noFill/>
+        </p:spPr>
+        <p:txBody>
+          <a:bodyPr wrap="none">
+            <a:spAutoFit/>
+          </a:bodyPr>
+          <a:lstStyle/>
+          <a:p>
+            <a:pPr>
+              <a:defRPr sz="1100" b="1">
+                <a:solidFill>
+                  <a:srgbClr val="0078D4"/>
+                </a:solidFill>
+                <a:latin typeface="Aptos"/>
+              </a:defRPr>
+            </a:pPr>
+            <a:r>
+              <a:t>17</a:t>
+            </a:r>
+          </a:p>
+        </p:txBody>
+      </p:sp>
+      <p:sp>
+        <p:nvSpPr>
+          <p:cNvPr id="5" name="TextBox 4"/>
+          <p:cNvSpPr txBox="1"/>
+          <p:nvPr/>
+        </p:nvSpPr>
+        <p:spPr>
+          <a:xfrm>
+            <a:off x="868680" y="1417320"/>
+            <a:ext cx="6400800" cy="4526280"/>
+          </a:xfrm>
+          <a:prstGeom prst="rect">
+            <a:avLst/>
+          </a:prstGeom>
+          <a:noFill/>
+        </p:spPr>
+        <p:txBody>
+          <a:bodyPr wrap="none">
+            <a:spAutoFit/>
+          </a:bodyPr>
+          <a:lstStyle/>
+          <a:p>
+            <a:pPr>
+              <a:spcAft>
+                <a:spcPts val="1800"/>
+              </a:spcAft>
+              <a:defRPr sz="2200">
+                <a:solidFill>
+                  <a:srgbClr val="EBF2F4"/>
+                </a:solidFill>
+                <a:latin typeface="Aptos"/>
+              </a:defRPr>
+            </a:pPr>
+            <a:r>
+              <a:t>•  Some teams currently flatten JSON in Spark, pipelines, or application code</a:t>
+            </a:r>
+          </a:p>
+          <a:p>
+            <a:pPr>
+              <a:spcAft>
+                <a:spcPts val="1800"/>
+              </a:spcAft>
+              <a:defRPr sz="2200">
+                <a:solidFill>
+                  <a:srgbClr val="EBF2F4"/>
+                </a:solidFill>
+                <a:latin typeface="Aptos"/>
+              </a:defRPr>
+            </a:pPr>
+            <a:r>
+              <a:t>•  Keep that processing when it adds capabilities KQL does not provide</a:t>
+            </a:r>
+          </a:p>
+          <a:p>
+            <a:pPr>
+              <a:spcAft>
+                <a:spcPts val="1800"/>
+              </a:spcAft>
+              <a:defRPr sz="2200">
+                <a:solidFill>
+                  <a:srgbClr val="EBF2F4"/>
+                </a:solidFill>
+                <a:latin typeface="Aptos"/>
+              </a:defRPr>
+            </a:pPr>
+            <a:r>
+              <a:t>•  Move routine parsing and drift observation closer to ingestion when it reduces data movement</a:t>
+            </a:r>
+          </a:p>
+          <a:p>
+            <a:pPr>
+              <a:spcAft>
+                <a:spcPts val="1800"/>
+              </a:spcAft>
+              <a:defRPr sz="2200">
+                <a:solidFill>
+                  <a:srgbClr val="EBF2F4"/>
+                </a:solidFill>
+                <a:latin typeface="Aptos"/>
+              </a:defRPr>
+            </a:pPr>
+            <a:r>
+              <a:t>•  Compare both paths with representative volume before cutting over</a:t>
+            </a:r>
+          </a:p>
+        </p:txBody>
+      </p:sp>
+      <p:sp>
+        <p:nvSpPr>
+          <p:cNvPr id="6" name="Rectangle 5"/>
+          <p:cNvSpPr/>
+          <p:nvPr/>
+        </p:nvSpPr>
+        <p:spPr>
+          <a:xfrm>
+            <a:off x="7818120" y="1371600"/>
+            <a:ext cx="3749039" cy="4526280"/>
+          </a:xfrm>
+          <a:prstGeom prst="rect">
+            <a:avLst/>
+          </a:prstGeom>
+          <a:solidFill>
+            <a:srgbClr val="1B2932"/>
+          </a:solidFill>
+          <a:ln>
+            <a:solidFill>
+              <a:srgbClr val="3C525C"/>
+            </a:solidFill>
+          </a:ln>
+        </p:spPr>
+        <p:style>
+          <a:lnRef idx="1">
+            <a:schemeClr val="accent1"/>
+          </a:lnRef>
+          <a:fillRef idx="3">
+            <a:schemeClr val="accent1"/>
+          </a:fillRef>
+          <a:effectRef idx="2">
+            <a:schemeClr val="accent1"/>
+          </a:effectRef>
+          <a:fontRef idx="minor">
+            <a:schemeClr val="lt1"/>
+          </a:fontRef>
+        </p:style>
+        <p:txBody>
+          <a:bodyPr rtlCol="0" anchor="ctr"/>
+          <a:lstStyle/>
+          <a:p>
+            <a:pPr algn="ctr"/>
+          </a:p>
+        </p:txBody>
+      </p:sp>
+      <p:sp>
+        <p:nvSpPr>
+          <p:cNvPr id="7" name="Rounded Rectangle 6"/>
+          <p:cNvSpPr/>
+          <p:nvPr/>
+        </p:nvSpPr>
+        <p:spPr>
+          <a:xfrm>
+            <a:off x="8366760" y="2834640"/>
+            <a:ext cx="2651760" cy="1051560"/>
+          </a:xfrm>
+          <a:prstGeom prst="roundRect">
+            <a:avLst/>
+          </a:prstGeom>
+          <a:solidFill>
+            <a:srgbClr val="E67E22"/>
+          </a:solidFill>
+          <a:ln>
+            <a:noFill/>
+          </a:ln>
+        </p:spPr>
+        <p:style>
+          <a:lnRef idx="1">
+            <a:schemeClr val="accent1"/>
+          </a:lnRef>
+          <a:fillRef idx="3">
+            <a:schemeClr val="accent1"/>
+          </a:fillRef>
+          <a:effectRef idx="2">
+            <a:schemeClr val="accent1"/>
+          </a:effectRef>
+          <a:fontRef idx="minor">
+            <a:schemeClr val="lt1"/>
+          </a:fontRef>
+        </p:style>
+        <p:txBody>
+          <a:bodyPr rtlCol="0" anchor="ctr"/>
+          <a:lstStyle/>
+          <a:p>
+            <a:pPr algn="ctr">
+              <a:defRPr sz="2000" b="1">
+                <a:solidFill>
+                  <a:srgbClr val="FFFFFF"/>
+                </a:solidFill>
+                <a:latin typeface="Aptos Display"/>
+              </a:defRPr>
+            </a:pPr>
+            <a:r>
+              <a:t>MOVE ONLY WHAT FITS</a:t>
+            </a:r>
+          </a:p>
+        </p:txBody>
+      </p:sp>
+    </p:spTree>
+  </p:cSld>
+  <p:clrMapOvr>
+    <a:masterClrMapping/>
+  </p:clrMapOvr>
+</p:sld>
+</file>
+
+<file path=ppt/slides/slide18.xml><?xml version="1.0" encoding="utf-8"?>
+<p:sld xmlns:a="http://schemas.openxmlformats.org/drawingml/2006/main" xmlns:p="http://schemas.openxmlformats.org/presentationml/2006/main" xmlns:r="http://schemas.openxmlformats.org/officeDocument/2006/relationships">
+  <p:cSld>
+    <p:bg>
+      <p:bgPr>
+        <a:solidFill>
+          <a:srgbClr val="0E161D"/>
+        </a:solidFill>
+        <a:effectLst/>
+      </p:bgPr>
+    </p:bg>
+    <p:spTree>
+      <p:nvGrpSpPr>
+        <p:cNvPr id="1" name=""/>
+        <p:cNvGrpSpPr/>
+        <p:nvPr/>
+      </p:nvGrpSpPr>
+      <p:grpSpPr/>
+      <p:sp>
+        <p:nvSpPr>
+          <p:cNvPr id="2" name="TextBox 1"/>
+          <p:cNvSpPr txBox="1"/>
+          <p:nvPr/>
+        </p:nvSpPr>
+        <p:spPr>
+          <a:xfrm>
+            <a:off x="640080" y="411480"/>
+            <a:ext cx="10789920" cy="548640"/>
+          </a:xfrm>
+          <a:prstGeom prst="rect">
+            <a:avLst/>
+          </a:prstGeom>
+          <a:noFill/>
+        </p:spPr>
+        <p:txBody>
+          <a:bodyPr wrap="none">
+            <a:spAutoFit/>
+          </a:bodyPr>
+          <a:lstStyle/>
+          <a:p>
+            <a:pPr>
+              <a:defRPr sz="2800" b="1">
+                <a:solidFill>
+                  <a:srgbClr val="EBF2F4"/>
+                </a:solidFill>
+                <a:latin typeface="Aptos"/>
+              </a:defRPr>
+            </a:pPr>
+            <a:r>
+              <a:t>A sensible way to start</a:t>
+            </a:r>
+          </a:p>
+        </p:txBody>
+      </p:sp>
+      <p:sp>
+        <p:nvSpPr>
+          <p:cNvPr id="3" name="Rectangle 2"/>
+          <p:cNvSpPr/>
+          <p:nvPr/>
+        </p:nvSpPr>
+        <p:spPr>
+          <a:xfrm>
+            <a:off x="640080" y="1060704"/>
+            <a:ext cx="1051560" cy="64008"/>
+          </a:xfrm>
+          <a:prstGeom prst="rect">
+            <a:avLst/>
+          </a:prstGeom>
+          <a:solidFill>
+            <a:srgbClr val="0078D4"/>
+          </a:solidFill>
+          <a:ln>
+            <a:noFill/>
+          </a:ln>
+        </p:spPr>
+        <p:style>
+          <a:lnRef idx="1">
+            <a:schemeClr val="accent1"/>
+          </a:lnRef>
+          <a:fillRef idx="3">
+            <a:schemeClr val="accent1"/>
+          </a:fillRef>
+          <a:effectRef idx="2">
+            <a:schemeClr val="accent1"/>
+          </a:effectRef>
+          <a:fontRef idx="minor">
+            <a:schemeClr val="lt1"/>
+          </a:fontRef>
+        </p:style>
+        <p:txBody>
+          <a:bodyPr rtlCol="0" anchor="ctr"/>
+          <a:lstStyle/>
+          <a:p>
+            <a:pPr algn="ctr"/>
+          </a:p>
+        </p:txBody>
+      </p:sp>
+      <p:sp>
+        <p:nvSpPr>
+          <p:cNvPr id="4" name="TextBox 3"/>
+          <p:cNvSpPr txBox="1"/>
+          <p:nvPr/>
+        </p:nvSpPr>
+        <p:spPr>
+          <a:xfrm>
+            <a:off x="11155680" y="457200"/>
+            <a:ext cx="457200" cy="365760"/>
+          </a:xfrm>
+          <a:prstGeom prst="rect">
+            <a:avLst/>
+          </a:prstGeom>
+          <a:noFill/>
+        </p:spPr>
+        <p:txBody>
+          <a:bodyPr wrap="none">
+            <a:spAutoFit/>
+          </a:bodyPr>
+          <a:lstStyle/>
+          <a:p>
+            <a:pPr>
+              <a:defRPr sz="1100" b="1">
+                <a:solidFill>
+                  <a:srgbClr val="0078D4"/>
+                </a:solidFill>
+                <a:latin typeface="Aptos"/>
+              </a:defRPr>
+            </a:pPr>
+            <a:r>
+              <a:t>18</a:t>
+            </a:r>
+          </a:p>
+        </p:txBody>
+      </p:sp>
+      <p:sp>
+        <p:nvSpPr>
+          <p:cNvPr id="5" name="TextBox 4"/>
+          <p:cNvSpPr txBox="1"/>
+          <p:nvPr/>
+        </p:nvSpPr>
+        <p:spPr>
+          <a:xfrm>
+            <a:off x="868680" y="1417320"/>
+            <a:ext cx="6400800" cy="4526280"/>
+          </a:xfrm>
+          <a:prstGeom prst="rect">
+            <a:avLst/>
+          </a:prstGeom>
+          <a:noFill/>
+        </p:spPr>
+        <p:txBody>
+          <a:bodyPr wrap="none">
+            <a:spAutoFit/>
+          </a:bodyPr>
+          <a:lstStyle/>
+          <a:p>
+            <a:pPr>
+              <a:spcAft>
+                <a:spcPts val="1800"/>
+              </a:spcAft>
+              <a:defRPr sz="2200">
+                <a:solidFill>
+                  <a:srgbClr val="EBF2F4"/>
+                </a:solidFill>
+                <a:latin typeface="Aptos"/>
+              </a:defRPr>
+            </a:pPr>
+            <a:r>
+              <a:t>•  Shadow one source type before changing the current path</a:t>
+            </a:r>
+          </a:p>
+          <a:p>
+            <a:pPr>
+              <a:spcAft>
+                <a:spcPts val="1800"/>
+              </a:spcAft>
+              <a:defRPr sz="2200">
+                <a:solidFill>
+                  <a:srgbClr val="EBF2F4"/>
+                </a:solidFill>
+                <a:latin typeface="Aptos"/>
+              </a:defRPr>
+            </a:pPr>
+            <a:r>
+              <a:t>•  Measure ingestion cost, latency, array growth, and completeness</a:t>
+            </a:r>
+          </a:p>
+          <a:p>
+            <a:pPr>
+              <a:spcAft>
+                <a:spcPts val="1800"/>
+              </a:spcAft>
+              <a:defRPr sz="2200">
+                <a:solidFill>
+                  <a:srgbClr val="EBF2F4"/>
+                </a:solidFill>
+                <a:latin typeface="Aptos"/>
+              </a:defRPr>
+            </a:pPr>
+            <a:r>
+              <a:t>•  Exercise failure and replay while the blast radius is small</a:t>
+            </a:r>
+          </a:p>
+          <a:p>
+            <a:pPr>
+              <a:spcAft>
+                <a:spcPts val="1800"/>
+              </a:spcAft>
+              <a:defRPr sz="2200">
+                <a:solidFill>
+                  <a:srgbClr val="EBF2F4"/>
+                </a:solidFill>
+                <a:latin typeface="Aptos"/>
+              </a:defRPr>
+            </a:pPr>
+            <a:r>
+              <a:t>•  Change the existing process only after the numbers and outputs agree</a:t>
             </a:r>
           </a:p>
         </p:txBody>
@@ -5520,7 +6136,7 @@
               </a:defRPr>
             </a:pPr>
             <a:r>
-              <a:t>Where we started</a:t>
+              <a:t>Schema drift is more than a new field</a:t>
             </a:r>
           </a:p>
         </p:txBody>
@@ -5638,7 +6254,7 @@
               </a:defRPr>
             </a:pPr>
             <a:r>
-              <a:t>•  Telemetry lands in Eventhouse, then a notebook reads it back out</a:t>
+              <a:t>•  A producer adds a measurement</a:t>
             </a:r>
           </a:p>
           <a:p>
@@ -5654,7 +6270,7 @@
               </a:defRPr>
             </a:pPr>
             <a:r>
-              <a:t>•  Spark infers and flattens the JSON before writing Delta</a:t>
+              <a:t>•  A number starts arriving as text</a:t>
             </a:r>
           </a:p>
           <a:p>
@@ -5670,7 +6286,39 @@
               </a:defRPr>
             </a:pPr>
             <a:r>
-              <a:t>•  Watermarks, drift buffers, and merge jobs keep the batches coordinated</a:t>
+              <a:t>•  A property disappears from some messages</a:t>
+            </a:r>
+          </a:p>
+          <a:p>
+            <a:pPr>
+              <a:spcAft>
+                <a:spcPts val="1800"/>
+              </a:spcAft>
+              <a:defRPr sz="2200">
+                <a:solidFill>
+                  <a:srgbClr val="EBF2F4"/>
+                </a:solidFill>
+                <a:latin typeface="Aptos"/>
+              </a:defRPr>
+            </a:pPr>
+            <a:r>
+              <a:t>•  A nested object changes shape</a:t>
+            </a:r>
+          </a:p>
+          <a:p>
+            <a:pPr>
+              <a:spcAft>
+                <a:spcPts val="1800"/>
+              </a:spcAft>
+              <a:defRPr sz="2200">
+                <a:solidFill>
+                  <a:srgbClr val="EBF2F4"/>
+                </a:solidFill>
+                <a:latin typeface="Aptos"/>
+              </a:defRPr>
+            </a:pPr>
+            <a:r>
+              <a:t>•  An array contains a different number of items</a:t>
             </a:r>
           </a:p>
         </p:txBody>
@@ -5735,7 +6383,7 @@
             <a:avLst/>
           </a:prstGeom>
           <a:solidFill>
-            <a:srgbClr val="C42B1C"/>
+            <a:srgbClr val="E67E22"/>
           </a:solidFill>
           <a:ln>
             <a:noFill/>
@@ -5768,7 +6416,7 @@
               </a:defRPr>
             </a:pPr>
             <a:r>
-              <a:t>EXPORT → SPARK</a:t>
+              <a:t>ADD | REMOVE | RETYPE</a:t>
             </a:r>
           </a:p>
         </p:txBody>
@@ -5830,7 +6478,7 @@
               </a:defRPr>
             </a:pPr>
             <a:r>
-              <a:t>The extra work adds up</a:t>
+              <a:t>Flexible input, stable output</a:t>
             </a:r>
           </a:p>
         </p:txBody>
@@ -5948,7 +6596,7 @@
               </a:defRPr>
             </a:pPr>
             <a:r>
-              <a:t>•  Each run starts Spark and exports another batch</a:t>
+              <a:t>•  Producers need room to evolve their messages</a:t>
             </a:r>
           </a:p>
           <a:p>
@@ -5964,7 +6612,7 @@
               </a:defRPr>
             </a:pPr>
             <a:r>
-              <a:t>•  Parallel connector reads can compete for export capacity</a:t>
+              <a:t>•  Reports and APIs need columns they can rely on</a:t>
             </a:r>
           </a:p>
           <a:p>
@@ -5980,7 +6628,7 @@
               </a:defRPr>
             </a:pPr>
             <a:r>
-              <a:t>•  A parsing problem now has its own scheduling and recovery process</a:t>
+              <a:t>•  Rejecting every change loses useful data</a:t>
             </a:r>
           </a:p>
           <a:p>
@@ -5996,7 +6644,23 @@
               </a:defRPr>
             </a:pPr>
             <a:r>
-              <a:t>•  We only want to remove the work Eventhouse can already do</a:t>
+              <a:t>•  Accepting every key as a column creates an unstable contract</a:t>
+            </a:r>
+          </a:p>
+          <a:p>
+            <a:pPr>
+              <a:spcAft>
+                <a:spcPts val="1800"/>
+              </a:spcAft>
+              <a:defRPr sz="2200">
+                <a:solidFill>
+                  <a:srgbClr val="EBF2F4"/>
+                </a:solidFill>
+                <a:latin typeface="Aptos"/>
+              </a:defRPr>
+            </a:pPr>
+            <a:r>
+              <a:t>•  The design has to serve both sides</a:t>
             </a:r>
           </a:p>
         </p:txBody>
@@ -6061,7 +6725,7 @@
             <a:avLst/>
           </a:prstGeom>
           <a:solidFill>
-            <a:srgbClr val="E67E22"/>
+            <a:srgbClr val="0078D4"/>
           </a:solidFill>
           <a:ln>
             <a:noFill/>
@@ -6094,7 +6758,7 @@
               </a:defRPr>
             </a:pPr>
             <a:r>
-              <a:t>MOVE + INFER + MERGE</a:t>
+              <a:t>FLEXIBLE → STABLE</a:t>
             </a:r>
           </a:p>
         </p:txBody>
@@ -6156,7 +6820,7 @@
               </a:defRPr>
             </a:pPr>
             <a:r>
-              <a:t>The revised data path</a:t>
+              <a:t>The five principles</a:t>
             </a:r>
           </a:p>
         </p:txBody>
@@ -6274,7 +6938,7 @@
               </a:defRPr>
             </a:pPr>
             <a:r>
-              <a:t>•  Keep one raw copy for investigation and replay</a:t>
+              <a:t>•  Keep the original message for investigation and replay</a:t>
             </a:r>
           </a:p>
           <a:p>
@@ -6290,7 +6954,7 @@
               </a:defRPr>
             </a:pPr>
             <a:r>
-              <a:t>•  Use update policies to fill ordinary typed tables</a:t>
+              <a:t>•  Separate the input shape from the consumer contract</a:t>
             </a:r>
           </a:p>
           <a:p>
@@ -6306,7 +6970,7 @@
               </a:defRPr>
             </a:pPr>
             <a:r>
-              <a:t>•  Leave unfamiliar fields in residual JSON</a:t>
+              <a:t>•  Preserve unfamiliar values in residual JSON</a:t>
             </a:r>
           </a:p>
           <a:p>
@@ -6322,67 +6986,121 @@
               </a:defRPr>
             </a:pPr>
             <a:r>
-              <a:t>•  Record drift in a separate table for review</a:t>
-            </a:r>
-          </a:p>
-        </p:txBody>
-      </p:sp>
-      <p:pic>
-        <p:nvPicPr>
-          <p:cNvPr id="6" name="Picture 5" descr="target-architecture.png"/>
-          <p:cNvPicPr>
-            <a:picLocks noChangeAspect="1"/>
-          </p:cNvPicPr>
-          <p:nvPr/>
-        </p:nvPicPr>
-        <p:blipFill>
-          <a:blip r:embed="rId2"/>
-          <a:stretch>
-            <a:fillRect/>
-          </a:stretch>
-        </p:blipFill>
-        <p:spPr>
-          <a:xfrm>
-            <a:off x="7452360" y="1325880"/>
-            <a:ext cx="4251960" cy="3611880"/>
-          </a:xfrm>
-          <a:prstGeom prst="rect">
-            <a:avLst/>
-          </a:prstGeom>
-        </p:spPr>
-      </p:pic>
-      <p:sp>
-        <p:nvSpPr>
-          <p:cNvPr id="7" name="TextBox 6"/>
-          <p:cNvSpPr txBox="1"/>
-          <p:nvPr/>
-        </p:nvSpPr>
-        <p:spPr>
-          <a:xfrm>
-            <a:off x="7543800" y="5166360"/>
-            <a:ext cx="3977639" cy="502920"/>
-          </a:xfrm>
-          <a:prstGeom prst="rect">
-            <a:avLst/>
-          </a:prstGeom>
-          <a:noFill/>
-        </p:spPr>
-        <p:txBody>
-          <a:bodyPr wrap="none">
-            <a:spAutoFit/>
-          </a:bodyPr>
-          <a:lstStyle/>
-          <a:p>
-            <a:pPr>
-              <a:defRPr sz="1700" b="1">
-                <a:solidFill>
-                  <a:srgbClr val="008577"/>
-                </a:solidFill>
-                <a:latin typeface="Aptos"/>
-              </a:defRPr>
-            </a:pPr>
-            <a:r>
-              <a:t>No routine telemetry export</a:t>
+              <a:t>•  Detect drift without stopping known-field processing</a:t>
+            </a:r>
+          </a:p>
+          <a:p>
+            <a:pPr>
+              <a:spcAft>
+                <a:spcPts val="1800"/>
+              </a:spcAft>
+              <a:defRPr sz="2200">
+                <a:solidFill>
+                  <a:srgbClr val="EBF2F4"/>
+                </a:solidFill>
+                <a:latin typeface="Aptos"/>
+              </a:defRPr>
+            </a:pPr>
+            <a:r>
+              <a:t>•  Promote a field only after review</a:t>
+            </a:r>
+          </a:p>
+        </p:txBody>
+      </p:sp>
+      <p:sp>
+        <p:nvSpPr>
+          <p:cNvPr id="6" name="Rectangle 5"/>
+          <p:cNvSpPr/>
+          <p:nvPr/>
+        </p:nvSpPr>
+        <p:spPr>
+          <a:xfrm>
+            <a:off x="7818120" y="1371600"/>
+            <a:ext cx="3749039" cy="4526280"/>
+          </a:xfrm>
+          <a:prstGeom prst="rect">
+            <a:avLst/>
+          </a:prstGeom>
+          <a:solidFill>
+            <a:srgbClr val="1B2932"/>
+          </a:solidFill>
+          <a:ln>
+            <a:solidFill>
+              <a:srgbClr val="3C525C"/>
+            </a:solidFill>
+          </a:ln>
+        </p:spPr>
+        <p:style>
+          <a:lnRef idx="1">
+            <a:schemeClr val="accent1"/>
+          </a:lnRef>
+          <a:fillRef idx="3">
+            <a:schemeClr val="accent1"/>
+          </a:fillRef>
+          <a:effectRef idx="2">
+            <a:schemeClr val="accent1"/>
+          </a:effectRef>
+          <a:fontRef idx="minor">
+            <a:schemeClr val="lt1"/>
+          </a:fontRef>
+        </p:style>
+        <p:txBody>
+          <a:bodyPr rtlCol="0" anchor="ctr"/>
+          <a:lstStyle/>
+          <a:p>
+            <a:pPr algn="ctr"/>
+          </a:p>
+        </p:txBody>
+      </p:sp>
+      <p:sp>
+        <p:nvSpPr>
+          <p:cNvPr id="7" name="Rounded Rectangle 6"/>
+          <p:cNvSpPr/>
+          <p:nvPr/>
+        </p:nvSpPr>
+        <p:spPr>
+          <a:xfrm>
+            <a:off x="8366760" y="2834640"/>
+            <a:ext cx="2651760" cy="1051560"/>
+          </a:xfrm>
+          <a:prstGeom prst="roundRect">
+            <a:avLst/>
+          </a:prstGeom>
+          <a:solidFill>
+            <a:srgbClr val="008577"/>
+          </a:solidFill>
+          <a:ln>
+            <a:noFill/>
+          </a:ln>
+        </p:spPr>
+        <p:style>
+          <a:lnRef idx="1">
+            <a:schemeClr val="accent1"/>
+          </a:lnRef>
+          <a:fillRef idx="3">
+            <a:schemeClr val="accent1"/>
+          </a:fillRef>
+          <a:effectRef idx="2">
+            <a:schemeClr val="accent1"/>
+          </a:effectRef>
+          <a:fontRef idx="minor">
+            <a:schemeClr val="lt1"/>
+          </a:fontRef>
+        </p:style>
+        <p:txBody>
+          <a:bodyPr rtlCol="0" anchor="ctr"/>
+          <a:lstStyle/>
+          <a:p>
+            <a:pPr algn="ctr">
+              <a:defRPr sz="2000" b="1">
+                <a:solidFill>
+                  <a:srgbClr val="FFFFFF"/>
+                </a:solidFill>
+                <a:latin typeface="Aptos Display"/>
+              </a:defRPr>
+            </a:pPr>
+            <a:r>
+              <a:t>KEEP → DETECT → REVIEW</a:t>
             </a:r>
           </a:p>
         </p:txBody>
@@ -6444,7 +7162,7 @@
               </a:defRPr>
             </a:pPr>
             <a:r>
-              <a:t>A new field arrives</a:t>
+              <a:t>How the pieces fit together</a:t>
             </a:r>
           </a:p>
         </p:txBody>
@@ -6562,7 +7280,7 @@
               </a:defRPr>
             </a:pPr>
             <a:r>
-              <a:t>•  Controller 01 is still reporting its usual measurements</a:t>
+              <a:t>•  RawTelemetry is the recovery point</a:t>
             </a:r>
           </a:p>
           <a:p>
@@ -6578,7 +7296,7 @@
               </a:defRPr>
             </a:pPr>
             <a:r>
-              <a:t>•  Firmware version 2 adds serviceCountdownHours: 120</a:t>
+              <a:t>•  Stored functions create fixed typed rows</a:t>
             </a:r>
           </a:p>
           <a:p>
@@ -6594,7 +7312,7 @@
               </a:defRPr>
             </a:pPr>
             <a:r>
-              <a:t>•  There is no matching target column yet</a:t>
+              <a:t>•  Update policies run those functions on arrival</a:t>
             </a:r>
           </a:p>
           <a:p>
@@ -6610,90 +7328,83 @@
               </a:defRPr>
             </a:pPr>
             <a:r>
-              <a:t>•  The value must survive without holding up the rest of the row</a:t>
-            </a:r>
-          </a:p>
-        </p:txBody>
-      </p:sp>
-      <p:sp>
-        <p:nvSpPr>
-          <p:cNvPr id="6" name="Rectangle 5"/>
-          <p:cNvSpPr/>
-          <p:nvPr/>
-        </p:nvSpPr>
-        <p:spPr>
-          <a:xfrm>
-            <a:off x="7543800" y="1417320"/>
-            <a:ext cx="4069080" cy="4389120"/>
-          </a:xfrm>
-          <a:prstGeom prst="rect">
-            <a:avLst/>
-          </a:prstGeom>
-          <a:solidFill>
-            <a:srgbClr val="080F14"/>
-          </a:solidFill>
-          <a:ln>
-            <a:solidFill>
-              <a:srgbClr val="3C525C"/>
-            </a:solidFill>
-          </a:ln>
-        </p:spPr>
-        <p:style>
-          <a:lnRef idx="1">
-            <a:schemeClr val="accent1"/>
-          </a:lnRef>
-          <a:fillRef idx="3">
-            <a:schemeClr val="accent1"/>
-          </a:fillRef>
-          <a:effectRef idx="2">
-            <a:schemeClr val="accent1"/>
-          </a:effectRef>
-          <a:fontRef idx="minor">
-            <a:schemeClr val="lt1"/>
-          </a:fontRef>
-        </p:style>
-        <p:txBody>
-          <a:bodyPr rtlCol="0" anchor="ctr" lIns="228600" rIns="182880" tIns="228600"/>
-          <a:lstStyle/>
-          <a:p>
-            <a:pPr algn="ctr">
-              <a:defRPr sz="1400">
-                <a:solidFill>
-                  <a:srgbClr val="DCEEF1"/>
-                </a:solidFill>
-                <a:latin typeface="Cascadia Mono"/>
-              </a:defRPr>
-            </a:pPr>
-            <a:r>
-              <a:t>"sourceType":"controller",</a:t>
-            </a:r>
-            <a:br/>
-            <a:r>
-              <a:t>"schemaVersion":2,</a:t>
-            </a:r>
-            <a:br/>
-            <a:r>
-              <a:t>"telemetry": {</a:t>
-            </a:r>
-            <a:br/>
-            <a:r>
-              <a:t>  "controllerStatus":"running",</a:t>
-            </a:r>
-            <a:br/>
-            <a:r>
-              <a:t>  "engineHours":1251.0,</a:t>
-            </a:r>
-            <a:br/>
-            <a:r>
-              <a:t>  "fuelConsumption":8.2,</a:t>
-            </a:r>
-            <a:br/>
-            <a:r>
-              <a:t>  "serviceCountdownHours":120</a:t>
-            </a:r>
-            <a:br/>
-            <a:r>
-              <a:t>}</a:t>
+              <a:t>•  A separate path records drift for review</a:t>
+            </a:r>
+          </a:p>
+          <a:p>
+            <a:pPr>
+              <a:spcAft>
+                <a:spcPts val="1800"/>
+              </a:spcAft>
+              <a:defRPr sz="2200">
+                <a:solidFill>
+                  <a:srgbClr val="EBF2F4"/>
+                </a:solidFill>
+                <a:latin typeface="Aptos"/>
+              </a:defRPr>
+            </a:pPr>
+            <a:r>
+              <a:t>•  Arrays are written as child rows</a:t>
+            </a:r>
+          </a:p>
+        </p:txBody>
+      </p:sp>
+      <p:pic>
+        <p:nvPicPr>
+          <p:cNvPr id="6" name="Picture 5" descr="target-architecture.png"/>
+          <p:cNvPicPr>
+            <a:picLocks noChangeAspect="1"/>
+          </p:cNvPicPr>
+          <p:nvPr/>
+        </p:nvPicPr>
+        <p:blipFill>
+          <a:blip r:embed="rId2"/>
+          <a:stretch>
+            <a:fillRect/>
+          </a:stretch>
+        </p:blipFill>
+        <p:spPr>
+          <a:xfrm>
+            <a:off x="7452360" y="1325880"/>
+            <a:ext cx="4251960" cy="3611880"/>
+          </a:xfrm>
+          <a:prstGeom prst="rect">
+            <a:avLst/>
+          </a:prstGeom>
+        </p:spPr>
+      </p:pic>
+      <p:sp>
+        <p:nvSpPr>
+          <p:cNvPr id="7" name="TextBox 6"/>
+          <p:cNvSpPr txBox="1"/>
+          <p:nvPr/>
+        </p:nvSpPr>
+        <p:spPr>
+          <a:xfrm>
+            <a:off x="7543800" y="5166360"/>
+            <a:ext cx="3977639" cy="502920"/>
+          </a:xfrm>
+          <a:prstGeom prst="rect">
+            <a:avLst/>
+          </a:prstGeom>
+          <a:noFill/>
+        </p:spPr>
+        <p:txBody>
+          <a:bodyPr wrap="none">
+            <a:spAutoFit/>
+          </a:bodyPr>
+          <a:lstStyle/>
+          <a:p>
+            <a:pPr>
+              <a:defRPr sz="1700" b="1">
+                <a:solidFill>
+                  <a:srgbClr val="008577"/>
+                </a:solidFill>
+                <a:latin typeface="Aptos"/>
+              </a:defRPr>
+            </a:pPr>
+            <a:r>
+              <a:t>No routine telemetry export</a:t>
             </a:r>
           </a:p>
         </p:txBody>
@@ -6755,7 +7466,7 @@
               </a:defRPr>
             </a:pPr>
             <a:r>
-              <a:t>First, keep the whole payload</a:t>
+              <a:t>A new field arrives</a:t>
             </a:r>
           </a:p>
         </p:txBody>
@@ -6873,7 +7584,7 @@
               </a:defRPr>
             </a:pPr>
             <a:r>
-              <a:t>•  A few envelope values are mapped to columns</a:t>
+              <a:t>•  Controller 01 is still reporting its usual measurements</a:t>
             </a:r>
           </a:p>
           <a:p>
@@ -6889,7 +7600,7 @@
               </a:defRPr>
             </a:pPr>
             <a:r>
-              <a:t>•  DropMappedFields leaves everything else in RawRecord</a:t>
+              <a:t>•  Firmware version 2 adds serviceCountdownHours: 120</a:t>
             </a:r>
           </a:p>
           <a:p>
@@ -6905,7 +7616,23 @@
               </a:defRPr>
             </a:pPr>
             <a:r>
-              <a:t>•  The landing table does not change when the payload does</a:t>
+              <a:t>•  There is no matching target column yet</a:t>
+            </a:r>
+          </a:p>
+          <a:p>
+            <a:pPr>
+              <a:spcAft>
+                <a:spcPts val="1800"/>
+              </a:spcAft>
+              <a:defRPr sz="2200">
+                <a:solidFill>
+                  <a:srgbClr val="EBF2F4"/>
+                </a:solidFill>
+                <a:latin typeface="Aptos"/>
+              </a:defRPr>
+            </a:pPr>
+            <a:r>
+              <a:t>•  The value must survive without holding up the rest of the row</a:t>
             </a:r>
           </a:p>
         </p:txBody>
@@ -6960,31 +7687,35 @@
               </a:defRPr>
             </a:pPr>
             <a:r>
-              <a:t>SourceType     controller</a:t>
+              <a:t>"sourceType":"controller",</a:t>
             </a:r>
             <a:br/>
             <a:r>
-              <a:t>SchemaVersion  2</a:t>
+              <a:t>"schemaVersion":2,</a:t>
             </a:r>
             <a:br/>
             <a:r>
-              <a:t>RawRecord      {</a:t>
+              <a:t>"telemetry": {</a:t>
             </a:r>
             <a:br/>
             <a:r>
-              <a:t> "payload":{"telemetry":{</a:t>
+              <a:t>  "controllerStatus":"running",</a:t>
             </a:r>
             <a:br/>
             <a:r>
-              <a:t>  ...,</a:t>
+              <a:t>  "engineHours":1251.0,</a:t>
             </a:r>
             <a:br/>
             <a:r>
+              <a:t>  "fuelConsumption":8.2,</a:t>
+            </a:r>
+            <a:br/>
+            <a:r>
               <a:t>  "serviceCountdownHours":120</a:t>
             </a:r>
             <a:br/>
             <a:r>
-              <a:t> }}}</a:t>
+              <a:t>}</a:t>
             </a:r>
           </a:p>
         </p:txBody>
@@ -7046,7 +7777,7 @@
               </a:defRPr>
             </a:pPr>
             <a:r>
-              <a:t>Then write the fields we know</a:t>
+              <a:t>First, keep the whole payload</a:t>
             </a:r>
           </a:p>
         </p:txBody>
@@ -7164,7 +7895,7 @@
               </a:defRPr>
             </a:pPr>
             <a:r>
-              <a:t>•  The transform casts each approved value explicitly</a:t>
+              <a:t>•  A few envelope values are mapped to columns</a:t>
             </a:r>
           </a:p>
           <a:p>
@@ -7180,7 +7911,7 @@
               </a:defRPr>
             </a:pPr>
             <a:r>
-              <a:t>•  bag_remove_keys leaves the new property in ResidualTelemetry</a:t>
+              <a:t>•  DropMappedFields leaves everything else in RawRecord</a:t>
             </a:r>
           </a:p>
           <a:p>
@@ -7196,7 +7927,7 @@
               </a:defRPr>
             </a:pPr>
             <a:r>
-              <a:t>•  Reports continue to see the same columns as before</a:t>
+              <a:t>•  The landing table does not change when the payload does</a:t>
             </a:r>
           </a:p>
         </p:txBody>
@@ -7251,27 +7982,31 @@
               </a:defRPr>
             </a:pPr>
             <a:r>
-              <a:t>ControllerStatus  running</a:t>
+              <a:t>SourceType     controller</a:t>
             </a:r>
             <a:br/>
             <a:r>
-              <a:t>EngineHours       1251.0</a:t>
+              <a:t>SchemaVersion  2</a:t>
             </a:r>
             <a:br/>
             <a:r>
-              <a:t>FuelConsumption   8.2</a:t>
+              <a:t>RawRecord      {</a:t>
             </a:r>
             <a:br/>
             <a:r>
-              <a:t>ResidualTelemetry {</a:t>
+              <a:t> "payload":{"telemetry":{</a:t>
             </a:r>
             <a:br/>
             <a:r>
-              <a:t> "serviceCountdownHours":120</a:t>
+              <a:t>  ...,</a:t>
             </a:r>
             <a:br/>
             <a:r>
-              <a:t>}</a:t>
+              <a:t>  "serviceCountdownHours":120</a:t>
+            </a:r>
+            <a:br/>
+            <a:r>
+              <a:t> }}}</a:t>
             </a:r>
           </a:p>
         </p:txBody>
@@ -7333,7 +8068,7 @@
               </a:defRPr>
             </a:pPr>
             <a:r>
-              <a:t>Update policies do the routine work</a:t>
+              <a:t>Then write the fields we know</a:t>
             </a:r>
           </a:p>
         </p:txBody>
@@ -7451,7 +8186,7 @@
               </a:defRPr>
             </a:pPr>
             <a:r>
-              <a:t>•  One policy writes the controller row</a:t>
+              <a:t>•  The transform casts each approved value explicitly</a:t>
             </a:r>
           </a:p>
           <a:p>
@@ -7467,7 +8202,7 @@
               </a:defRPr>
             </a:pPr>
             <a:r>
-              <a:t>•  Another checks the same message for unknown fields</a:t>
+              <a:t>•  bag_remove_keys leaves the new property in ResidualTelemetry</a:t>
             </a:r>
           </a:p>
           <a:p>
@@ -7483,7 +8218,7 @@
               </a:defRPr>
             </a:pPr>
             <a:r>
-              <a:t>•  There is no notebook schedule or export watermark in between</a:t>
+              <a:t>•  Reports continue to see the same columns as before</a:t>
             </a:r>
           </a:p>
         </p:txBody>
@@ -7538,24 +8273,27 @@
               </a:defRPr>
             </a:pPr>
             <a:r>
-              <a:t>{"Source":"RawTelemetry",</a:t>
+              <a:t>ControllerStatus  running</a:t>
             </a:r>
             <a:br/>
             <a:r>
-              <a:t> "Query":"TransformControllerTelemetry()",</a:t>
+              <a:t>EngineHours       1251.0</a:t>
             </a:r>
             <a:br/>
             <a:r>
-              <a:t> "IsTransactional":false}</a:t>
+              <a:t>FuelConsumption   8.2</a:t>
             </a:r>
             <a:br/>
+            <a:r>
+              <a:t>ResidualTelemetry {</a:t>
+            </a:r>
             <a:br/>
             <a:r>
-              <a:t>Raw row  →  typed row</a:t>
+              <a:t> "serviceCountdownHours":120</a:t>
             </a:r>
             <a:br/>
             <a:r>
-              <a:t>         →  drift observation</a:t>
+              <a:t>}</a:t>
             </a:r>
           </a:p>
         </p:txBody>
@@ -7617,7 +8355,7 @@
               </a:defRPr>
             </a:pPr>
             <a:r>
-              <a:t>The new field goes onto the review list</a:t>
+              <a:t>Update policies do the routine work</a:t>
             </a:r>
           </a:p>
         </p:txBody>
@@ -7735,7 +8473,7 @@
               </a:defRPr>
             </a:pPr>
             <a:r>
-              <a:t>•  bag_keys finds serviceCountdownHours</a:t>
+              <a:t>•  One policy writes the controller row</a:t>
             </a:r>
           </a:p>
           <a:p>
@@ -7751,7 +8489,7 @@
               </a:defRPr>
             </a:pPr>
             <a:r>
-              <a:t>•  gettype records long; the sample value is 120</a:t>
+              <a:t>•  Another checks the same message for unknown fields</a:t>
             </a:r>
           </a:p>
           <a:p>
@@ -7767,7 +8505,7 @@
               </a:defRPr>
             </a:pPr>
             <a:r>
-              <a:t>•  Normal controller processing carries on while the team reviews it</a:t>
+              <a:t>•  There is no notebook schedule or export watermark in between</a:t>
             </a:r>
           </a:p>
         </p:txBody>
@@ -7822,28 +8560,24 @@
               </a:defRPr>
             </a:pPr>
             <a:r>
-              <a:t>SourceType    controller</a:t>
+              <a:t>{"Source":"RawTelemetry",</a:t>
             </a:r>
             <a:br/>
             <a:r>
-              <a:t>FieldPath     serviceCountdownHours</a:t>
+              <a:t> "Query":"TransformControllerTelemetry()",</a:t>
             </a:r>
             <a:br/>
             <a:r>
-              <a:t>ObservedType  long</a:t>
-            </a:r>
-            <a:br/>
-            <a:r>
-              <a:t>SampleValue   120</a:t>
+              <a:t> "IsTransactional":false}</a:t>
             </a:r>
             <a:br/>
             <a:br/>
             <a:r>
-              <a:t>bag_keys + mv-expand</a:t>
+              <a:t>Raw row  →  typed row</a:t>
             </a:r>
             <a:br/>
             <a:r>
-              <a:t>+ set_has_element + gettype</a:t>
+              <a:t>         →  drift observation</a:t>
             </a:r>
           </a:p>
         </p:txBody>

</xml_diff>